<commit_message>
Refresh IPMA Kyrgyzstan CoD PPTX export
Regenerate the 14-slide PowerPoint to match the HTML deck
content and visual structure for download/use offline.

Co-authored-by: umekishev <umekishev@users.noreply.github.com>
</commit_message>
<xml_diff>
--- a/presentations/IPMA_Kyrgyzstan_CoD_Presentation.pptx
+++ b/presentations/IPMA_Kyrgyzstan_CoD_Presentation.pptx
@@ -3239,7 +3239,7 @@
         <p:spPr>
           <a:xfrm>
             <a:off x="10241280" y="457200"/>
-            <a:ext cx="1280160" cy="1280160"/>
+            <a:ext cx="1234440" cy="1234440"/>
           </a:xfrm>
           <a:prstGeom prst="ellipse">
             <a:avLst/>
@@ -3281,7 +3281,7 @@
         </p:nvSpPr>
         <p:spPr>
           <a:xfrm>
-            <a:off x="10469880" y="685800"/>
+            <a:off x="10442448" y="658368"/>
             <a:ext cx="822960" cy="822960"/>
           </a:xfrm>
           <a:prstGeom prst="ellipse">
@@ -3324,8 +3324,8 @@
         </p:nvSpPr>
         <p:spPr>
           <a:xfrm>
-            <a:off x="822960" y="1463040"/>
-            <a:ext cx="9144000" cy="365760"/>
+            <a:off x="822960" y="1417320"/>
+            <a:ext cx="9144000" cy="320040"/>
           </a:xfrm>
           <a:prstGeom prst="rect">
             <a:avLst/>
@@ -3359,7 +3359,7 @@
         </p:nvSpPr>
         <p:spPr>
           <a:xfrm>
-            <a:off x="822960" y="1965960"/>
+            <a:off x="822960" y="1920240"/>
             <a:ext cx="10058400" cy="914400"/>
           </a:xfrm>
           <a:prstGeom prst="rect">
@@ -3395,7 +3395,7 @@
         <p:spPr>
           <a:xfrm>
             <a:off x="822960" y="2926080"/>
-            <a:ext cx="10058400" cy="457200"/>
+            <a:ext cx="10058400" cy="411480"/>
           </a:xfrm>
           <a:prstGeom prst="rect">
             <a:avLst/>
@@ -3429,7 +3429,7 @@
         </p:nvSpPr>
         <p:spPr>
           <a:xfrm>
-            <a:off x="822960" y="3657600"/>
+            <a:off x="822960" y="3520440"/>
             <a:ext cx="10058400" cy="365760"/>
           </a:xfrm>
           <a:prstGeom prst="rect">
@@ -3465,7 +3465,7 @@
         <p:spPr>
           <a:xfrm>
             <a:off x="822960" y="5623560"/>
-            <a:ext cx="9144000" cy="320040"/>
+            <a:ext cx="10058400" cy="320040"/>
           </a:xfrm>
           <a:prstGeom prst="rect">
             <a:avLst/>
@@ -3604,7 +3604,7 @@
         <p:spPr>
           <a:xfrm>
             <a:off x="640080" y="320040"/>
-            <a:ext cx="5486400" cy="274320"/>
+            <a:ext cx="7315200" cy="274320"/>
           </a:xfrm>
           <a:prstGeom prst="rect">
             <a:avLst/>
@@ -3639,7 +3639,7 @@
         <p:spPr>
           <a:xfrm>
             <a:off x="640080" y="594360"/>
-            <a:ext cx="10515600" cy="640080"/>
+            <a:ext cx="10972800" cy="640080"/>
           </a:xfrm>
           <a:prstGeom prst="rect">
             <a:avLst/>
@@ -3654,7 +3654,7 @@
           <a:p>
             <a:pPr algn="l"/>
             <a:r>
-              <a:rPr sz="3200" b="1">
+              <a:rPr sz="3000" b="1">
                 <a:solidFill>
                   <a:srgbClr val="0B1F33"/>
                 </a:solidFill>
@@ -3674,7 +3674,7 @@
         <p:spPr>
           <a:xfrm>
             <a:off x="640080" y="1234440"/>
-            <a:ext cx="10515600" cy="411480"/>
+            <a:ext cx="10972800" cy="365760"/>
           </a:xfrm>
           <a:prstGeom prst="rect">
             <a:avLst/>
@@ -4644,7 +4644,7 @@
         </p:nvSpPr>
         <p:spPr>
           <a:xfrm>
-            <a:off x="548640" y="6446520"/>
+            <a:off x="502920" y="6446520"/>
             <a:ext cx="7315200" cy="320040"/>
           </a:xfrm>
           <a:prstGeom prst="rect">
@@ -4819,7 +4819,7 @@
         <p:spPr>
           <a:xfrm>
             <a:off x="640080" y="320040"/>
-            <a:ext cx="5486400" cy="274320"/>
+            <a:ext cx="7315200" cy="274320"/>
           </a:xfrm>
           <a:prstGeom prst="rect">
             <a:avLst/>
@@ -4854,7 +4854,7 @@
         <p:spPr>
           <a:xfrm>
             <a:off x="640080" y="594360"/>
-            <a:ext cx="10515600" cy="640080"/>
+            <a:ext cx="10972800" cy="640080"/>
           </a:xfrm>
           <a:prstGeom prst="rect">
             <a:avLst/>
@@ -4869,7 +4869,7 @@
           <a:p>
             <a:pPr algn="l"/>
             <a:r>
-              <a:rPr sz="3200" b="1">
+              <a:rPr sz="3000" b="1">
                 <a:solidFill>
                   <a:srgbClr val="0B1F33"/>
                 </a:solidFill>
@@ -4889,7 +4889,7 @@
         <p:spPr>
           <a:xfrm>
             <a:off x="640080" y="1234440"/>
-            <a:ext cx="10515600" cy="411480"/>
+            <a:ext cx="10972800" cy="365760"/>
           </a:xfrm>
           <a:prstGeom prst="rect">
             <a:avLst/>
@@ -4923,7 +4923,7 @@
         </p:nvSpPr>
         <p:spPr>
           <a:xfrm>
-            <a:off x="640080" y="1920240"/>
+            <a:off x="640080" y="1965960"/>
             <a:ext cx="10972800" cy="3840480"/>
           </a:xfrm>
           <a:prstGeom prst="rect">
@@ -4937,7 +4937,7 @@
           </a:bodyPr>
           <a:lstStyle/>
           <a:p>
-            <a:pPr algn="l">
+            <a:pPr>
               <a:spcAft>
                 <a:spcPts val="1600"/>
               </a:spcAft>
@@ -4953,7 +4953,7 @@
             </a:r>
           </a:p>
           <a:p>
-            <a:pPr algn="l">
+            <a:pPr>
               <a:spcAft>
                 <a:spcPts val="1600"/>
               </a:spcAft>
@@ -4969,7 +4969,7 @@
             </a:r>
           </a:p>
           <a:p>
-            <a:pPr algn="l">
+            <a:pPr>
               <a:spcAft>
                 <a:spcPts val="1600"/>
               </a:spcAft>
@@ -4985,7 +4985,7 @@
             </a:r>
           </a:p>
           <a:p>
-            <a:pPr algn="l">
+            <a:pPr>
               <a:spcAft>
                 <a:spcPts val="1600"/>
               </a:spcAft>
@@ -5001,7 +5001,7 @@
             </a:r>
           </a:p>
           <a:p>
-            <a:pPr algn="l">
+            <a:pPr>
               <a:spcAft>
                 <a:spcPts val="1600"/>
               </a:spcAft>
@@ -5017,7 +5017,7 @@
             </a:r>
           </a:p>
           <a:p>
-            <a:pPr algn="l">
+            <a:pPr>
               <a:spcAft>
                 <a:spcPts val="1600"/>
               </a:spcAft>
@@ -5042,7 +5042,7 @@
         </p:nvSpPr>
         <p:spPr>
           <a:xfrm>
-            <a:off x="548640" y="6446520"/>
+            <a:off x="502920" y="6446520"/>
             <a:ext cx="7315200" cy="320040"/>
           </a:xfrm>
           <a:prstGeom prst="rect">
@@ -5217,7 +5217,7 @@
         <p:spPr>
           <a:xfrm>
             <a:off x="640080" y="320040"/>
-            <a:ext cx="5486400" cy="274320"/>
+            <a:ext cx="7315200" cy="274320"/>
           </a:xfrm>
           <a:prstGeom prst="rect">
             <a:avLst/>
@@ -5252,7 +5252,7 @@
         <p:spPr>
           <a:xfrm>
             <a:off x="640080" y="594360"/>
-            <a:ext cx="10515600" cy="640080"/>
+            <a:ext cx="10972800" cy="640080"/>
           </a:xfrm>
           <a:prstGeom prst="rect">
             <a:avLst/>
@@ -5267,7 +5267,7 @@
           <a:p>
             <a:pPr algn="l"/>
             <a:r>
-              <a:rPr sz="3200" b="1">
+              <a:rPr sz="3000" b="1">
                 <a:solidFill>
                   <a:srgbClr val="0B1F33"/>
                 </a:solidFill>
@@ -5287,7 +5287,7 @@
         <p:spPr>
           <a:xfrm>
             <a:off x="640080" y="1234440"/>
-            <a:ext cx="10515600" cy="411480"/>
+            <a:ext cx="10972800" cy="365760"/>
           </a:xfrm>
           <a:prstGeom prst="rect">
             <a:avLst/>
@@ -5945,7 +5945,7 @@
         </p:nvSpPr>
         <p:spPr>
           <a:xfrm>
-            <a:off x="548640" y="6446520"/>
+            <a:off x="502920" y="6446520"/>
             <a:ext cx="7315200" cy="320040"/>
           </a:xfrm>
           <a:prstGeom prst="rect">
@@ -6162,8 +6162,8 @@
         </p:nvSpPr>
         <p:spPr>
           <a:xfrm>
-            <a:off x="822960" y="1463040"/>
-            <a:ext cx="10058400" cy="365760"/>
+            <a:off x="822960" y="1417320"/>
+            <a:ext cx="10058400" cy="320040"/>
           </a:xfrm>
           <a:prstGeom prst="rect">
             <a:avLst/>
@@ -6197,7 +6197,7 @@
         </p:nvSpPr>
         <p:spPr>
           <a:xfrm>
-            <a:off x="822960" y="2011680"/>
+            <a:off x="822960" y="1965960"/>
             <a:ext cx="10515600" cy="1828800"/>
           </a:xfrm>
           <a:prstGeom prst="rect">
@@ -6232,8 +6232,8 @@
         </p:nvSpPr>
         <p:spPr>
           <a:xfrm>
-            <a:off x="822960" y="4114800"/>
-            <a:ext cx="10515600" cy="731520"/>
+            <a:off x="822960" y="4069080"/>
+            <a:ext cx="10515600" cy="822960"/>
           </a:xfrm>
           <a:prstGeom prst="rect">
             <a:avLst/>
@@ -6267,7 +6267,7 @@
         </p:nvSpPr>
         <p:spPr>
           <a:xfrm>
-            <a:off x="548640" y="6446520"/>
+            <a:off x="502920" y="6446520"/>
             <a:ext cx="7315200" cy="320040"/>
           </a:xfrm>
           <a:prstGeom prst="rect">
@@ -6477,7 +6477,7 @@
         <p:spPr>
           <a:xfrm>
             <a:off x="822960" y="2651760"/>
-            <a:ext cx="10515600" cy="457200"/>
+            <a:ext cx="10515600" cy="411480"/>
           </a:xfrm>
           <a:prstGeom prst="rect">
             <a:avLst/>
@@ -6511,7 +6511,7 @@
         </p:nvSpPr>
         <p:spPr>
           <a:xfrm>
-            <a:off x="822960" y="3474720"/>
+            <a:off x="822960" y="3429000"/>
             <a:ext cx="10515600" cy="1828800"/>
           </a:xfrm>
           <a:prstGeom prst="roundRect">
@@ -6554,8 +6554,8 @@
         </p:nvSpPr>
         <p:spPr>
           <a:xfrm>
-            <a:off x="1097280" y="3749039"/>
-            <a:ext cx="9875520" cy="320040"/>
+            <a:off x="1097280" y="3703320"/>
+            <a:ext cx="9875520" cy="274320"/>
           </a:xfrm>
           <a:prstGeom prst="rect">
             <a:avLst/>
@@ -6589,7 +6589,7 @@
         </p:nvSpPr>
         <p:spPr>
           <a:xfrm>
-            <a:off x="1097280" y="4160520"/>
+            <a:off x="1097280" y="4114800"/>
             <a:ext cx="9875520" cy="365760"/>
           </a:xfrm>
           <a:prstGeom prst="rect">
@@ -6659,7 +6659,7 @@
         </p:nvSpPr>
         <p:spPr>
           <a:xfrm>
-            <a:off x="822960" y="5669280"/>
+            <a:off x="822960" y="5623560"/>
             <a:ext cx="10515600" cy="365760"/>
           </a:xfrm>
           <a:prstGeom prst="rect">
@@ -6694,7 +6694,7 @@
         </p:nvSpPr>
         <p:spPr>
           <a:xfrm>
-            <a:off x="548640" y="6446520"/>
+            <a:off x="502920" y="6446520"/>
             <a:ext cx="7315200" cy="320040"/>
           </a:xfrm>
           <a:prstGeom prst="rect">
@@ -6869,7 +6869,7 @@
         <p:spPr>
           <a:xfrm>
             <a:off x="640080" y="320040"/>
-            <a:ext cx="5486400" cy="274320"/>
+            <a:ext cx="7315200" cy="274320"/>
           </a:xfrm>
           <a:prstGeom prst="rect">
             <a:avLst/>
@@ -6904,7 +6904,7 @@
         <p:spPr>
           <a:xfrm>
             <a:off x="640080" y="594360"/>
-            <a:ext cx="10515600" cy="640080"/>
+            <a:ext cx="10972800" cy="640080"/>
           </a:xfrm>
           <a:prstGeom prst="rect">
             <a:avLst/>
@@ -6919,7 +6919,7 @@
           <a:p>
             <a:pPr algn="l"/>
             <a:r>
-              <a:rPr sz="3200" b="1">
+              <a:rPr sz="3000" b="1">
                 <a:solidFill>
                   <a:srgbClr val="0B1F33"/>
                 </a:solidFill>
@@ -6939,7 +6939,7 @@
         <p:spPr>
           <a:xfrm>
             <a:off x="640080" y="1234440"/>
-            <a:ext cx="10515600" cy="411480"/>
+            <a:ext cx="10972800" cy="365760"/>
           </a:xfrm>
           <a:prstGeom prst="rect">
             <a:avLst/>
@@ -7143,7 +7143,7 @@
           </a:bodyPr>
           <a:lstStyle/>
           <a:p>
-            <a:pPr algn="l">
+            <a:pPr>
               <a:spcAft>
                 <a:spcPts val="1000"/>
               </a:spcAft>
@@ -7159,7 +7159,7 @@
             </a:r>
           </a:p>
           <a:p>
-            <a:pPr algn="l">
+            <a:pPr>
               <a:spcAft>
                 <a:spcPts val="1000"/>
               </a:spcAft>
@@ -7175,7 +7175,7 @@
             </a:r>
           </a:p>
           <a:p>
-            <a:pPr algn="l">
+            <a:pPr>
               <a:spcAft>
                 <a:spcPts val="1000"/>
               </a:spcAft>
@@ -7191,7 +7191,7 @@
             </a:r>
           </a:p>
           <a:p>
-            <a:pPr algn="l">
+            <a:pPr>
               <a:spcAft>
                 <a:spcPts val="1000"/>
               </a:spcAft>
@@ -7386,7 +7386,7 @@
           </a:bodyPr>
           <a:lstStyle/>
           <a:p>
-            <a:pPr algn="l">
+            <a:pPr>
               <a:spcAft>
                 <a:spcPts val="1000"/>
               </a:spcAft>
@@ -7402,7 +7402,7 @@
             </a:r>
           </a:p>
           <a:p>
-            <a:pPr algn="l">
+            <a:pPr>
               <a:spcAft>
                 <a:spcPts val="1000"/>
               </a:spcAft>
@@ -7418,7 +7418,7 @@
             </a:r>
           </a:p>
           <a:p>
-            <a:pPr algn="l">
+            <a:pPr>
               <a:spcAft>
                 <a:spcPts val="1000"/>
               </a:spcAft>
@@ -7434,7 +7434,7 @@
             </a:r>
           </a:p>
           <a:p>
-            <a:pPr algn="l">
+            <a:pPr>
               <a:spcAft>
                 <a:spcPts val="1000"/>
               </a:spcAft>
@@ -7459,7 +7459,7 @@
         </p:nvSpPr>
         <p:spPr>
           <a:xfrm>
-            <a:off x="548640" y="6446520"/>
+            <a:off x="502920" y="6446520"/>
             <a:ext cx="7315200" cy="320040"/>
           </a:xfrm>
           <a:prstGeom prst="rect">
@@ -7634,7 +7634,7 @@
         <p:spPr>
           <a:xfrm>
             <a:off x="640080" y="320040"/>
-            <a:ext cx="5486400" cy="274320"/>
+            <a:ext cx="7315200" cy="274320"/>
           </a:xfrm>
           <a:prstGeom prst="rect">
             <a:avLst/>
@@ -7669,7 +7669,7 @@
         <p:spPr>
           <a:xfrm>
             <a:off x="640080" y="594360"/>
-            <a:ext cx="10515600" cy="640080"/>
+            <a:ext cx="10972800" cy="640080"/>
           </a:xfrm>
           <a:prstGeom prst="rect">
             <a:avLst/>
@@ -7684,7 +7684,7 @@
           <a:p>
             <a:pPr algn="l"/>
             <a:r>
-              <a:rPr sz="3200" b="1">
+              <a:rPr sz="3000" b="1">
                 <a:solidFill>
                   <a:srgbClr val="0B1F33"/>
                 </a:solidFill>
@@ -7704,7 +7704,7 @@
         <p:spPr>
           <a:xfrm>
             <a:off x="640080" y="1234440"/>
-            <a:ext cx="10515600" cy="411480"/>
+            <a:ext cx="10972800" cy="365760"/>
           </a:xfrm>
           <a:prstGeom prst="rect">
             <a:avLst/>
@@ -8674,7 +8674,7 @@
         </p:nvSpPr>
         <p:spPr>
           <a:xfrm>
-            <a:off x="548640" y="6446520"/>
+            <a:off x="502920" y="6446520"/>
             <a:ext cx="7315200" cy="320040"/>
           </a:xfrm>
           <a:prstGeom prst="rect">
@@ -8849,7 +8849,7 @@
         <p:spPr>
           <a:xfrm>
             <a:off x="640080" y="320040"/>
-            <a:ext cx="5486400" cy="274320"/>
+            <a:ext cx="7315200" cy="274320"/>
           </a:xfrm>
           <a:prstGeom prst="rect">
             <a:avLst/>
@@ -8884,7 +8884,7 @@
         <p:spPr>
           <a:xfrm>
             <a:off x="640080" y="594360"/>
-            <a:ext cx="10515600" cy="640080"/>
+            <a:ext cx="10972800" cy="640080"/>
           </a:xfrm>
           <a:prstGeom prst="rect">
             <a:avLst/>
@@ -8899,7 +8899,7 @@
           <a:p>
             <a:pPr algn="l"/>
             <a:r>
-              <a:rPr sz="3200" b="1">
+              <a:rPr sz="3000" b="1">
                 <a:solidFill>
                   <a:srgbClr val="0B1F33"/>
                 </a:solidFill>
@@ -8919,7 +8919,7 @@
         <p:spPr>
           <a:xfrm>
             <a:off x="640080" y="1234440"/>
-            <a:ext cx="10515600" cy="411480"/>
+            <a:ext cx="10972800" cy="365760"/>
           </a:xfrm>
           <a:prstGeom prst="rect">
             <a:avLst/>
@@ -9631,7 +9631,7 @@
         </p:nvSpPr>
         <p:spPr>
           <a:xfrm>
-            <a:off x="548640" y="6446520"/>
+            <a:off x="502920" y="6446520"/>
             <a:ext cx="7315200" cy="320040"/>
           </a:xfrm>
           <a:prstGeom prst="rect">
@@ -9849,7 +9849,7 @@
         <p:spPr>
           <a:xfrm>
             <a:off x="822960" y="1645920"/>
-            <a:ext cx="10058400" cy="365760"/>
+            <a:ext cx="10058400" cy="320040"/>
           </a:xfrm>
           <a:prstGeom prst="rect">
             <a:avLst/>
@@ -9883,8 +9883,8 @@
         </p:nvSpPr>
         <p:spPr>
           <a:xfrm>
-            <a:off x="822960" y="2194560"/>
-            <a:ext cx="10515600" cy="2011680"/>
+            <a:off x="822960" y="2148840"/>
+            <a:ext cx="10515600" cy="2103120"/>
           </a:xfrm>
           <a:prstGeom prst="rect">
             <a:avLst/>
@@ -9919,7 +9919,7 @@
         <p:spPr>
           <a:xfrm>
             <a:off x="822960" y="4572000"/>
-            <a:ext cx="10058400" cy="457200"/>
+            <a:ext cx="10058400" cy="411480"/>
           </a:xfrm>
           <a:prstGeom prst="rect">
             <a:avLst/>
@@ -9953,7 +9953,7 @@
         </p:nvSpPr>
         <p:spPr>
           <a:xfrm>
-            <a:off x="548640" y="6446520"/>
+            <a:off x="502920" y="6446520"/>
             <a:ext cx="7315200" cy="320040"/>
           </a:xfrm>
           <a:prstGeom prst="rect">
@@ -10128,7 +10128,7 @@
         <p:spPr>
           <a:xfrm>
             <a:off x="640080" y="320040"/>
-            <a:ext cx="5486400" cy="274320"/>
+            <a:ext cx="7315200" cy="274320"/>
           </a:xfrm>
           <a:prstGeom prst="rect">
             <a:avLst/>
@@ -10163,7 +10163,7 @@
         <p:spPr>
           <a:xfrm>
             <a:off x="640080" y="594360"/>
-            <a:ext cx="10515600" cy="640080"/>
+            <a:ext cx="10972800" cy="640080"/>
           </a:xfrm>
           <a:prstGeom prst="rect">
             <a:avLst/>
@@ -10178,7 +10178,7 @@
           <a:p>
             <a:pPr algn="l"/>
             <a:r>
-              <a:rPr sz="3200" b="1">
+              <a:rPr sz="3000" b="1">
                 <a:solidFill>
                   <a:srgbClr val="0B1F33"/>
                 </a:solidFill>
@@ -10198,7 +10198,7 @@
         <p:spPr>
           <a:xfrm>
             <a:off x="640080" y="1234440"/>
-            <a:ext cx="10515600" cy="411480"/>
+            <a:ext cx="10972800" cy="365760"/>
           </a:xfrm>
           <a:prstGeom prst="rect">
             <a:avLst/>
@@ -11136,7 +11136,7 @@
         </p:nvSpPr>
         <p:spPr>
           <a:xfrm>
-            <a:off x="548640" y="6446520"/>
+            <a:off x="502920" y="6446520"/>
             <a:ext cx="7315200" cy="320040"/>
           </a:xfrm>
           <a:prstGeom prst="rect">
@@ -11311,7 +11311,7 @@
         <p:spPr>
           <a:xfrm>
             <a:off x="640080" y="320040"/>
-            <a:ext cx="5486400" cy="274320"/>
+            <a:ext cx="7315200" cy="274320"/>
           </a:xfrm>
           <a:prstGeom prst="rect">
             <a:avLst/>
@@ -11346,7 +11346,7 @@
         <p:spPr>
           <a:xfrm>
             <a:off x="640080" y="594360"/>
-            <a:ext cx="10515600" cy="640080"/>
+            <a:ext cx="10972800" cy="640080"/>
           </a:xfrm>
           <a:prstGeom prst="rect">
             <a:avLst/>
@@ -11361,7 +11361,7 @@
           <a:p>
             <a:pPr algn="l"/>
             <a:r>
-              <a:rPr sz="3200" b="1">
+              <a:rPr sz="3000" b="1">
                 <a:solidFill>
                   <a:srgbClr val="0B1F33"/>
                 </a:solidFill>
@@ -11381,7 +11381,7 @@
         <p:spPr>
           <a:xfrm>
             <a:off x="640080" y="1234440"/>
-            <a:ext cx="10515600" cy="411480"/>
+            <a:ext cx="10972800" cy="365760"/>
           </a:xfrm>
           <a:prstGeom prst="rect">
             <a:avLst/>
@@ -11519,7 +11519,7 @@
             <a:r>
               <a:rPr sz="2200" b="1">
                 <a:solidFill>
-                  <a:srgbClr val="FFFFFF"/>
+                  <a:srgbClr val="0B1F33"/>
                 </a:solidFill>
                 <a:latin typeface="Georgia"/>
               </a:rPr>
@@ -11554,7 +11554,7 @@
             <a:r>
               <a:rPr sz="1300" b="0">
                 <a:solidFill>
-                  <a:srgbClr val="FFFFFF"/>
+                  <a:srgbClr val="0B1F33"/>
                 </a:solidFill>
                 <a:latin typeface="Calibri"/>
               </a:rPr>
@@ -11585,7 +11585,7 @@
           </a:bodyPr>
           <a:lstStyle/>
           <a:p>
-            <a:pPr algn="l">
+            <a:pPr>
               <a:spcAft>
                 <a:spcPts val="1200"/>
               </a:spcAft>
@@ -11601,7 +11601,7 @@
             </a:r>
           </a:p>
           <a:p>
-            <a:pPr algn="l">
+            <a:pPr>
               <a:spcAft>
                 <a:spcPts val="1200"/>
               </a:spcAft>
@@ -11617,7 +11617,7 @@
             </a:r>
           </a:p>
           <a:p>
-            <a:pPr algn="l">
+            <a:pPr>
               <a:spcAft>
                 <a:spcPts val="1200"/>
               </a:spcAft>
@@ -11633,7 +11633,7 @@
             </a:r>
           </a:p>
           <a:p>
-            <a:pPr algn="l">
+            <a:pPr>
               <a:spcAft>
                 <a:spcPts val="1200"/>
               </a:spcAft>
@@ -11828,7 +11828,7 @@
           </a:bodyPr>
           <a:lstStyle/>
           <a:p>
-            <a:pPr algn="l">
+            <a:pPr>
               <a:spcAft>
                 <a:spcPts val="1200"/>
               </a:spcAft>
@@ -11844,7 +11844,7 @@
             </a:r>
           </a:p>
           <a:p>
-            <a:pPr algn="l">
+            <a:pPr>
               <a:spcAft>
                 <a:spcPts val="1200"/>
               </a:spcAft>
@@ -11860,7 +11860,7 @@
             </a:r>
           </a:p>
           <a:p>
-            <a:pPr algn="l">
+            <a:pPr>
               <a:spcAft>
                 <a:spcPts val="1200"/>
               </a:spcAft>
@@ -11876,7 +11876,7 @@
             </a:r>
           </a:p>
           <a:p>
-            <a:pPr algn="l">
+            <a:pPr>
               <a:spcAft>
                 <a:spcPts val="1200"/>
               </a:spcAft>
@@ -12071,7 +12071,7 @@
           </a:bodyPr>
           <a:lstStyle/>
           <a:p>
-            <a:pPr algn="l">
+            <a:pPr>
               <a:spcAft>
                 <a:spcPts val="1200"/>
               </a:spcAft>
@@ -12087,7 +12087,7 @@
             </a:r>
           </a:p>
           <a:p>
-            <a:pPr algn="l">
+            <a:pPr>
               <a:spcAft>
                 <a:spcPts val="1200"/>
               </a:spcAft>
@@ -12103,7 +12103,7 @@
             </a:r>
           </a:p>
           <a:p>
-            <a:pPr algn="l">
+            <a:pPr>
               <a:spcAft>
                 <a:spcPts val="1200"/>
               </a:spcAft>
@@ -12119,7 +12119,7 @@
             </a:r>
           </a:p>
           <a:p>
-            <a:pPr algn="l">
+            <a:pPr>
               <a:spcAft>
                 <a:spcPts val="1200"/>
               </a:spcAft>
@@ -12144,7 +12144,7 @@
         </p:nvSpPr>
         <p:spPr>
           <a:xfrm>
-            <a:off x="548640" y="6446520"/>
+            <a:off x="502920" y="6446520"/>
             <a:ext cx="7315200" cy="320040"/>
           </a:xfrm>
           <a:prstGeom prst="rect">
@@ -12319,7 +12319,7 @@
         <p:spPr>
           <a:xfrm>
             <a:off x="640080" y="320040"/>
-            <a:ext cx="5486400" cy="274320"/>
+            <a:ext cx="7315200" cy="274320"/>
           </a:xfrm>
           <a:prstGeom prst="rect">
             <a:avLst/>
@@ -12354,7 +12354,7 @@
         <p:spPr>
           <a:xfrm>
             <a:off x="640080" y="594360"/>
-            <a:ext cx="10515600" cy="640080"/>
+            <a:ext cx="10972800" cy="640080"/>
           </a:xfrm>
           <a:prstGeom prst="rect">
             <a:avLst/>
@@ -12369,7 +12369,7 @@
           <a:p>
             <a:pPr algn="l"/>
             <a:r>
-              <a:rPr sz="3200" b="1">
+              <a:rPr sz="3000" b="1">
                 <a:solidFill>
                   <a:srgbClr val="0B1F33"/>
                 </a:solidFill>
@@ -12389,7 +12389,7 @@
         <p:spPr>
           <a:xfrm>
             <a:off x="640080" y="1234440"/>
-            <a:ext cx="10515600" cy="411480"/>
+            <a:ext cx="10972800" cy="365760"/>
           </a:xfrm>
           <a:prstGeom prst="rect">
             <a:avLst/>
@@ -12423,23 +12423,23 @@
         </p:nvSpPr>
         <p:spPr>
           <a:xfrm>
-            <a:off x="640080" y="1828800"/>
-            <a:ext cx="10972800" cy="914400"/>
-          </a:xfrm>
-          <a:prstGeom prst="rect">
-            <a:avLst/>
-          </a:prstGeom>
-          <a:noFill/>
-        </p:spPr>
-        <p:txBody>
-          <a:bodyPr wrap="square">
-            <a:spAutoFit/>
-          </a:bodyPr>
-          <a:lstStyle/>
-          <a:p>
-            <a:pPr algn="l">
+            <a:off x="640080" y="1783080"/>
+            <a:ext cx="10972800" cy="822960"/>
+          </a:xfrm>
+          <a:prstGeom prst="rect">
+            <a:avLst/>
+          </a:prstGeom>
+          <a:noFill/>
+        </p:spPr>
+        <p:txBody>
+          <a:bodyPr wrap="square">
+            <a:spAutoFit/>
+          </a:bodyPr>
+          <a:lstStyle/>
+          <a:p>
+            <a:pPr>
               <a:spcAft>
-                <a:spcPts val="800"/>
+                <a:spcPts val="600"/>
               </a:spcAft>
             </a:pPr>
             <a:r>
@@ -12453,9 +12453,9 @@
             </a:r>
           </a:p>
           <a:p>
-            <a:pPr algn="l">
+            <a:pPr>
               <a:spcAft>
-                <a:spcPts val="800"/>
+                <a:spcPts val="600"/>
               </a:spcAft>
             </a:pPr>
             <a:r>
@@ -12478,7 +12478,7 @@
         </p:nvSpPr>
         <p:spPr>
           <a:xfrm>
-            <a:off x="640080" y="3017520"/>
+            <a:off x="640080" y="2926080"/>
             <a:ext cx="5440680" cy="1234440"/>
           </a:xfrm>
           <a:prstGeom prst="roundRect">
@@ -12521,7 +12521,7 @@
         </p:nvSpPr>
         <p:spPr>
           <a:xfrm>
-            <a:off x="960120" y="3246120"/>
+            <a:off x="960120" y="3154680"/>
             <a:ext cx="4846320" cy="320040"/>
           </a:xfrm>
           <a:prstGeom prst="rect">
@@ -12556,7 +12556,7 @@
         </p:nvSpPr>
         <p:spPr>
           <a:xfrm>
-            <a:off x="960120" y="3657600"/>
+            <a:off x="960120" y="3566160"/>
             <a:ext cx="4846320" cy="411480"/>
           </a:xfrm>
           <a:prstGeom prst="rect">
@@ -12591,7 +12591,7 @@
         </p:nvSpPr>
         <p:spPr>
           <a:xfrm>
-            <a:off x="6309360" y="3017520"/>
+            <a:off x="6309360" y="2926080"/>
             <a:ext cx="5440680" cy="1234440"/>
           </a:xfrm>
           <a:prstGeom prst="roundRect">
@@ -12634,7 +12634,7 @@
         </p:nvSpPr>
         <p:spPr>
           <a:xfrm>
-            <a:off x="6629400" y="3246120"/>
+            <a:off x="6629400" y="3154680"/>
             <a:ext cx="4846320" cy="320040"/>
           </a:xfrm>
           <a:prstGeom prst="rect">
@@ -12669,7 +12669,7 @@
         </p:nvSpPr>
         <p:spPr>
           <a:xfrm>
-            <a:off x="6629400" y="3657600"/>
+            <a:off x="6629400" y="3566160"/>
             <a:ext cx="4846320" cy="411480"/>
           </a:xfrm>
           <a:prstGeom prst="rect">
@@ -12704,7 +12704,7 @@
         </p:nvSpPr>
         <p:spPr>
           <a:xfrm>
-            <a:off x="640080" y="4434840"/>
+            <a:off x="640080" y="4343400"/>
             <a:ext cx="5440680" cy="1234440"/>
           </a:xfrm>
           <a:prstGeom prst="roundRect">
@@ -12747,7 +12747,7 @@
         </p:nvSpPr>
         <p:spPr>
           <a:xfrm>
-            <a:off x="960120" y="4663440"/>
+            <a:off x="960120" y="4572000"/>
             <a:ext cx="4846320" cy="320040"/>
           </a:xfrm>
           <a:prstGeom prst="rect">
@@ -12782,7 +12782,7 @@
         </p:nvSpPr>
         <p:spPr>
           <a:xfrm>
-            <a:off x="960120" y="5074920"/>
+            <a:off x="960120" y="4983480"/>
             <a:ext cx="4846320" cy="411480"/>
           </a:xfrm>
           <a:prstGeom prst="rect">
@@ -12817,7 +12817,7 @@
         </p:nvSpPr>
         <p:spPr>
           <a:xfrm>
-            <a:off x="6309360" y="4434840"/>
+            <a:off x="6309360" y="4343400"/>
             <a:ext cx="5440680" cy="1234440"/>
           </a:xfrm>
           <a:prstGeom prst="roundRect">
@@ -12860,7 +12860,7 @@
         </p:nvSpPr>
         <p:spPr>
           <a:xfrm>
-            <a:off x="6629400" y="4663440"/>
+            <a:off x="6629400" y="4572000"/>
             <a:ext cx="4846320" cy="320040"/>
           </a:xfrm>
           <a:prstGeom prst="rect">
@@ -12895,7 +12895,7 @@
         </p:nvSpPr>
         <p:spPr>
           <a:xfrm>
-            <a:off x="6629400" y="5074920"/>
+            <a:off x="6629400" y="4983480"/>
             <a:ext cx="4846320" cy="411480"/>
           </a:xfrm>
           <a:prstGeom prst="rect">
@@ -12930,7 +12930,7 @@
         </p:nvSpPr>
         <p:spPr>
           <a:xfrm>
-            <a:off x="548640" y="6446520"/>
+            <a:off x="502920" y="6446520"/>
             <a:ext cx="7315200" cy="320040"/>
           </a:xfrm>
           <a:prstGeom prst="rect">
@@ -13105,7 +13105,7 @@
         <p:spPr>
           <a:xfrm>
             <a:off x="640080" y="320040"/>
-            <a:ext cx="5486400" cy="274320"/>
+            <a:ext cx="7315200" cy="274320"/>
           </a:xfrm>
           <a:prstGeom prst="rect">
             <a:avLst/>
@@ -13140,7 +13140,7 @@
         <p:spPr>
           <a:xfrm>
             <a:off x="640080" y="594360"/>
-            <a:ext cx="10515600" cy="640080"/>
+            <a:ext cx="10972800" cy="640080"/>
           </a:xfrm>
           <a:prstGeom prst="rect">
             <a:avLst/>
@@ -13155,7 +13155,7 @@
           <a:p>
             <a:pPr algn="l"/>
             <a:r>
-              <a:rPr sz="3200" b="1">
+              <a:rPr sz="3000" b="1">
                 <a:solidFill>
                   <a:srgbClr val="0B1F33"/>
                 </a:solidFill>
@@ -13175,7 +13175,7 @@
         <p:spPr>
           <a:xfrm>
             <a:off x="640080" y="1234440"/>
-            <a:ext cx="10515600" cy="411480"/>
+            <a:ext cx="10972800" cy="365760"/>
           </a:xfrm>
           <a:prstGeom prst="rect">
             <a:avLst/>
@@ -13196,7 +13196,7 @@
                 </a:solidFill>
                 <a:latin typeface="Calibri"/>
               </a:rPr>
-              <a:t>Quality certification rooted in collaboration</a:t>
+              <a:t>Quality certification rooted in collaboration with peer MAs / CBs</a:t>
             </a:r>
           </a:p>
         </p:txBody>
@@ -13209,56 +13209,21 @@
         </p:nvSpPr>
         <p:spPr>
           <a:xfrm>
-            <a:off x="640080" y="1828800"/>
-            <a:ext cx="10972800" cy="365760"/>
-          </a:xfrm>
-          <a:prstGeom prst="rect">
-            <a:avLst/>
-          </a:prstGeom>
-          <a:noFill/>
-        </p:spPr>
-        <p:txBody>
-          <a:bodyPr wrap="square">
-            <a:spAutoFit/>
-          </a:bodyPr>
-          <a:lstStyle/>
-          <a:p>
-            <a:pPr algn="l"/>
-            <a:r>
-              <a:rPr sz="1500" b="1">
-                <a:solidFill>
-                  <a:srgbClr val="2E6B8A"/>
-                </a:solidFill>
-                <a:latin typeface="Calibri"/>
-              </a:rPr>
-              <a:t>Target: establish CB capability for Kyrgyzstan with peer-MA support.</a:t>
-            </a:r>
-          </a:p>
-        </p:txBody>
-      </p:sp>
-      <p:sp>
-        <p:nvSpPr>
-          <p:cNvPr id="8" name="TextBox 7"/>
-          <p:cNvSpPr txBox="1"/>
-          <p:nvPr/>
-        </p:nvSpPr>
-        <p:spPr>
-          <a:xfrm>
-            <a:off x="640080" y="2377440"/>
-            <a:ext cx="10972800" cy="3474720"/>
-          </a:xfrm>
-          <a:prstGeom prst="rect">
-            <a:avLst/>
-          </a:prstGeom>
-          <a:noFill/>
-        </p:spPr>
-        <p:txBody>
-          <a:bodyPr wrap="square">
-            <a:spAutoFit/>
-          </a:bodyPr>
-          <a:lstStyle/>
-          <a:p>
-            <a:pPr algn="l">
+            <a:off x="640080" y="1965960"/>
+            <a:ext cx="10972800" cy="3840480"/>
+          </a:xfrm>
+          <a:prstGeom prst="rect">
+            <a:avLst/>
+          </a:prstGeom>
+          <a:noFill/>
+        </p:spPr>
+        <p:txBody>
+          <a:bodyPr wrap="square">
+            <a:spAutoFit/>
+          </a:bodyPr>
+          <a:lstStyle/>
+          <a:p>
+            <a:pPr>
               <a:spcAft>
                 <a:spcPts val="1400"/>
               </a:spcAft>
@@ -13274,7 +13239,7 @@
             </a:r>
           </a:p>
           <a:p>
-            <a:pPr algn="l">
+            <a:pPr>
               <a:spcAft>
                 <a:spcPts val="1400"/>
               </a:spcAft>
@@ -13290,7 +13255,7 @@
             </a:r>
           </a:p>
           <a:p>
-            <a:pPr algn="l">
+            <a:pPr>
               <a:spcAft>
                 <a:spcPts val="1400"/>
               </a:spcAft>
@@ -13306,7 +13271,7 @@
             </a:r>
           </a:p>
           <a:p>
-            <a:pPr algn="l">
+            <a:pPr>
               <a:spcAft>
                 <a:spcPts val="1400"/>
               </a:spcAft>
@@ -13322,7 +13287,7 @@
             </a:r>
           </a:p>
           <a:p>
-            <a:pPr algn="l">
+            <a:pPr>
               <a:spcAft>
                 <a:spcPts val="1400"/>
               </a:spcAft>
@@ -13338,7 +13303,7 @@
             </a:r>
           </a:p>
           <a:p>
-            <a:pPr algn="l">
+            <a:pPr>
               <a:spcAft>
                 <a:spcPts val="1400"/>
               </a:spcAft>
@@ -13357,42 +13322,42 @@
       </p:sp>
       <p:sp>
         <p:nvSpPr>
+          <p:cNvPr id="8" name="TextBox 7"/>
+          <p:cNvSpPr txBox="1"/>
+          <p:nvPr/>
+        </p:nvSpPr>
+        <p:spPr>
+          <a:xfrm>
+            <a:off x="502920" y="6446520"/>
+            <a:ext cx="7315200" cy="320040"/>
+          </a:xfrm>
+          <a:prstGeom prst="rect">
+            <a:avLst/>
+          </a:prstGeom>
+          <a:noFill/>
+        </p:spPr>
+        <p:txBody>
+          <a:bodyPr wrap="square">
+            <a:spAutoFit/>
+          </a:bodyPr>
+          <a:lstStyle/>
+          <a:p>
+            <a:pPr algn="l"/>
+            <a:r>
+              <a:rPr sz="1100" b="0">
+                <a:solidFill>
+                  <a:srgbClr val="8A9AA8"/>
+                </a:solidFill>
+                <a:latin typeface="Calibri"/>
+              </a:rPr>
+              <a:t>IPMA Kyrgyzstan  ·  Applying Member Association</a:t>
+            </a:r>
+          </a:p>
+        </p:txBody>
+      </p:sp>
+      <p:sp>
+        <p:nvSpPr>
           <p:cNvPr id="9" name="TextBox 8"/>
-          <p:cNvSpPr txBox="1"/>
-          <p:nvPr/>
-        </p:nvSpPr>
-        <p:spPr>
-          <a:xfrm>
-            <a:off x="548640" y="6446520"/>
-            <a:ext cx="7315200" cy="320040"/>
-          </a:xfrm>
-          <a:prstGeom prst="rect">
-            <a:avLst/>
-          </a:prstGeom>
-          <a:noFill/>
-        </p:spPr>
-        <p:txBody>
-          <a:bodyPr wrap="square">
-            <a:spAutoFit/>
-          </a:bodyPr>
-          <a:lstStyle/>
-          <a:p>
-            <a:pPr algn="l"/>
-            <a:r>
-              <a:rPr sz="1100" b="0">
-                <a:solidFill>
-                  <a:srgbClr val="8A9AA8"/>
-                </a:solidFill>
-                <a:latin typeface="Calibri"/>
-              </a:rPr>
-              <a:t>IPMA Kyrgyzstan  ·  Applying Member Association</a:t>
-            </a:r>
-          </a:p>
-        </p:txBody>
-      </p:sp>
-      <p:sp>
-        <p:nvSpPr>
-          <p:cNvPr id="10" name="TextBox 9"/>
           <p:cNvSpPr txBox="1"/>
           <p:nvPr/>
         </p:nvSpPr>

</xml_diff>

<commit_message>
Localize IPMA Kyrgyzstan CoD presentation to Russian
Translate all 14 slides in HTML and PPTX while keeping IPMA
terminology (AMA, CB, Young Crew, CoD) where standard.

Co-authored-by: umekishev <umekishev@users.noreply.github.com>
</commit_message>
<xml_diff>
--- a/presentations/IPMA_Kyrgyzstan_CoD_Presentation.pptx
+++ b/presentations/IPMA_Kyrgyzstan_CoD_Presentation.pptx
@@ -3325,7 +3325,7 @@
         <p:spPr>
           <a:xfrm>
             <a:off x="822960" y="1417320"/>
-            <a:ext cx="9144000" cy="320040"/>
+            <a:ext cx="10058400" cy="320040"/>
           </a:xfrm>
           <a:prstGeom prst="rect">
             <a:avLst/>
@@ -3340,13 +3340,13 @@
           <a:p>
             <a:pPr algn="l"/>
             <a:r>
-              <a:rPr sz="1400" b="1">
+              <a:rPr sz="1300" b="1">
                 <a:solidFill>
                   <a:srgbClr val="C9A227"/>
                 </a:solidFill>
                 <a:latin typeface="Calibri"/>
               </a:rPr>
-              <a:t>COUNCIL OF DELEGATES</a:t>
+              <a:t>СОВЕТ ДЕЛЕГАТОВ (COUNCIL OF DELEGATES)</a:t>
             </a:r>
           </a:p>
         </p:txBody>
@@ -3375,13 +3375,13 @@
           <a:p>
             <a:pPr algn="l"/>
             <a:r>
-              <a:rPr sz="4800" b="1">
+              <a:rPr sz="4600" b="1">
                 <a:solidFill>
                   <a:srgbClr val="FFFFFF"/>
                 </a:solidFill>
                 <a:latin typeface="Georgia"/>
               </a:rPr>
-              <a:t>IPMA Kyrgyzstan</a:t>
+              <a:t>IPMA Кыргызстан</a:t>
             </a:r>
           </a:p>
         </p:txBody>
@@ -3410,13 +3410,13 @@
           <a:p>
             <a:pPr algn="l"/>
             <a:r>
-              <a:rPr sz="2400" b="0">
+              <a:rPr sz="2200" b="0">
                 <a:solidFill>
                   <a:srgbClr val="C5D4DE"/>
                 </a:solidFill>
                 <a:latin typeface="Calibri"/>
               </a:rPr>
-              <a:t>Applying Member Association</a:t>
+              <a:t>Ассоциация-кандидат в члены IPMA</a:t>
             </a:r>
           </a:p>
         </p:txBody>
@@ -3451,7 +3451,7 @@
                 </a:solidFill>
                 <a:latin typeface="Calibri"/>
               </a:rPr>
-              <a:t>Presentation to the IPMA Council of Delegates</a:t>
+              <a:t>Презентация для Совета делегатов IPMA</a:t>
             </a:r>
           </a:p>
         </p:txBody>
@@ -3486,7 +3486,7 @@
                 </a:solidFill>
                 <a:latin typeface="Calibri"/>
               </a:rPr>
-              <a:t>Bringing the IPMA standard to Central Asia  ·  Bishkek, Kyrgyz Republic</a:t>
+              <a:t>Стандарты IPMA в Центральной Азии  ·  Бишкек, Кыргызская Республика</a:t>
             </a:r>
           </a:p>
         </p:txBody>
@@ -3625,7 +3625,7 @@
                 </a:solidFill>
                 <a:latin typeface="Calibri"/>
               </a:rPr>
-              <a:t>IPMA KYRGYZSTAN</a:t>
+              <a:t>IPMA КЫРГЫЗСТАН</a:t>
             </a:r>
           </a:p>
         </p:txBody>
@@ -3654,13 +3654,13 @@
           <a:p>
             <a:pPr algn="l"/>
             <a:r>
-              <a:rPr sz="3000" b="1">
+              <a:rPr sz="2800" b="1">
                 <a:solidFill>
                   <a:srgbClr val="0B1F33"/>
                 </a:solidFill>
                 <a:latin typeface="Georgia"/>
               </a:rPr>
-              <a:t>Promotion of the IPMA ecosystem</a:t>
+              <a:t>Продвижение экосистемы IPMA</a:t>
             </a:r>
           </a:p>
         </p:txBody>
@@ -3695,7 +3695,7 @@
                 </a:solidFill>
                 <a:latin typeface="Calibri"/>
               </a:rPr>
-              <a:t>Visibility, knowledge and community channels</a:t>
+              <a:t>Видимость, знания и каналы сообщества</a:t>
             </a:r>
           </a:p>
         </p:txBody>
@@ -3810,13 +3810,13 @@
           <a:p>
             <a:pPr algn="l"/>
             <a:r>
-              <a:rPr sz="1800" b="1">
+              <a:rPr sz="1700" b="1">
                 <a:solidFill>
                   <a:srgbClr val="0B1F33"/>
                 </a:solidFill>
                 <a:latin typeface="Georgia"/>
               </a:rPr>
-              <a:t>Website</a:t>
+              <a:t>Сайт</a:t>
             </a:r>
           </a:p>
         </p:txBody>
@@ -3851,7 +3851,7 @@
                 </a:solidFill>
                 <a:latin typeface="Calibri"/>
               </a:rPr>
-              <a:t>Official site promoting IPMA values, events and pathways</a:t>
+              <a:t>Официальный ресурс о ценностях IPMA, событиях и путях развития</a:t>
             </a:r>
           </a:p>
         </p:txBody>
@@ -3966,13 +3966,13 @@
           <a:p>
             <a:pPr algn="l"/>
             <a:r>
-              <a:rPr sz="1800" b="1">
+              <a:rPr sz="1700" b="1">
                 <a:solidFill>
                   <a:srgbClr val="0B1F33"/>
                 </a:solidFill>
                 <a:latin typeface="Georgia"/>
               </a:rPr>
-              <a:t>Social media</a:t>
+              <a:t>Соцсети</a:t>
             </a:r>
           </a:p>
         </p:txBody>
@@ -4007,7 +4007,7 @@
                 </a:solidFill>
                 <a:latin typeface="Calibri"/>
               </a:rPr>
-              <a:t>LinkedIn, Instagram and professional channels in KR</a:t>
+              <a:t>LinkedIn, Instagram и профессиональные каналы в КР</a:t>
             </a:r>
           </a:p>
         </p:txBody>
@@ -4122,13 +4122,13 @@
           <a:p>
             <a:pPr algn="l"/>
             <a:r>
-              <a:rPr sz="1800" b="1">
+              <a:rPr sz="1700" b="1">
                 <a:solidFill>
                   <a:srgbClr val="0B1F33"/>
                 </a:solidFill>
                 <a:latin typeface="Georgia"/>
               </a:rPr>
-              <a:t>Universities</a:t>
+              <a:t>Университеты</a:t>
             </a:r>
           </a:p>
         </p:txBody>
@@ -4163,7 +4163,7 @@
                 </a:solidFill>
                 <a:latin typeface="Calibri"/>
               </a:rPr>
-              <a:t>Guest lectures and curriculum links in Bishkek and beyond</a:t>
+              <a:t>Гостевые лекции и связи с программами в Бишкеке и регионах</a:t>
             </a:r>
           </a:p>
         </p:txBody>
@@ -4278,13 +4278,13 @@
           <a:p>
             <a:pPr algn="l"/>
             <a:r>
-              <a:rPr sz="1800" b="1">
+              <a:rPr sz="1700" b="1">
                 <a:solidFill>
                   <a:srgbClr val="0B1F33"/>
                 </a:solidFill>
                 <a:latin typeface="Georgia"/>
               </a:rPr>
-              <a:t>Events</a:t>
+              <a:t>Мероприятия</a:t>
             </a:r>
           </a:p>
         </p:txBody>
@@ -4319,7 +4319,7 @@
                 </a:solidFill>
                 <a:latin typeface="Calibri"/>
               </a:rPr>
-              <a:t>Webinars, conferences and knowledge forums</a:t>
+              <a:t>Вебинары, конференции и форумы обмена знаниями</a:t>
             </a:r>
           </a:p>
         </p:txBody>
@@ -4434,13 +4434,13 @@
           <a:p>
             <a:pPr algn="l"/>
             <a:r>
-              <a:rPr sz="1800" b="1">
+              <a:rPr sz="1700" b="1">
                 <a:solidFill>
                   <a:srgbClr val="0B1F33"/>
                 </a:solidFill>
                 <a:latin typeface="Georgia"/>
               </a:rPr>
-              <a:t>Publications</a:t>
+              <a:t>Публикации</a:t>
             </a:r>
           </a:p>
         </p:txBody>
@@ -4475,7 +4475,7 @@
                 </a:solidFill>
                 <a:latin typeface="Calibri"/>
               </a:rPr>
-              <a:t>Professional articles and case studies from local practice</a:t>
+              <a:t>Профессиональные статьи и кейсы из местной практики</a:t>
             </a:r>
           </a:p>
         </p:txBody>
@@ -4590,13 +4590,13 @@
           <a:p>
             <a:pPr algn="l"/>
             <a:r>
-              <a:rPr sz="1800" b="1">
+              <a:rPr sz="1700" b="1">
                 <a:solidFill>
                   <a:srgbClr val="0B1F33"/>
                 </a:solidFill>
                 <a:latin typeface="Georgia"/>
               </a:rPr>
-              <a:t>Regional links</a:t>
+              <a:t>Региональные связи</a:t>
             </a:r>
           </a:p>
         </p:txBody>
@@ -4631,7 +4631,7 @@
                 </a:solidFill>
                 <a:latin typeface="Calibri"/>
               </a:rPr>
-              <a:t>Exchange with Central Asian and neighbouring MAs</a:t>
+              <a:t>Обмен с MA Центральной Азии и соседних стран</a:t>
             </a:r>
           </a:p>
         </p:txBody>
@@ -4645,7 +4645,7 @@
         <p:spPr>
           <a:xfrm>
             <a:off x="502920" y="6446520"/>
-            <a:ext cx="7315200" cy="320040"/>
+            <a:ext cx="8229600" cy="320040"/>
           </a:xfrm>
           <a:prstGeom prst="rect">
             <a:avLst/>
@@ -4666,7 +4666,7 @@
                 </a:solidFill>
                 <a:latin typeface="Calibri"/>
               </a:rPr>
-              <a:t>IPMA Kyrgyzstan  ·  Applying Member Association</a:t>
+              <a:t>IPMA Кыргызстан  ·  Ассоциация-кандидат</a:t>
             </a:r>
           </a:p>
         </p:txBody>
@@ -4840,7 +4840,7 @@
                 </a:solidFill>
                 <a:latin typeface="Calibri"/>
               </a:rPr>
-              <a:t>IPMA KYRGYZSTAN</a:t>
+              <a:t>IPMA КЫРГЫЗСТАН</a:t>
             </a:r>
           </a:p>
         </p:txBody>
@@ -4869,13 +4869,13 @@
           <a:p>
             <a:pPr algn="l"/>
             <a:r>
-              <a:rPr sz="3000" b="1">
+              <a:rPr sz="2800" b="1">
                 <a:solidFill>
                   <a:srgbClr val="0B1F33"/>
                 </a:solidFill>
                 <a:latin typeface="Georgia"/>
               </a:rPr>
-              <a:t>Development of Young Crew Kyrgyzstan</a:t>
+              <a:t>Развитие Young Crew Кыргызстан</a:t>
             </a:r>
           </a:p>
         </p:txBody>
@@ -4910,7 +4910,7 @@
                 </a:solidFill>
                 <a:latin typeface="Calibri"/>
               </a:rPr>
-              <a:t>Starting PM careers with IPMA standards</a:t>
+              <a:t>Старт карьеры в управлении проектами со стандартами IPMA</a:t>
             </a:r>
           </a:p>
         </p:txBody>
@@ -4939,97 +4939,97 @@
           <a:p>
             <a:pPr>
               <a:spcAft>
-                <a:spcPts val="1600"/>
+                <a:spcPts val="1400"/>
               </a:spcAft>
             </a:pPr>
             <a:r>
-              <a:rPr sz="1700" b="0">
+              <a:rPr sz="1500" b="0">
                 <a:solidFill>
                   <a:srgbClr val="1C2834"/>
                 </a:solidFill>
                 <a:latin typeface="Calibri"/>
               </a:rPr>
-              <a:t>• Introduce ambitious youth to IPMA standards, values and global community</a:t>
+              <a:t>• Знакомить амбициозную молодёжь со стандартами, ценностями и глобальным сообществом IPMA</a:t>
             </a:r>
           </a:p>
           <a:p>
             <a:pPr>
               <a:spcAft>
-                <a:spcPts val="1600"/>
+                <a:spcPts val="1400"/>
               </a:spcAft>
             </a:pPr>
             <a:r>
-              <a:rPr sz="1700" b="0">
+              <a:rPr sz="1500" b="0">
                 <a:solidFill>
                   <a:srgbClr val="1C2834"/>
                 </a:solidFill>
                 <a:latin typeface="Calibri"/>
               </a:rPr>
-              <a:t>• Connect students and early-career professionals to Young Crew Kyrgyzstan</a:t>
+              <a:t>• Привлекать студентов и молодых специалистов в Young Crew Кыргызстан</a:t>
             </a:r>
           </a:p>
           <a:p>
             <a:pPr>
               <a:spcAft>
-                <a:spcPts val="1600"/>
+                <a:spcPts val="1400"/>
               </a:spcAft>
             </a:pPr>
             <a:r>
-              <a:rPr sz="1700" b="0">
+              <a:rPr sz="1500" b="0">
                 <a:solidFill>
                   <a:srgbClr val="1C2834"/>
                 </a:solidFill>
                 <a:latin typeface="Calibri"/>
               </a:rPr>
-              <a:t>• Partner with universities in Bishkek and regional centres to enrich PM education</a:t>
+              <a:t>• Партнёрство с университетами Бишкека и регионов для обогащения образования PM</a:t>
             </a:r>
           </a:p>
           <a:p>
             <a:pPr>
               <a:spcAft>
-                <a:spcPts val="1600"/>
+                <a:spcPts val="1400"/>
               </a:spcAft>
             </a:pPr>
             <a:r>
-              <a:rPr sz="1700" b="0">
+              <a:rPr sz="1500" b="0">
                 <a:solidFill>
                   <a:srgbClr val="1C2834"/>
                 </a:solidFill>
                 <a:latin typeface="Calibri"/>
               </a:rPr>
-              <a:t>• Support pathways from academic programmes toward IPMA Level D certification</a:t>
+              <a:t>• Поддерживать путь от учебных программ к сертификации IPMA Level D</a:t>
             </a:r>
           </a:p>
           <a:p>
             <a:pPr>
               <a:spcAft>
-                <a:spcPts val="1600"/>
+                <a:spcPts val="1400"/>
               </a:spcAft>
             </a:pPr>
             <a:r>
-              <a:rPr sz="1700" b="0">
+              <a:rPr sz="1500" b="0">
                 <a:solidFill>
                   <a:srgbClr val="1C2834"/>
                 </a:solidFill>
                 <a:latin typeface="Calibri"/>
               </a:rPr>
-              <a:t>• Link Young Crew talent with employers facing project capability shortages</a:t>
+              <a:t>• Связывать таланты Young Crew с работодателями, которым нужны проектные компетенции</a:t>
             </a:r>
           </a:p>
           <a:p>
             <a:pPr>
               <a:spcAft>
-                <a:spcPts val="1600"/>
+                <a:spcPts val="1400"/>
               </a:spcAft>
             </a:pPr>
             <a:r>
-              <a:rPr sz="1700" b="0">
+              <a:rPr sz="1500" b="0">
                 <a:solidFill>
                   <a:srgbClr val="1C2834"/>
                 </a:solidFill>
                 <a:latin typeface="Calibri"/>
               </a:rPr>
-              <a:t>• Encourage regional Young Crew collaboration across Central Asia</a:t>
+              <a:t>• Развивать региональное сотрудничество Young Crew в Центральной Азии</a:t>
             </a:r>
           </a:p>
         </p:txBody>
@@ -5043,7 +5043,7 @@
         <p:spPr>
           <a:xfrm>
             <a:off x="502920" y="6446520"/>
-            <a:ext cx="7315200" cy="320040"/>
+            <a:ext cx="8229600" cy="320040"/>
           </a:xfrm>
           <a:prstGeom prst="rect">
             <a:avLst/>
@@ -5064,7 +5064,7 @@
                 </a:solidFill>
                 <a:latin typeface="Calibri"/>
               </a:rPr>
-              <a:t>IPMA Kyrgyzstan  ·  Applying Member Association</a:t>
+              <a:t>IPMA Кыргызстан  ·  Ассоциация-кандидат</a:t>
             </a:r>
           </a:p>
         </p:txBody>
@@ -5238,7 +5238,7 @@
                 </a:solidFill>
                 <a:latin typeface="Calibri"/>
               </a:rPr>
-              <a:t>IPMA KYRGYZSTAN</a:t>
+              <a:t>IPMA КЫРГЫЗСТАН</a:t>
             </a:r>
           </a:p>
         </p:txBody>
@@ -5267,13 +5267,13 @@
           <a:p>
             <a:pPr algn="l"/>
             <a:r>
-              <a:rPr sz="3000" b="1">
+              <a:rPr sz="2800" b="1">
                 <a:solidFill>
                   <a:srgbClr val="0B1F33"/>
                 </a:solidFill>
                 <a:latin typeface="Georgia"/>
               </a:rPr>
-              <a:t>Our distinctive contribution</a:t>
+              <a:t>Наш особый вклад</a:t>
             </a:r>
           </a:p>
         </p:txBody>
@@ -5308,7 +5308,7 @@
                 </a:solidFill>
                 <a:latin typeface="Calibri"/>
               </a:rPr>
-              <a:t>Why IPMA Kyrgyzstan matters for the IPMA family</a:t>
+              <a:t>Почему IPMA Кыргызстан важен для семьи IPMA</a:t>
             </a:r>
           </a:p>
         </p:txBody>
@@ -5407,7 +5407,7 @@
         </p:nvSpPr>
         <p:spPr>
           <a:xfrm>
-            <a:off x="1005840" y="1965960"/>
+            <a:off x="1005840" y="1938528"/>
             <a:ext cx="10241280" cy="274320"/>
           </a:xfrm>
           <a:prstGeom prst="rect">
@@ -5423,13 +5423,13 @@
           <a:p>
             <a:pPr algn="l"/>
             <a:r>
-              <a:rPr sz="1600" b="1">
+              <a:rPr sz="1500" b="1">
                 <a:solidFill>
                   <a:srgbClr val="0B1F33"/>
                 </a:solidFill>
                 <a:latin typeface="Georgia"/>
               </a:rPr>
-              <a:t>Central Asia presence</a:t>
+              <a:t>Присутствие в Центральной Азии</a:t>
             </a:r>
           </a:p>
         </p:txBody>
@@ -5442,8 +5442,8 @@
         </p:nvSpPr>
         <p:spPr>
           <a:xfrm>
-            <a:off x="1005840" y="2286000"/>
-            <a:ext cx="10241280" cy="365760"/>
+            <a:off x="1005840" y="2267712"/>
+            <a:ext cx="10241280" cy="411480"/>
           </a:xfrm>
           <a:prstGeom prst="rect">
             <a:avLst/>
@@ -5458,13 +5458,13 @@
           <a:p>
             <a:pPr algn="l"/>
             <a:r>
-              <a:rPr sz="1300" b="0">
+              <a:rPr sz="1200" b="0">
                 <a:solidFill>
                   <a:srgbClr val="5A6B78"/>
                 </a:solidFill>
                 <a:latin typeface="Calibri"/>
               </a:rPr>
-              <a:t>Extend the IPMA footprint into a strategically important region with growing infrastructure and energy investment.</a:t>
+              <a:t>Расширить присутствие IPMA в стратегически важном регионе с растущими инвестициями в инфраструктуру и энергетику.</a:t>
             </a:r>
           </a:p>
         </p:txBody>
@@ -5563,7 +5563,7 @@
         </p:nvSpPr>
         <p:spPr>
           <a:xfrm>
-            <a:off x="1005840" y="3017520"/>
+            <a:off x="1005840" y="2990088"/>
             <a:ext cx="10241280" cy="274320"/>
           </a:xfrm>
           <a:prstGeom prst="rect">
@@ -5579,13 +5579,13 @@
           <a:p>
             <a:pPr algn="l"/>
             <a:r>
-              <a:rPr sz="1600" b="1">
+              <a:rPr sz="1500" b="1">
                 <a:solidFill>
                   <a:srgbClr val="0B1F33"/>
                 </a:solidFill>
                 <a:latin typeface="Georgia"/>
               </a:rPr>
-              <a:t>Bilingual reach</a:t>
+              <a:t>Двуязычный охват</a:t>
             </a:r>
           </a:p>
         </p:txBody>
@@ -5598,8 +5598,8 @@
         </p:nvSpPr>
         <p:spPr>
           <a:xfrm>
-            <a:off x="1005840" y="3337560"/>
-            <a:ext cx="10241280" cy="365760"/>
+            <a:off x="1005840" y="3319272"/>
+            <a:ext cx="10241280" cy="411480"/>
           </a:xfrm>
           <a:prstGeom prst="rect">
             <a:avLst/>
@@ -5614,13 +5614,13 @@
           <a:p>
             <a:pPr algn="l"/>
             <a:r>
-              <a:rPr sz="1300" b="0">
+              <a:rPr sz="1200" b="0">
                 <a:solidFill>
                   <a:srgbClr val="5A6B78"/>
                 </a:solidFill>
                 <a:latin typeface="Calibri"/>
               </a:rPr>
-              <a:t>Serve Russian- and Kyrgyz-speaking professionals and open accessible pathways into the IPMA ecosystem.</a:t>
+              <a:t>Работать с русско- и кыргызскоязычными специалистами и открывать доступные пути в экосистему IPMA.</a:t>
             </a:r>
           </a:p>
         </p:txBody>
@@ -5719,7 +5719,7 @@
         </p:nvSpPr>
         <p:spPr>
           <a:xfrm>
-            <a:off x="1005840" y="4069080"/>
+            <a:off x="1005840" y="4041648"/>
             <a:ext cx="10241280" cy="274320"/>
           </a:xfrm>
           <a:prstGeom prst="rect">
@@ -5735,13 +5735,13 @@
           <a:p>
             <a:pPr algn="l"/>
             <a:r>
-              <a:rPr sz="1600" b="1">
+              <a:rPr sz="1500" b="1">
                 <a:solidFill>
                   <a:srgbClr val="0B1F33"/>
                 </a:solidFill>
                 <a:latin typeface="Georgia"/>
               </a:rPr>
-              <a:t>Public &amp; donor projects</a:t>
+              <a:t>Государственные и донорские проекты</a:t>
             </a:r>
           </a:p>
         </p:txBody>
@@ -5754,8 +5754,8 @@
         </p:nvSpPr>
         <p:spPr>
           <a:xfrm>
-            <a:off x="1005840" y="4389120"/>
-            <a:ext cx="10241280" cy="365760"/>
+            <a:off x="1005840" y="4370832"/>
+            <a:ext cx="10241280" cy="411480"/>
           </a:xfrm>
           <a:prstGeom prst="rect">
             <a:avLst/>
@@ -5770,13 +5770,13 @@
           <a:p>
             <a:pPr algn="l"/>
             <a:r>
-              <a:rPr sz="1300" b="0">
+              <a:rPr sz="1200" b="0">
                 <a:solidFill>
                   <a:srgbClr val="5A6B78"/>
                 </a:solidFill>
                 <a:latin typeface="Calibri"/>
               </a:rPr>
-              <a:t>Raise competence where national programmes and international projects need reliable P3M practice.</a:t>
+              <a:t>Повышать компетентность там, где национальные программы и международные проекты нуждаются в надёжной практике P3M.</a:t>
             </a:r>
           </a:p>
         </p:txBody>
@@ -5875,7 +5875,7 @@
         </p:nvSpPr>
         <p:spPr>
           <a:xfrm>
-            <a:off x="1005840" y="5120639"/>
+            <a:off x="1005840" y="5093207"/>
             <a:ext cx="10241280" cy="274320"/>
           </a:xfrm>
           <a:prstGeom prst="rect">
@@ -5891,13 +5891,13 @@
           <a:p>
             <a:pPr algn="l"/>
             <a:r>
-              <a:rPr sz="1600" b="1">
+              <a:rPr sz="1500" b="1">
                 <a:solidFill>
                   <a:srgbClr val="0B1F33"/>
                 </a:solidFill>
                 <a:latin typeface="Georgia"/>
               </a:rPr>
-              <a:t>Peer collaboration</a:t>
+              <a:t>Партнёрство с другими MA</a:t>
             </a:r>
           </a:p>
         </p:txBody>
@@ -5910,8 +5910,8 @@
         </p:nvSpPr>
         <p:spPr>
           <a:xfrm>
-            <a:off x="1005840" y="5440679"/>
-            <a:ext cx="10241280" cy="365760"/>
+            <a:off x="1005840" y="5422391"/>
+            <a:ext cx="10241280" cy="411480"/>
           </a:xfrm>
           <a:prstGeom prst="rect">
             <a:avLst/>
@@ -5926,13 +5926,13 @@
           <a:p>
             <a:pPr algn="l"/>
             <a:r>
-              <a:rPr sz="1300" b="0">
+              <a:rPr sz="1200" b="0">
                 <a:solidFill>
                   <a:srgbClr val="5A6B78"/>
                 </a:solidFill>
                 <a:latin typeface="Calibri"/>
               </a:rPr>
-              <a:t>Learn from mature MAs and CBs, and share back local insights from emerging-market project environments.</a:t>
+              <a:t>Учиться у зрелых ассоциаций и CB и делиться опытом emerging-рынков проектной среды.</a:t>
             </a:r>
           </a:p>
         </p:txBody>
@@ -5946,7 +5946,7 @@
         <p:spPr>
           <a:xfrm>
             <a:off x="502920" y="6446520"/>
-            <a:ext cx="7315200" cy="320040"/>
+            <a:ext cx="8229600" cy="320040"/>
           </a:xfrm>
           <a:prstGeom prst="rect">
             <a:avLst/>
@@ -5967,7 +5967,7 @@
                 </a:solidFill>
                 <a:latin typeface="Calibri"/>
               </a:rPr>
-              <a:t>IPMA Kyrgyzstan  ·  Applying Member Association</a:t>
+              <a:t>IPMA Кыргызстан  ·  Ассоциация-кандидат</a:t>
             </a:r>
           </a:p>
         </p:txBody>
@@ -6162,7 +6162,7 @@
         </p:nvSpPr>
         <p:spPr>
           <a:xfrm>
-            <a:off x="822960" y="1417320"/>
+            <a:off x="822960" y="1371600"/>
             <a:ext cx="10058400" cy="320040"/>
           </a:xfrm>
           <a:prstGeom prst="rect">
@@ -6184,7 +6184,7 @@
                 </a:solidFill>
                 <a:latin typeface="Calibri"/>
               </a:rPr>
-              <a:t>WE WELCOME YOUR SUPPORT</a:t>
+              <a:t>МЫ ПРОСИМ ВАШЕЙ ПОДДЕРЖКИ</a:t>
             </a:r>
           </a:p>
         </p:txBody>
@@ -6197,8 +6197,8 @@
         </p:nvSpPr>
         <p:spPr>
           <a:xfrm>
-            <a:off x="822960" y="1965960"/>
-            <a:ext cx="10515600" cy="1828800"/>
+            <a:off x="822960" y="1920240"/>
+            <a:ext cx="10515600" cy="1920240"/>
           </a:xfrm>
           <a:prstGeom prst="rect">
             <a:avLst/>
@@ -6213,13 +6213,13 @@
           <a:p>
             <a:pPr algn="l"/>
             <a:r>
-              <a:rPr sz="2400" b="0">
+              <a:rPr sz="2200" b="0">
                 <a:solidFill>
                   <a:srgbClr val="FFFFFF"/>
                 </a:solidFill>
                 <a:latin typeface="Georgia"/>
               </a:rPr>
-              <a:t>The IPMA Kyrgyzstan team is ready to establish a distinct Member Association, grow a national P3M community, and collaborate with IPMA globally and through peer associations.</a:t>
+              <a:t>Команда IPMA Кыргызстан готова создать самостоятельную Member Association, вырастить национальное сообщество P3M и сотрудничать с IPMA глобально и через другие ассоциации.</a:t>
             </a:r>
           </a:p>
         </p:txBody>
@@ -6232,8 +6232,8 @@
         </p:nvSpPr>
         <p:spPr>
           <a:xfrm>
-            <a:off x="822960" y="4069080"/>
-            <a:ext cx="10515600" cy="822960"/>
+            <a:off x="822960" y="4114800"/>
+            <a:ext cx="10515600" cy="914400"/>
           </a:xfrm>
           <a:prstGeom prst="rect">
             <a:avLst/>
@@ -6248,13 +6248,13 @@
           <a:p>
             <a:pPr algn="l"/>
             <a:r>
-              <a:rPr sz="1600" b="0">
+              <a:rPr sz="1500" b="0">
                 <a:solidFill>
                   <a:srgbClr val="C5D4DE"/>
                 </a:solidFill>
                 <a:latin typeface="Calibri"/>
               </a:rPr>
-              <a:t>We respectfully ask for your support as an Applying Member Association — and look forward to contributing a new Central Asian voice to the IPMA family.</a:t>
+              <a:t>Мы уважительно просим поддержать нас как ассоциацию-кандидата — и с нетерпением ждём возможности привнести голос Центральной Азии в семью IPMA.</a:t>
             </a:r>
           </a:p>
         </p:txBody>
@@ -6268,7 +6268,7 @@
         <p:spPr>
           <a:xfrm>
             <a:off x="502920" y="6446520"/>
-            <a:ext cx="7315200" cy="320040"/>
+            <a:ext cx="8229600" cy="320040"/>
           </a:xfrm>
           <a:prstGeom prst="rect">
             <a:avLst/>
@@ -6289,7 +6289,7 @@
                 </a:solidFill>
                 <a:latin typeface="Calibri"/>
               </a:rPr>
-              <a:t>IPMA Kyrgyzstan  ·  Applying Member Association</a:t>
+              <a:t>IPMA Кыргызстан  ·  Ассоциация-кандидат</a:t>
             </a:r>
           </a:p>
         </p:txBody>
@@ -6463,7 +6463,7 @@
                 </a:solidFill>
                 <a:latin typeface="Georgia"/>
               </a:rPr>
-              <a:t>Thank you for your attention</a:t>
+              <a:t>Спасибо за внимание</a:t>
             </a:r>
           </a:p>
         </p:txBody>
@@ -6498,7 +6498,7 @@
                 </a:solidFill>
                 <a:latin typeface="Calibri"/>
               </a:rPr>
-              <a:t>Looking forward to future cooperation within the IPMA family</a:t>
+              <a:t>Ждём сотрудничества в семье IPMA</a:t>
             </a:r>
           </a:p>
         </p:txBody>
@@ -6576,7 +6576,7 @@
                 </a:solidFill>
                 <a:latin typeface="Calibri"/>
               </a:rPr>
-              <a:t>CONTACTS</a:t>
+              <a:t>КОНТАКТЫ</a:t>
             </a:r>
           </a:p>
         </p:txBody>
@@ -6611,7 +6611,7 @@
                 </a:solidFill>
                 <a:latin typeface="Calibri"/>
               </a:rPr>
-              <a:t>President:  [name]@[organisation].kg</a:t>
+              <a:t>Президент:  [имя]@[организация].kg</a:t>
             </a:r>
           </a:p>
         </p:txBody>
@@ -6646,7 +6646,7 @@
                 </a:solidFill>
                 <a:latin typeface="Calibri"/>
               </a:rPr>
-              <a:t>Vice-President:  [name]@[organisation].kg</a:t>
+              <a:t>Вице-президент:  [имя]@[организация].kg</a:t>
             </a:r>
           </a:p>
         </p:txBody>
@@ -6681,7 +6681,7 @@
                 </a:solidFill>
                 <a:latin typeface="Calibri"/>
               </a:rPr>
-              <a:t>Any questions?</a:t>
+              <a:t>Вопросы?</a:t>
             </a:r>
           </a:p>
         </p:txBody>
@@ -6695,7 +6695,7 @@
         <p:spPr>
           <a:xfrm>
             <a:off x="502920" y="6446520"/>
-            <a:ext cx="7315200" cy="320040"/>
+            <a:ext cx="8229600" cy="320040"/>
           </a:xfrm>
           <a:prstGeom prst="rect">
             <a:avLst/>
@@ -6716,7 +6716,7 @@
                 </a:solidFill>
                 <a:latin typeface="Calibri"/>
               </a:rPr>
-              <a:t>IPMA Kyrgyzstan  ·  Applying Member Association</a:t>
+              <a:t>IPMA Кыргызстан  ·  Ассоциация-кандидат</a:t>
             </a:r>
           </a:p>
         </p:txBody>
@@ -6890,7 +6890,7 @@
                 </a:solidFill>
                 <a:latin typeface="Calibri"/>
               </a:rPr>
-              <a:t>IPMA KYRGYZSTAN</a:t>
+              <a:t>IPMA КЫРГЫЗСТАН</a:t>
             </a:r>
           </a:p>
         </p:txBody>
@@ -6919,13 +6919,13 @@
           <a:p>
             <a:pPr algn="l"/>
             <a:r>
-              <a:rPr sz="3000" b="1">
+              <a:rPr sz="2800" b="1">
                 <a:solidFill>
                   <a:srgbClr val="0B1F33"/>
                 </a:solidFill>
                 <a:latin typeface="Georgia"/>
               </a:rPr>
-              <a:t>Introduction of ourselves</a:t>
+              <a:t>Представление команды</a:t>
             </a:r>
           </a:p>
         </p:txBody>
@@ -6960,7 +6960,7 @@
                 </a:solidFill>
                 <a:latin typeface="Calibri"/>
               </a:rPr>
-              <a:t>Leadership of the applying Member Association</a:t>
+              <a:t>Руководство ассоциации-кандидата</a:t>
             </a:r>
           </a:p>
         </p:txBody>
@@ -7081,7 +7081,7 @@
                 </a:solidFill>
                 <a:latin typeface="Calibri"/>
               </a:rPr>
-              <a:t>PRESIDENT</a:t>
+              <a:t>ПРЕЗИДЕНТ</a:t>
             </a:r>
           </a:p>
         </p:txBody>
@@ -7116,7 +7116,7 @@
                 </a:solidFill>
                 <a:latin typeface="Georgia"/>
               </a:rPr>
-              <a:t>[Name Surname]</a:t>
+              <a:t>[Имя Фамилия]</a:t>
             </a:r>
           </a:p>
         </p:txBody>
@@ -7145,65 +7145,65 @@
           <a:p>
             <a:pPr>
               <a:spcAft>
-                <a:spcPts val="1000"/>
+                <a:spcPts val="900"/>
               </a:spcAft>
             </a:pPr>
             <a:r>
-              <a:rPr sz="1400" b="0">
+              <a:rPr sz="1300" b="0">
                 <a:solidFill>
                   <a:srgbClr val="1C2834"/>
                 </a:solidFill>
                 <a:latin typeface="Calibri"/>
               </a:rPr>
-              <a:t>• Project management practitioner / academic with experience in Kyrgyzstan</a:t>
+              <a:t>• Практик / преподаватель в области управления проектами в Кыргызстане</a:t>
             </a:r>
           </a:p>
           <a:p>
             <a:pPr>
               <a:spcAft>
-                <a:spcPts val="1000"/>
+                <a:spcPts val="900"/>
               </a:spcAft>
             </a:pPr>
             <a:r>
-              <a:rPr sz="1400" b="0">
+              <a:rPr sz="1300" b="0">
                 <a:solidFill>
                   <a:srgbClr val="1C2834"/>
                 </a:solidFill>
                 <a:latin typeface="Calibri"/>
               </a:rPr>
-              <a:t>• Leadership in establishing a national PM professional community</a:t>
+              <a:t>• Опыт формирования национального профессионального сообщества PM</a:t>
             </a:r>
           </a:p>
           <a:p>
             <a:pPr>
               <a:spcAft>
-                <a:spcPts val="1000"/>
+                <a:spcPts val="900"/>
               </a:spcAft>
             </a:pPr>
             <a:r>
-              <a:rPr sz="1400" b="0">
+              <a:rPr sz="1300" b="0">
                 <a:solidFill>
                   <a:srgbClr val="1C2834"/>
                 </a:solidFill>
                 <a:latin typeface="Calibri"/>
               </a:rPr>
-              <a:t>• Strong links with universities, public sector and industry partners</a:t>
+              <a:t>• Связи с университетами, госсектором и бизнес-партнёрами</a:t>
             </a:r>
           </a:p>
           <a:p>
             <a:pPr>
               <a:spcAft>
-                <a:spcPts val="1000"/>
+                <a:spcPts val="900"/>
               </a:spcAft>
             </a:pPr>
             <a:r>
-              <a:rPr sz="1400" b="0">
+              <a:rPr sz="1300" b="0">
                 <a:solidFill>
                   <a:srgbClr val="1C2834"/>
                 </a:solidFill>
                 <a:latin typeface="Calibri"/>
               </a:rPr>
-              <a:t>• Committed to aligning national practice with IPMA values and standards</a:t>
+              <a:t>• Готовность выстраивать практику в соответствии с ценностями IPMA</a:t>
             </a:r>
           </a:p>
         </p:txBody>
@@ -7324,7 +7324,7 @@
                 </a:solidFill>
                 <a:latin typeface="Calibri"/>
               </a:rPr>
-              <a:t>VICE-PRESIDENT</a:t>
+              <a:t>ВИЦЕ-ПРЕЗИДЕНТ</a:t>
             </a:r>
           </a:p>
         </p:txBody>
@@ -7359,7 +7359,7 @@
                 </a:solidFill>
                 <a:latin typeface="Georgia"/>
               </a:rPr>
-              <a:t>[Name Surname]</a:t>
+              <a:t>[Имя Фамилия]</a:t>
             </a:r>
           </a:p>
         </p:txBody>
@@ -7388,65 +7388,65 @@
           <a:p>
             <a:pPr>
               <a:spcAft>
-                <a:spcPts val="1000"/>
+                <a:spcPts val="900"/>
               </a:spcAft>
             </a:pPr>
             <a:r>
-              <a:rPr sz="1400" b="0">
+              <a:rPr sz="1300" b="0">
                 <a:solidFill>
                   <a:srgbClr val="1C2834"/>
                 </a:solidFill>
                 <a:latin typeface="Calibri"/>
               </a:rPr>
-              <a:t>• Experience in education, certification pathways and community building</a:t>
+              <a:t>• Опыт в образовании, сертификационных траекториях и развитии сообщества</a:t>
             </a:r>
           </a:p>
           <a:p>
             <a:pPr>
               <a:spcAft>
-                <a:spcPts val="1000"/>
+                <a:spcPts val="900"/>
               </a:spcAft>
             </a:pPr>
             <a:r>
-              <a:rPr sz="1400" b="0">
+              <a:rPr sz="1300" b="0">
                 <a:solidFill>
                   <a:srgbClr val="1C2834"/>
                 </a:solidFill>
                 <a:latin typeface="Calibri"/>
               </a:rPr>
-              <a:t>• Focus on Young Crew development and university engagement</a:t>
+              <a:t>• Фокус на Young Crew и работе с университетами</a:t>
             </a:r>
           </a:p>
           <a:p>
             <a:pPr>
               <a:spcAft>
-                <a:spcPts val="1000"/>
+                <a:spcPts val="900"/>
               </a:spcAft>
             </a:pPr>
             <a:r>
-              <a:rPr sz="1400" b="0">
+              <a:rPr sz="1300" b="0">
                 <a:solidFill>
                   <a:srgbClr val="1C2834"/>
                 </a:solidFill>
                 <a:latin typeface="Calibri"/>
               </a:rPr>
-              <a:t>• Author / contributor in project and programme management topics</a:t>
+              <a:t>• Автор / участник публикаций по управлению проектами и программами</a:t>
             </a:r>
           </a:p>
           <a:p>
             <a:pPr>
               <a:spcAft>
-                <a:spcPts val="1000"/>
+                <a:spcPts val="900"/>
               </a:spcAft>
             </a:pPr>
             <a:r>
-              <a:rPr sz="1400" b="0">
+              <a:rPr sz="1300" b="0">
                 <a:solidFill>
                   <a:srgbClr val="1C2834"/>
                 </a:solidFill>
                 <a:latin typeface="Calibri"/>
               </a:rPr>
-              <a:t>• Ready to co-lead IPMA Kyrgyzstan operations and partnerships</a:t>
+              <a:t>• Готовность совместно вести операционную работу и партнёрства</a:t>
             </a:r>
           </a:p>
         </p:txBody>
@@ -7460,7 +7460,7 @@
         <p:spPr>
           <a:xfrm>
             <a:off x="502920" y="6446520"/>
-            <a:ext cx="7315200" cy="320040"/>
+            <a:ext cx="8229600" cy="320040"/>
           </a:xfrm>
           <a:prstGeom prst="rect">
             <a:avLst/>
@@ -7481,7 +7481,7 @@
                 </a:solidFill>
                 <a:latin typeface="Calibri"/>
               </a:rPr>
-              <a:t>IPMA Kyrgyzstan  ·  Applying Member Association</a:t>
+              <a:t>IPMA Кыргызстан  ·  Ассоциация-кандидат</a:t>
             </a:r>
           </a:p>
         </p:txBody>
@@ -7655,7 +7655,7 @@
                 </a:solidFill>
                 <a:latin typeface="Calibri"/>
               </a:rPr>
-              <a:t>IPMA KYRGYZSTAN</a:t>
+              <a:t>IPMA КЫРГЫЗСТАН</a:t>
             </a:r>
           </a:p>
         </p:txBody>
@@ -7684,13 +7684,13 @@
           <a:p>
             <a:pPr algn="l"/>
             <a:r>
-              <a:rPr sz="3000" b="1">
+              <a:rPr sz="2800" b="1">
                 <a:solidFill>
                   <a:srgbClr val="0B1F33"/>
                 </a:solidFill>
                 <a:latin typeface="Georgia"/>
               </a:rPr>
-              <a:t>A team ready to build IPMA Kyrgyzstan</a:t>
+              <a:t>Команда готова к запуску</a:t>
             </a:r>
           </a:p>
         </p:txBody>
@@ -7725,7 +7725,7 @@
                 </a:solidFill>
                 <a:latin typeface="Calibri"/>
               </a:rPr>
-              <a:t>Governance roles prepared for launch</a:t>
+              <a:t>Ключевые роли управления ассоциацией</a:t>
             </a:r>
           </a:p>
         </p:txBody>
@@ -7824,8 +7824,8 @@
         </p:nvSpPr>
         <p:spPr>
           <a:xfrm>
-            <a:off x="914400" y="2240280"/>
-            <a:ext cx="3108960" cy="411480"/>
+            <a:off x="914400" y="2194560"/>
+            <a:ext cx="3108960" cy="457200"/>
           </a:xfrm>
           <a:prstGeom prst="rect">
             <a:avLst/>
@@ -7840,13 +7840,13 @@
           <a:p>
             <a:pPr algn="l"/>
             <a:r>
-              <a:rPr sz="1800" b="1">
+              <a:rPr sz="1600" b="1">
                 <a:solidFill>
                   <a:srgbClr val="0B1F33"/>
                 </a:solidFill>
                 <a:latin typeface="Georgia"/>
               </a:rPr>
-              <a:t>President</a:t>
+              <a:t>Президент</a:t>
             </a:r>
           </a:p>
         </p:txBody>
@@ -7881,7 +7881,7 @@
                 </a:solidFill>
                 <a:latin typeface="Calibri"/>
               </a:rPr>
-              <a:t>Overall leadership &amp; CoD representation</a:t>
+              <a:t>Общее руководство и представительство на CoD</a:t>
             </a:r>
           </a:p>
         </p:txBody>
@@ -7980,8 +7980,8 @@
         </p:nvSpPr>
         <p:spPr>
           <a:xfrm>
-            <a:off x="4663440" y="2240280"/>
-            <a:ext cx="3108960" cy="411480"/>
+            <a:off x="4663440" y="2194560"/>
+            <a:ext cx="3108960" cy="457200"/>
           </a:xfrm>
           <a:prstGeom prst="rect">
             <a:avLst/>
@@ -7996,13 +7996,13 @@
           <a:p>
             <a:pPr algn="l"/>
             <a:r>
-              <a:rPr sz="1800" b="1">
+              <a:rPr sz="1600" b="1">
                 <a:solidFill>
                   <a:srgbClr val="0B1F33"/>
                 </a:solidFill>
                 <a:latin typeface="Georgia"/>
               </a:rPr>
-              <a:t>Vice-President</a:t>
+              <a:t>Вице-президент</a:t>
             </a:r>
           </a:p>
         </p:txBody>
@@ -8037,7 +8037,7 @@
                 </a:solidFill>
                 <a:latin typeface="Calibri"/>
               </a:rPr>
-              <a:t>Membership, partners &amp; operations</a:t>
+              <a:t>Членство, партнёры и операционная работа</a:t>
             </a:r>
           </a:p>
         </p:txBody>
@@ -8136,8 +8136,8 @@
         </p:nvSpPr>
         <p:spPr>
           <a:xfrm>
-            <a:off x="8412479" y="2240280"/>
-            <a:ext cx="3108960" cy="411480"/>
+            <a:off x="8412479" y="2194560"/>
+            <a:ext cx="3108960" cy="457200"/>
           </a:xfrm>
           <a:prstGeom prst="rect">
             <a:avLst/>
@@ -8152,13 +8152,13 @@
           <a:p>
             <a:pPr algn="l"/>
             <a:r>
-              <a:rPr sz="1800" b="1">
+              <a:rPr sz="1600" b="1">
                 <a:solidFill>
                   <a:srgbClr val="0B1F33"/>
                 </a:solidFill>
                 <a:latin typeface="Georgia"/>
               </a:rPr>
-              <a:t>Certification Lead</a:t>
+              <a:t>Руководитель сертификации</a:t>
             </a:r>
           </a:p>
         </p:txBody>
@@ -8193,7 +8193,7 @@
                 </a:solidFill>
                 <a:latin typeface="Calibri"/>
               </a:rPr>
-              <a:t>CB setup, assessors &amp; quality</a:t>
+              <a:t>Создание CB, ассессоры и качество</a:t>
             </a:r>
           </a:p>
         </p:txBody>
@@ -8292,8 +8292,8 @@
         </p:nvSpPr>
         <p:spPr>
           <a:xfrm>
-            <a:off x="914400" y="4206240"/>
-            <a:ext cx="3108960" cy="411480"/>
+            <a:off x="914400" y="4160520"/>
+            <a:ext cx="3108960" cy="457200"/>
           </a:xfrm>
           <a:prstGeom prst="rect">
             <a:avLst/>
@@ -8308,13 +8308,13 @@
           <a:p>
             <a:pPr algn="l"/>
             <a:r>
-              <a:rPr sz="1800" b="1">
+              <a:rPr sz="1600" b="1">
                 <a:solidFill>
                   <a:srgbClr val="0B1F33"/>
                 </a:solidFill>
                 <a:latin typeface="Georgia"/>
               </a:rPr>
-              <a:t>Young Crew Lead</a:t>
+              <a:t>Лидер Young Crew</a:t>
             </a:r>
           </a:p>
         </p:txBody>
@@ -8349,7 +8349,7 @@
                 </a:solidFill>
                 <a:latin typeface="Calibri"/>
               </a:rPr>
-              <a:t>Universities &amp; early-career talent</a:t>
+              <a:t>Университеты и молодые специалисты</a:t>
             </a:r>
           </a:p>
         </p:txBody>
@@ -8448,8 +8448,8 @@
         </p:nvSpPr>
         <p:spPr>
           <a:xfrm>
-            <a:off x="4663440" y="4206240"/>
-            <a:ext cx="3108960" cy="411480"/>
+            <a:off x="4663440" y="4160520"/>
+            <a:ext cx="3108960" cy="457200"/>
           </a:xfrm>
           <a:prstGeom prst="rect">
             <a:avLst/>
@@ -8464,13 +8464,13 @@
           <a:p>
             <a:pPr algn="l"/>
             <a:r>
-              <a:rPr sz="1800" b="1">
+              <a:rPr sz="1600" b="1">
                 <a:solidFill>
                   <a:srgbClr val="0B1F33"/>
                 </a:solidFill>
                 <a:latin typeface="Georgia"/>
               </a:rPr>
-              <a:t>Communications</a:t>
+              <a:t>Коммуникации</a:t>
             </a:r>
           </a:p>
         </p:txBody>
@@ -8505,7 +8505,7 @@
                 </a:solidFill>
                 <a:latin typeface="Calibri"/>
               </a:rPr>
-              <a:t>Ecosystem, events &amp; digital presence</a:t>
+              <a:t>Экосистема, мероприятия и цифровой канал</a:t>
             </a:r>
           </a:p>
         </p:txBody>
@@ -8604,8 +8604,8 @@
         </p:nvSpPr>
         <p:spPr>
           <a:xfrm>
-            <a:off x="8412479" y="4206240"/>
-            <a:ext cx="3108960" cy="411480"/>
+            <a:off x="8412479" y="4160520"/>
+            <a:ext cx="3108960" cy="457200"/>
           </a:xfrm>
           <a:prstGeom prst="rect">
             <a:avLst/>
@@ -8620,13 +8620,13 @@
           <a:p>
             <a:pPr algn="l"/>
             <a:r>
-              <a:rPr sz="1800" b="1">
+              <a:rPr sz="1600" b="1">
                 <a:solidFill>
                   <a:srgbClr val="0B1F33"/>
                 </a:solidFill>
                 <a:latin typeface="Georgia"/>
               </a:rPr>
-              <a:t>Treasurer</a:t>
+              <a:t>Казначей</a:t>
             </a:r>
           </a:p>
         </p:txBody>
@@ -8661,7 +8661,7 @@
                 </a:solidFill>
                 <a:latin typeface="Calibri"/>
               </a:rPr>
-              <a:t>Not-for-profit financial stewardship</a:t>
+              <a:t>Финансовое управление НКО</a:t>
             </a:r>
           </a:p>
         </p:txBody>
@@ -8675,7 +8675,7 @@
         <p:spPr>
           <a:xfrm>
             <a:off x="502920" y="6446520"/>
-            <a:ext cx="7315200" cy="320040"/>
+            <a:ext cx="8229600" cy="320040"/>
           </a:xfrm>
           <a:prstGeom prst="rect">
             <a:avLst/>
@@ -8696,7 +8696,7 @@
                 </a:solidFill>
                 <a:latin typeface="Calibri"/>
               </a:rPr>
-              <a:t>IPMA Kyrgyzstan  ·  Applying Member Association</a:t>
+              <a:t>IPMA Кыргызстан  ·  Ассоциация-кандидат</a:t>
             </a:r>
           </a:p>
         </p:txBody>
@@ -8870,7 +8870,7 @@
                 </a:solidFill>
                 <a:latin typeface="Calibri"/>
               </a:rPr>
-              <a:t>IPMA KYRGYZSTAN</a:t>
+              <a:t>IPMA КЫРГЫЗСТАН</a:t>
             </a:r>
           </a:p>
         </p:txBody>
@@ -8899,13 +8899,13 @@
           <a:p>
             <a:pPr algn="l"/>
             <a:r>
-              <a:rPr sz="3000" b="1">
+              <a:rPr sz="2800" b="1">
                 <a:solidFill>
                   <a:srgbClr val="0B1F33"/>
                 </a:solidFill>
                 <a:latin typeface="Georgia"/>
               </a:rPr>
-              <a:t>Strategic position of Kyrgyzstan</a:t>
+              <a:t>Стратегическое положение Кыргызстана</a:t>
             </a:r>
           </a:p>
         </p:txBody>
@@ -8940,7 +8940,7 @@
                 </a:solidFill>
                 <a:latin typeface="Calibri"/>
               </a:rPr>
-              <a:t>A Central Asian gateway for professional project management</a:t>
+              <a:t>Центральноазиатский мост для профессионального управления проектами</a:t>
             </a:r>
           </a:p>
         </p:txBody>
@@ -8997,7 +8997,7 @@
         <p:spPr>
           <a:xfrm>
             <a:off x="868680" y="1965960"/>
-            <a:ext cx="2194560" cy="365760"/>
+            <a:ext cx="2377440" cy="365760"/>
           </a:xfrm>
           <a:prstGeom prst="rect">
             <a:avLst/>
@@ -9018,7 +9018,7 @@
                 </a:solidFill>
                 <a:latin typeface="Calibri"/>
               </a:rPr>
-              <a:t>Area</a:t>
+              <a:t>Площадь</a:t>
             </a:r>
           </a:p>
         </p:txBody>
@@ -9031,8 +9031,8 @@
         </p:nvSpPr>
         <p:spPr>
           <a:xfrm>
-            <a:off x="3108960" y="1965960"/>
-            <a:ext cx="8229600" cy="365760"/>
+            <a:off x="3291840" y="1965960"/>
+            <a:ext cx="8046720" cy="365760"/>
           </a:xfrm>
           <a:prstGeom prst="rect">
             <a:avLst/>
@@ -9047,13 +9047,13 @@
           <a:p>
             <a:pPr algn="l"/>
             <a:r>
-              <a:rPr sz="1400" b="0">
+              <a:rPr sz="1300" b="0">
                 <a:solidFill>
                   <a:srgbClr val="1C2834"/>
                 </a:solidFill>
                 <a:latin typeface="Calibri"/>
               </a:rPr>
-              <a:t>199,900 km² — mountainous heart of Central Asia</a:t>
+              <a:t>199 900 км² — горное сердце Центральной Азии</a:t>
             </a:r>
           </a:p>
         </p:txBody>
@@ -9110,7 +9110,7 @@
         <p:spPr>
           <a:xfrm>
             <a:off x="868680" y="2651760"/>
-            <a:ext cx="2194560" cy="365760"/>
+            <a:ext cx="2377440" cy="365760"/>
           </a:xfrm>
           <a:prstGeom prst="rect">
             <a:avLst/>
@@ -9131,7 +9131,7 @@
                 </a:solidFill>
                 <a:latin typeface="Calibri"/>
               </a:rPr>
-              <a:t>Population</a:t>
+              <a:t>Население</a:t>
             </a:r>
           </a:p>
         </p:txBody>
@@ -9144,8 +9144,8 @@
         </p:nvSpPr>
         <p:spPr>
           <a:xfrm>
-            <a:off x="3108960" y="2651760"/>
-            <a:ext cx="8229600" cy="365760"/>
+            <a:off x="3291840" y="2651760"/>
+            <a:ext cx="8046720" cy="365760"/>
           </a:xfrm>
           <a:prstGeom prst="rect">
             <a:avLst/>
@@ -9160,13 +9160,13 @@
           <a:p>
             <a:pPr algn="l"/>
             <a:r>
-              <a:rPr sz="1400" b="0">
+              <a:rPr sz="1300" b="0">
                 <a:solidFill>
                   <a:srgbClr val="1C2834"/>
                 </a:solidFill>
                 <a:latin typeface="Calibri"/>
               </a:rPr>
-              <a:t>~7.2 million (2024)</a:t>
+              <a:t>~7,2 млн (2024)</a:t>
             </a:r>
           </a:p>
         </p:txBody>
@@ -9223,7 +9223,7 @@
         <p:spPr>
           <a:xfrm>
             <a:off x="868680" y="3337560"/>
-            <a:ext cx="2194560" cy="365760"/>
+            <a:ext cx="2377440" cy="365760"/>
           </a:xfrm>
           <a:prstGeom prst="rect">
             <a:avLst/>
@@ -9244,7 +9244,7 @@
                 </a:solidFill>
                 <a:latin typeface="Calibri"/>
               </a:rPr>
-              <a:t>Capital / HQ</a:t>
+              <a:t>Столица / офис</a:t>
             </a:r>
           </a:p>
         </p:txBody>
@@ -9257,8 +9257,8 @@
         </p:nvSpPr>
         <p:spPr>
           <a:xfrm>
-            <a:off x="3108960" y="3337560"/>
-            <a:ext cx="8229600" cy="365760"/>
+            <a:off x="3291840" y="3337560"/>
+            <a:ext cx="8046720" cy="365760"/>
           </a:xfrm>
           <a:prstGeom prst="rect">
             <a:avLst/>
@@ -9273,13 +9273,13 @@
           <a:p>
             <a:pPr algn="l"/>
             <a:r>
-              <a:rPr sz="1400" b="0">
+              <a:rPr sz="1300" b="0">
                 <a:solidFill>
                   <a:srgbClr val="1C2834"/>
                 </a:solidFill>
                 <a:latin typeface="Calibri"/>
               </a:rPr>
-              <a:t>Bishkek — proposed head office of the MA</a:t>
+              <a:t>Бишкек — предполагаемая штаб-квартира ассоциации</a:t>
             </a:r>
           </a:p>
         </p:txBody>
@@ -9336,7 +9336,7 @@
         <p:spPr>
           <a:xfrm>
             <a:off x="868680" y="4023360"/>
-            <a:ext cx="2194560" cy="365760"/>
+            <a:ext cx="2377440" cy="365760"/>
           </a:xfrm>
           <a:prstGeom prst="rect">
             <a:avLst/>
@@ -9357,7 +9357,7 @@
                 </a:solidFill>
                 <a:latin typeface="Calibri"/>
               </a:rPr>
-              <a:t>Key sectors</a:t>
+              <a:t>Отрасли</a:t>
             </a:r>
           </a:p>
         </p:txBody>
@@ -9370,8 +9370,8 @@
         </p:nvSpPr>
         <p:spPr>
           <a:xfrm>
-            <a:off x="3108960" y="4023360"/>
-            <a:ext cx="8229600" cy="365760"/>
+            <a:off x="3291840" y="4023360"/>
+            <a:ext cx="8046720" cy="365760"/>
           </a:xfrm>
           <a:prstGeom prst="rect">
             <a:avLst/>
@@ -9386,13 +9386,13 @@
           <a:p>
             <a:pPr algn="l"/>
             <a:r>
-              <a:rPr sz="1400" b="0">
+              <a:rPr sz="1300" b="0">
                 <a:solidFill>
                   <a:srgbClr val="1C2834"/>
                 </a:solidFill>
                 <a:latin typeface="Calibri"/>
               </a:rPr>
-              <a:t>Energy &amp; hydropower, mining, infrastructure, agriculture, IT &amp; digital services, public investment programmes</a:t>
+              <a:t>Энергетика и ГЭС, добыча, инфраструктура, сельское хозяйство, IT, госпрограммы инвестиций</a:t>
             </a:r>
           </a:p>
         </p:txBody>
@@ -9449,7 +9449,7 @@
         <p:spPr>
           <a:xfrm>
             <a:off x="868680" y="4709160"/>
-            <a:ext cx="2194560" cy="365760"/>
+            <a:ext cx="2377440" cy="365760"/>
           </a:xfrm>
           <a:prstGeom prst="rect">
             <a:avLst/>
@@ -9470,7 +9470,7 @@
                 </a:solidFill>
                 <a:latin typeface="Calibri"/>
               </a:rPr>
-              <a:t>Regional role</a:t>
+              <a:t>Регион</a:t>
             </a:r>
           </a:p>
         </p:txBody>
@@ -9483,8 +9483,8 @@
         </p:nvSpPr>
         <p:spPr>
           <a:xfrm>
-            <a:off x="3108960" y="4709160"/>
-            <a:ext cx="8229600" cy="365760"/>
+            <a:off x="3291840" y="4709160"/>
+            <a:ext cx="8046720" cy="365760"/>
           </a:xfrm>
           <a:prstGeom prst="rect">
             <a:avLst/>
@@ -9499,13 +9499,13 @@
           <a:p>
             <a:pPr algn="l"/>
             <a:r>
-              <a:rPr sz="1400" b="0">
+              <a:rPr sz="1300" b="0">
                 <a:solidFill>
                   <a:srgbClr val="1C2834"/>
                 </a:solidFill>
                 <a:latin typeface="Calibri"/>
               </a:rPr>
-              <a:t>Bridge between Central Asia, corridor projects and Eurasian markets</a:t>
+              <a:t>Связующее звено между Центральной Азией, коридорными проектами и евразийскими рынками</a:t>
             </a:r>
           </a:p>
         </p:txBody>
@@ -9562,7 +9562,7 @@
         <p:spPr>
           <a:xfrm>
             <a:off x="868680" y="5394960"/>
-            <a:ext cx="2194560" cy="365760"/>
+            <a:ext cx="2377440" cy="365760"/>
           </a:xfrm>
           <a:prstGeom prst="rect">
             <a:avLst/>
@@ -9583,7 +9583,7 @@
                 </a:solidFill>
                 <a:latin typeface="Calibri"/>
               </a:rPr>
-              <a:t>Opportunity</a:t>
+              <a:t>Возможность</a:t>
             </a:r>
           </a:p>
         </p:txBody>
@@ -9596,8 +9596,8 @@
         </p:nvSpPr>
         <p:spPr>
           <a:xfrm>
-            <a:off x="3108960" y="5394960"/>
-            <a:ext cx="8229600" cy="365760"/>
+            <a:off x="3291840" y="5394960"/>
+            <a:ext cx="8046720" cy="365760"/>
           </a:xfrm>
           <a:prstGeom prst="rect">
             <a:avLst/>
@@ -9612,13 +9612,13 @@
           <a:p>
             <a:pPr algn="l"/>
             <a:r>
-              <a:rPr sz="1400" b="0">
+              <a:rPr sz="1300" b="0">
                 <a:solidFill>
                   <a:srgbClr val="1C2834"/>
                 </a:solidFill>
                 <a:latin typeface="Calibri"/>
               </a:rPr>
-              <a:t>Growing demand for competent P3M capability in national and donor-funded projects</a:t>
+              <a:t>Растущий спрос на компетенции P3M в национальных и донорских проектах</a:t>
             </a:r>
           </a:p>
         </p:txBody>
@@ -9632,7 +9632,7 @@
         <p:spPr>
           <a:xfrm>
             <a:off x="502920" y="6446520"/>
-            <a:ext cx="7315200" cy="320040"/>
+            <a:ext cx="8229600" cy="320040"/>
           </a:xfrm>
           <a:prstGeom prst="rect">
             <a:avLst/>
@@ -9653,7 +9653,7 @@
                 </a:solidFill>
                 <a:latin typeface="Calibri"/>
               </a:rPr>
-              <a:t>IPMA Kyrgyzstan  ·  Applying Member Association</a:t>
+              <a:t>IPMA Кыргызстан  ·  Ассоциация-кандидат</a:t>
             </a:r>
           </a:p>
         </p:txBody>
@@ -9848,7 +9848,7 @@
         </p:nvSpPr>
         <p:spPr>
           <a:xfrm>
-            <a:off x="822960" y="1645920"/>
+            <a:off x="822960" y="1554480"/>
             <a:ext cx="10058400" cy="320040"/>
           </a:xfrm>
           <a:prstGeom prst="rect">
@@ -9870,7 +9870,7 @@
                 </a:solidFill>
                 <a:latin typeface="Calibri"/>
               </a:rPr>
-              <a:t>OUR MISSION</a:t>
+              <a:t>НАША МИССИЯ</a:t>
             </a:r>
           </a:p>
         </p:txBody>
@@ -9883,8 +9883,8 @@
         </p:nvSpPr>
         <p:spPr>
           <a:xfrm>
-            <a:off x="822960" y="2148840"/>
-            <a:ext cx="10515600" cy="2103120"/>
+            <a:off x="822960" y="2057400"/>
+            <a:ext cx="10515600" cy="2286000"/>
           </a:xfrm>
           <a:prstGeom prst="rect">
             <a:avLst/>
@@ -9899,13 +9899,13 @@
           <a:p>
             <a:pPr algn="l"/>
             <a:r>
-              <a:rPr sz="2600" b="0">
+              <a:rPr sz="2400" b="0">
                 <a:solidFill>
                   <a:srgbClr val="FFFFFF"/>
                 </a:solidFill>
                 <a:latin typeface="Georgia"/>
               </a:rPr>
-              <a:t>Promote and strengthen professionalism in project, programme and portfolio management across Kyrgyzstan — so that public and private projects achieve their objectives efficiently, ethically and in line with IPMA values and standards.</a:t>
+              <a:t>Продвигать и укреплять профессионализм в управлении проектами, программами и портфелями в Кыргызстане — чтобы государственные и частные проекты достигали целей эффективно, этично и в соответствии с ценностями и стандартами IPMA.</a:t>
             </a:r>
           </a:p>
         </p:txBody>
@@ -9918,7 +9918,7 @@
         </p:nvSpPr>
         <p:spPr>
           <a:xfrm>
-            <a:off x="822960" y="4572000"/>
+            <a:off x="822960" y="4617720"/>
             <a:ext cx="10058400" cy="411480"/>
           </a:xfrm>
           <a:prstGeom prst="rect">
@@ -9940,7 +9940,7 @@
                 </a:solidFill>
                 <a:latin typeface="Calibri"/>
               </a:rPr>
-              <a:t>A national home for the IPMA ecosystem in Central Asia.</a:t>
+              <a:t>Национальный дом экосистемы IPMA в Центральной Азии.</a:t>
             </a:r>
           </a:p>
         </p:txBody>
@@ -9954,7 +9954,7 @@
         <p:spPr>
           <a:xfrm>
             <a:off x="502920" y="6446520"/>
-            <a:ext cx="7315200" cy="320040"/>
+            <a:ext cx="8229600" cy="320040"/>
           </a:xfrm>
           <a:prstGeom prst="rect">
             <a:avLst/>
@@ -9975,7 +9975,7 @@
                 </a:solidFill>
                 <a:latin typeface="Calibri"/>
               </a:rPr>
-              <a:t>IPMA Kyrgyzstan  ·  Applying Member Association</a:t>
+              <a:t>IPMA Кыргызстан  ·  Ассоциация-кандидат</a:t>
             </a:r>
           </a:p>
         </p:txBody>
@@ -10149,7 +10149,7 @@
                 </a:solidFill>
                 <a:latin typeface="Calibri"/>
               </a:rPr>
-              <a:t>IPMA KYRGYZSTAN</a:t>
+              <a:t>IPMA КЫРГЫЗСТАН</a:t>
             </a:r>
           </a:p>
         </p:txBody>
@@ -10178,13 +10178,13 @@
           <a:p>
             <a:pPr algn="l"/>
             <a:r>
-              <a:rPr sz="3000" b="1">
+              <a:rPr sz="2800" b="1">
                 <a:solidFill>
                   <a:srgbClr val="0B1F33"/>
                 </a:solidFill>
                 <a:latin typeface="Georgia"/>
               </a:rPr>
-              <a:t>Strategic goals</a:t>
+              <a:t>Стратегические цели</a:t>
             </a:r>
           </a:p>
         </p:txBody>
@@ -10219,7 +10219,7 @@
                 </a:solidFill>
                 <a:latin typeface="Calibri"/>
               </a:rPr>
-              <a:t>Clear priorities for the first three years</a:t>
+              <a:t>Приоритеты первых трёх лет</a:t>
             </a:r>
           </a:p>
         </p:txBody>
@@ -10326,13 +10326,13 @@
           <a:p>
             <a:pPr algn="l"/>
             <a:r>
-              <a:rPr sz="1400" b="0">
+              <a:rPr sz="1300" b="0">
                 <a:solidFill>
                   <a:srgbClr val="1C2834"/>
                 </a:solidFill>
                 <a:latin typeface="Calibri"/>
               </a:rPr>
-              <a:t>Establish IPMA Kyrgyzstan as a recognised professional body in the Kyrgyz Republic.</a:t>
+              <a:t>Сделать IPMA Кыргызстан признанным профессиональным органом в Кыргызской Республике.</a:t>
             </a:r>
           </a:p>
         </p:txBody>
@@ -10439,13 +10439,13 @@
           <a:p>
             <a:pPr algn="l"/>
             <a:r>
-              <a:rPr sz="1400" b="0">
+              <a:rPr sz="1300" b="0">
                 <a:solidFill>
                   <a:srgbClr val="1C2834"/>
                 </a:solidFill>
                 <a:latin typeface="Calibri"/>
               </a:rPr>
-              <a:t>Grow a stable community of individual and corporate members from a clear baseline.</a:t>
+              <a:t>Вырастить устойчивое сообщество индивидуальных и корпоративных членов.</a:t>
             </a:r>
           </a:p>
         </p:txBody>
@@ -10552,13 +10552,13 @@
           <a:p>
             <a:pPr algn="l"/>
             <a:r>
-              <a:rPr sz="1400" b="0">
+              <a:rPr sz="1300" b="0">
                 <a:solidFill>
                   <a:srgbClr val="1C2834"/>
                 </a:solidFill>
                 <a:latin typeface="Calibri"/>
               </a:rPr>
-              <a:t>Establish the Kyrgyzstan Certification Body across all 4 IPMA levels.</a:t>
+              <a:t>Создать сертифицирующий орган (CB) Кыргызстана по всем 4 уровням IPMA.</a:t>
             </a:r>
           </a:p>
         </p:txBody>
@@ -10665,13 +10665,13 @@
           <a:p>
             <a:pPr algn="l"/>
             <a:r>
-              <a:rPr sz="1400" b="0">
+              <a:rPr sz="1300" b="0">
                 <a:solidFill>
                   <a:srgbClr val="1C2834"/>
                 </a:solidFill>
                 <a:latin typeface="Calibri"/>
               </a:rPr>
-              <a:t>Achieve sustained certification growth and quality of assessment.</a:t>
+              <a:t>Обеспечить рост сертификации и высокое качество оценки.</a:t>
             </a:r>
           </a:p>
         </p:txBody>
@@ -10778,13 +10778,13 @@
           <a:p>
             <a:pPr algn="l"/>
             <a:r>
-              <a:rPr sz="1400" b="0">
+              <a:rPr sz="1300" b="0">
                 <a:solidFill>
                   <a:srgbClr val="1C2834"/>
                 </a:solidFill>
                 <a:latin typeface="Calibri"/>
               </a:rPr>
-              <a:t>Promote the IPMA standard across Kyrgyzstan and the wider Central Asian region.</a:t>
+              <a:t>Продвигать стандарт IPMA в Кыргызстане и шире в Центральной Азии.</a:t>
             </a:r>
           </a:p>
         </p:txBody>
@@ -10891,13 +10891,13 @@
           <a:p>
             <a:pPr algn="l"/>
             <a:r>
-              <a:rPr sz="1400" b="0">
+              <a:rPr sz="1300" b="0">
                 <a:solidFill>
                   <a:srgbClr val="1C2834"/>
                 </a:solidFill>
                 <a:latin typeface="Calibri"/>
               </a:rPr>
-              <a:t>Launch and develop Young Crew Kyrgyzstan with universities.</a:t>
+              <a:t>Запустить и развивать Young Crew Кыргызстан вместе с университетами.</a:t>
             </a:r>
           </a:p>
         </p:txBody>
@@ -11004,13 +11004,13 @@
           <a:p>
             <a:pPr algn="l"/>
             <a:r>
-              <a:rPr sz="1400" b="0">
+              <a:rPr sz="1300" b="0">
                 <a:solidFill>
                   <a:srgbClr val="1C2834"/>
                 </a:solidFill>
                 <a:latin typeface="Calibri"/>
               </a:rPr>
-              <a:t>Participate in and organise IPMA events, webinars and knowledge exchanges.</a:t>
+              <a:t>Участвовать в мероприятиях IPMA и организовывать собственные события и вебинары.</a:t>
             </a:r>
           </a:p>
         </p:txBody>
@@ -11117,13 +11117,13 @@
           <a:p>
             <a:pPr algn="l"/>
             <a:r>
-              <a:rPr sz="1400" b="0">
+              <a:rPr sz="1300" b="0">
                 <a:solidFill>
                   <a:srgbClr val="1C2834"/>
                 </a:solidFill>
                 <a:latin typeface="Calibri"/>
               </a:rPr>
-              <a:t>Build durable partnerships with training providers, employers and peer MAs.</a:t>
+              <a:t>Выстроить партнёрства с провайдерами обучения, работодателями и другими MA.</a:t>
             </a:r>
           </a:p>
         </p:txBody>
@@ -11137,7 +11137,7 @@
         <p:spPr>
           <a:xfrm>
             <a:off x="502920" y="6446520"/>
-            <a:ext cx="7315200" cy="320040"/>
+            <a:ext cx="8229600" cy="320040"/>
           </a:xfrm>
           <a:prstGeom prst="rect">
             <a:avLst/>
@@ -11158,7 +11158,7 @@
                 </a:solidFill>
                 <a:latin typeface="Calibri"/>
               </a:rPr>
-              <a:t>IPMA Kyrgyzstan  ·  Applying Member Association</a:t>
+              <a:t>IPMA Кыргызстан  ·  Ассоциация-кандидат</a:t>
             </a:r>
           </a:p>
         </p:txBody>
@@ -11332,7 +11332,7 @@
                 </a:solidFill>
                 <a:latin typeface="Calibri"/>
               </a:rPr>
-              <a:t>IPMA KYRGYZSTAN</a:t>
+              <a:t>IPMA КЫРГЫЗСТАН</a:t>
             </a:r>
           </a:p>
         </p:txBody>
@@ -11361,13 +11361,13 @@
           <a:p>
             <a:pPr algn="l"/>
             <a:r>
-              <a:rPr sz="3000" b="1">
+              <a:rPr sz="2800" b="1">
                 <a:solidFill>
                   <a:srgbClr val="0B1F33"/>
                 </a:solidFill>
                 <a:latin typeface="Georgia"/>
               </a:rPr>
-              <a:t>Roadmap 2025–2027</a:t>
+              <a:t>Дорожная карта 2025–2027</a:t>
             </a:r>
           </a:p>
         </p:txBody>
@@ -11402,7 +11402,7 @@
                 </a:solidFill>
                 <a:latin typeface="Calibri"/>
               </a:rPr>
-              <a:t>Stabilise · Grow · Scale</a:t>
+              <a:t>Стабилизация · Рост · Масштаб</a:t>
             </a:r>
           </a:p>
         </p:txBody>
@@ -11459,7 +11459,7 @@
         <p:spPr>
           <a:xfrm>
             <a:off x="640080" y="1874519"/>
-            <a:ext cx="3611880" cy="822960"/>
+            <a:ext cx="3611880" cy="868680"/>
           </a:xfrm>
           <a:prstGeom prst="rect">
             <a:avLst/>
@@ -11537,7 +11537,7 @@
         <p:spPr>
           <a:xfrm>
             <a:off x="868680" y="2331720"/>
-            <a:ext cx="3108960" cy="274320"/>
+            <a:ext cx="3108960" cy="320040"/>
           </a:xfrm>
           <a:prstGeom prst="rect">
             <a:avLst/>
@@ -11552,13 +11552,13 @@
           <a:p>
             <a:pPr algn="l"/>
             <a:r>
-              <a:rPr sz="1300" b="0">
+              <a:rPr sz="1200" b="0">
                 <a:solidFill>
                   <a:srgbClr val="0B1F33"/>
                 </a:solidFill>
                 <a:latin typeface="Calibri"/>
               </a:rPr>
-              <a:t>Establish &amp; launch</a:t>
+              <a:t>Создание и запуск</a:t>
             </a:r>
           </a:p>
         </p:txBody>
@@ -11571,7 +11571,7 @@
         </p:nvSpPr>
         <p:spPr>
           <a:xfrm>
-            <a:off x="914400" y="2926080"/>
+            <a:off x="914400" y="2971800"/>
             <a:ext cx="3108960" cy="2743200"/>
           </a:xfrm>
           <a:prstGeom prst="rect">
@@ -11587,65 +11587,65 @@
           <a:p>
             <a:pPr>
               <a:spcAft>
-                <a:spcPts val="1200"/>
+                <a:spcPts val="1100"/>
               </a:spcAft>
             </a:pPr>
             <a:r>
-              <a:rPr sz="1400" b="0">
+              <a:rPr sz="1300" b="0">
                 <a:solidFill>
                   <a:srgbClr val="1C2834"/>
                 </a:solidFill>
                 <a:latin typeface="Calibri"/>
               </a:rPr>
-              <a:t>• Register non-profit association</a:t>
+              <a:t>• Зарегистрировать некоммерческую ассоциацию</a:t>
             </a:r>
           </a:p>
           <a:p>
             <a:pPr>
               <a:spcAft>
-                <a:spcPts val="1200"/>
+                <a:spcPts val="1100"/>
               </a:spcAft>
             </a:pPr>
             <a:r>
-              <a:rPr sz="1400" b="0">
+              <a:rPr sz="1300" b="0">
                 <a:solidFill>
                   <a:srgbClr val="1C2834"/>
                 </a:solidFill>
                 <a:latin typeface="Calibri"/>
               </a:rPr>
-              <a:t>• Become IPMA Applying Member Association</a:t>
+              <a:t>• Стать ассоциацией-кандидатом IPMA (AMA)</a:t>
             </a:r>
           </a:p>
           <a:p>
             <a:pPr>
               <a:spcAft>
-                <a:spcPts val="1200"/>
+                <a:spcPts val="1100"/>
               </a:spcAft>
             </a:pPr>
             <a:r>
-              <a:rPr sz="1400" b="0">
+              <a:rPr sz="1300" b="0">
                 <a:solidFill>
                   <a:srgbClr val="1C2834"/>
                 </a:solidFill>
                 <a:latin typeface="Calibri"/>
               </a:rPr>
-              <a:t>• Form Board and operating model</a:t>
+              <a:t>• Сформировать совет и операционную модель</a:t>
             </a:r>
           </a:p>
           <a:p>
             <a:pPr>
               <a:spcAft>
-                <a:spcPts val="1200"/>
+                <a:spcPts val="1100"/>
               </a:spcAft>
             </a:pPr>
             <a:r>
-              <a:rPr sz="1400" b="0">
+              <a:rPr sz="1300" b="0">
                 <a:solidFill>
                   <a:srgbClr val="1C2834"/>
                 </a:solidFill>
                 <a:latin typeface="Calibri"/>
               </a:rPr>
-              <a:t>• Target: ~25 founding members</a:t>
+              <a:t>• Цель: ~25 членов-основателей</a:t>
             </a:r>
           </a:p>
         </p:txBody>
@@ -11702,7 +11702,7 @@
         <p:spPr>
           <a:xfrm>
             <a:off x="4434840" y="1874519"/>
-            <a:ext cx="3611880" cy="822960"/>
+            <a:ext cx="3611880" cy="868680"/>
           </a:xfrm>
           <a:prstGeom prst="rect">
             <a:avLst/>
@@ -11780,7 +11780,7 @@
         <p:spPr>
           <a:xfrm>
             <a:off x="4663440" y="2331720"/>
-            <a:ext cx="3108960" cy="274320"/>
+            <a:ext cx="3108960" cy="320040"/>
           </a:xfrm>
           <a:prstGeom prst="rect">
             <a:avLst/>
@@ -11795,13 +11795,13 @@
           <a:p>
             <a:pPr algn="l"/>
             <a:r>
-              <a:rPr sz="1300" b="0">
+              <a:rPr sz="1200" b="0">
                 <a:solidFill>
                   <a:srgbClr val="FFFFFF"/>
                 </a:solidFill>
                 <a:latin typeface="Calibri"/>
               </a:rPr>
-              <a:t>Promote &amp; certify</a:t>
+              <a:t>Продвижение и сертификация</a:t>
             </a:r>
           </a:p>
         </p:txBody>
@@ -11814,7 +11814,7 @@
         </p:nvSpPr>
         <p:spPr>
           <a:xfrm>
-            <a:off x="4709160" y="2926080"/>
+            <a:off x="4709160" y="2971800"/>
             <a:ext cx="3108960" cy="2743200"/>
           </a:xfrm>
           <a:prstGeom prst="rect">
@@ -11830,65 +11830,65 @@
           <a:p>
             <a:pPr>
               <a:spcAft>
-                <a:spcPts val="1200"/>
+                <a:spcPts val="1100"/>
               </a:spcAft>
             </a:pPr>
             <a:r>
-              <a:rPr sz="1400" b="0">
+              <a:rPr sz="1300" b="0">
                 <a:solidFill>
                   <a:srgbClr val="1C2834"/>
                 </a:solidFill>
                 <a:latin typeface="Calibri"/>
               </a:rPr>
-              <a:t>• Grow membership and visibility</a:t>
+              <a:t>• Рост членства и узнаваемости</a:t>
             </a:r>
           </a:p>
           <a:p>
             <a:pPr>
               <a:spcAft>
-                <a:spcPts val="1200"/>
+                <a:spcPts val="1100"/>
               </a:spcAft>
             </a:pPr>
             <a:r>
-              <a:rPr sz="1400" b="0">
+              <a:rPr sz="1300" b="0">
                 <a:solidFill>
                   <a:srgbClr val="1C2834"/>
                 </a:solidFill>
                 <a:latin typeface="Calibri"/>
               </a:rPr>
-              <a:t>• Launch Certification Body pathway</a:t>
+              <a:t>• Запуск пути к Certification Body</a:t>
             </a:r>
           </a:p>
           <a:p>
             <a:pPr>
               <a:spcAft>
-                <a:spcPts val="1200"/>
+                <a:spcPts val="1100"/>
               </a:spcAft>
             </a:pPr>
             <a:r>
-              <a:rPr sz="1400" b="0">
+              <a:rPr sz="1300" b="0">
                 <a:solidFill>
                   <a:srgbClr val="1C2834"/>
                 </a:solidFill>
                 <a:latin typeface="Calibri"/>
               </a:rPr>
-              <a:t>• University &amp; corporate outreach</a:t>
+              <a:t>• Работа с вузами и корпоративным сектором</a:t>
             </a:r>
           </a:p>
           <a:p>
             <a:pPr>
               <a:spcAft>
-                <a:spcPts val="1200"/>
+                <a:spcPts val="1100"/>
               </a:spcAft>
             </a:pPr>
             <a:r>
-              <a:rPr sz="1400" b="0">
+              <a:rPr sz="1300" b="0">
                 <a:solidFill>
                   <a:srgbClr val="1C2834"/>
                 </a:solidFill>
                 <a:latin typeface="Calibri"/>
               </a:rPr>
-              <a:t>• Target: ~60 members</a:t>
+              <a:t>• Цель: ~60 членов</a:t>
             </a:r>
           </a:p>
         </p:txBody>
@@ -11945,7 +11945,7 @@
         <p:spPr>
           <a:xfrm>
             <a:off x="8229600" y="1874519"/>
-            <a:ext cx="3611880" cy="822960"/>
+            <a:ext cx="3611880" cy="868680"/>
           </a:xfrm>
           <a:prstGeom prst="rect">
             <a:avLst/>
@@ -12023,7 +12023,7 @@
         <p:spPr>
           <a:xfrm>
             <a:off x="8458200" y="2331720"/>
-            <a:ext cx="3108960" cy="274320"/>
+            <a:ext cx="3108960" cy="320040"/>
           </a:xfrm>
           <a:prstGeom prst="rect">
             <a:avLst/>
@@ -12038,13 +12038,13 @@
           <a:p>
             <a:pPr algn="l"/>
             <a:r>
-              <a:rPr sz="1300" b="0">
+              <a:rPr sz="1200" b="0">
                 <a:solidFill>
                   <a:srgbClr val="FFFFFF"/>
                 </a:solidFill>
                 <a:latin typeface="Calibri"/>
               </a:rPr>
-              <a:t>Scale &amp; show results</a:t>
+              <a:t>Масштаб и результаты</a:t>
             </a:r>
           </a:p>
         </p:txBody>
@@ -12057,7 +12057,7 @@
         </p:nvSpPr>
         <p:spPr>
           <a:xfrm>
-            <a:off x="8503920" y="2926080"/>
+            <a:off x="8503920" y="2971800"/>
             <a:ext cx="3108960" cy="2743200"/>
           </a:xfrm>
           <a:prstGeom prst="rect">
@@ -12073,65 +12073,65 @@
           <a:p>
             <a:pPr>
               <a:spcAft>
-                <a:spcPts val="1200"/>
+                <a:spcPts val="1100"/>
               </a:spcAft>
             </a:pPr>
             <a:r>
-              <a:rPr sz="1400" b="0">
+              <a:rPr sz="1300" b="0">
                 <a:solidFill>
                   <a:srgbClr val="1C2834"/>
                 </a:solidFill>
                 <a:latin typeface="Calibri"/>
               </a:rPr>
-              <a:t>• Present results to IPMA family</a:t>
+              <a:t>• Представить результаты семье IPMA</a:t>
             </a:r>
           </a:p>
           <a:p>
             <a:pPr>
               <a:spcAft>
-                <a:spcPts val="1200"/>
+                <a:spcPts val="1100"/>
               </a:spcAft>
             </a:pPr>
             <a:r>
-              <a:rPr sz="1400" b="0">
+              <a:rPr sz="1300" b="0">
                 <a:solidFill>
                   <a:srgbClr val="1C2834"/>
                 </a:solidFill>
                 <a:latin typeface="Calibri"/>
               </a:rPr>
-              <a:t>• Expand certification volumes</a:t>
+              <a:t>• Увеличить объёмы сертификации</a:t>
             </a:r>
           </a:p>
           <a:p>
             <a:pPr>
               <a:spcAft>
-                <a:spcPts val="1200"/>
+                <a:spcPts val="1100"/>
               </a:spcAft>
             </a:pPr>
             <a:r>
-              <a:rPr sz="1400" b="0">
+              <a:rPr sz="1300" b="0">
                 <a:solidFill>
                   <a:srgbClr val="1C2834"/>
                 </a:solidFill>
                 <a:latin typeface="Calibri"/>
               </a:rPr>
-              <a:t>• Regional Central Asia collaboration</a:t>
+              <a:t>• Региональное сотрудничество в ЦА</a:t>
             </a:r>
           </a:p>
           <a:p>
             <a:pPr>
               <a:spcAft>
-                <a:spcPts val="1200"/>
+                <a:spcPts val="1100"/>
               </a:spcAft>
             </a:pPr>
             <a:r>
-              <a:rPr sz="1400" b="0">
+              <a:rPr sz="1300" b="0">
                 <a:solidFill>
                   <a:srgbClr val="1C2834"/>
                 </a:solidFill>
                 <a:latin typeface="Calibri"/>
               </a:rPr>
-              <a:t>• Target: 100+ members</a:t>
+              <a:t>• Цель: 100+ членов</a:t>
             </a:r>
           </a:p>
         </p:txBody>
@@ -12145,7 +12145,7 @@
         <p:spPr>
           <a:xfrm>
             <a:off x="502920" y="6446520"/>
-            <a:ext cx="7315200" cy="320040"/>
+            <a:ext cx="8229600" cy="320040"/>
           </a:xfrm>
           <a:prstGeom prst="rect">
             <a:avLst/>
@@ -12166,7 +12166,7 @@
                 </a:solidFill>
                 <a:latin typeface="Calibri"/>
               </a:rPr>
-              <a:t>IPMA Kyrgyzstan  ·  Applying Member Association</a:t>
+              <a:t>IPMA Кыргызстан  ·  Ассоциация-кандидат</a:t>
             </a:r>
           </a:p>
         </p:txBody>
@@ -12340,7 +12340,7 @@
                 </a:solidFill>
                 <a:latin typeface="Calibri"/>
               </a:rPr>
-              <a:t>IPMA KYRGYZSTAN</a:t>
+              <a:t>IPMA КЫРГЫЗСТАН</a:t>
             </a:r>
           </a:p>
         </p:txBody>
@@ -12369,13 +12369,13 @@
           <a:p>
             <a:pPr algn="l"/>
             <a:r>
-              <a:rPr sz="3000" b="1">
+              <a:rPr sz="2800" b="1">
                 <a:solidFill>
                   <a:srgbClr val="0B1F33"/>
                 </a:solidFill>
                 <a:latin typeface="Georgia"/>
               </a:rPr>
-              <a:t>We will grow membership</a:t>
+              <a:t>Мы будем наращивать членство</a:t>
             </a:r>
           </a:p>
         </p:txBody>
@@ -12410,7 +12410,7 @@
                 </a:solidFill>
                 <a:latin typeface="Calibri"/>
               </a:rPr>
-              <a:t>Building the first national IPMA community in Kyrgyzstan</a:t>
+              <a:t>Создание первого национального сообщества IPMA в Кыргызстане</a:t>
             </a:r>
           </a:p>
         </p:txBody>
@@ -12424,7 +12424,7 @@
         <p:spPr>
           <a:xfrm>
             <a:off x="640080" y="1783080"/>
-            <a:ext cx="10972800" cy="822960"/>
+            <a:ext cx="10972800" cy="777240"/>
           </a:xfrm>
           <a:prstGeom prst="rect">
             <a:avLst/>
@@ -12439,33 +12439,33 @@
           <a:p>
             <a:pPr>
               <a:spcAft>
-                <a:spcPts val="600"/>
+                <a:spcPts val="500"/>
               </a:spcAft>
             </a:pPr>
             <a:r>
-              <a:rPr sz="1500" b="0">
+              <a:rPr sz="1400" b="0">
                 <a:solidFill>
                   <a:srgbClr val="1C2834"/>
                 </a:solidFill>
                 <a:latin typeface="Calibri"/>
               </a:rPr>
-              <a:t>Today there is no established IPMA Member Association serving Kyrgyzstan.</a:t>
+              <a:t>Сегодня в стране нет действующей Member Association IPMA.</a:t>
             </a:r>
           </a:p>
           <a:p>
             <a:pPr>
               <a:spcAft>
-                <a:spcPts val="600"/>
+                <a:spcPts val="500"/>
               </a:spcAft>
             </a:pPr>
             <a:r>
-              <a:rPr sz="1500" b="0">
+              <a:rPr sz="1400" b="0">
                 <a:solidFill>
                   <a:srgbClr val="1C2834"/>
                 </a:solidFill>
                 <a:latin typeface="Calibri"/>
               </a:rPr>
-              <a:t>We will open membership with clear value for professionals, employers and educators.</a:t>
+              <a:t>Мы откроем членство с понятной ценностью для специалистов, работодателей и образования.</a:t>
             </a:r>
           </a:p>
         </p:txBody>
@@ -12478,7 +12478,7 @@
         </p:nvSpPr>
         <p:spPr>
           <a:xfrm>
-            <a:off x="640080" y="2926080"/>
+            <a:off x="640080" y="2880360"/>
             <a:ext cx="5440680" cy="1234440"/>
           </a:xfrm>
           <a:prstGeom prst="roundRect">
@@ -12521,7 +12521,7 @@
         </p:nvSpPr>
         <p:spPr>
           <a:xfrm>
-            <a:off x="960120" y="3154680"/>
+            <a:off x="960120" y="3108960"/>
             <a:ext cx="4846320" cy="320040"/>
           </a:xfrm>
           <a:prstGeom prst="rect">
@@ -12537,13 +12537,13 @@
           <a:p>
             <a:pPr algn="l"/>
             <a:r>
-              <a:rPr sz="1600" b="1">
+              <a:rPr sz="1500" b="1">
                 <a:solidFill>
                   <a:srgbClr val="0B1F33"/>
                 </a:solidFill>
                 <a:latin typeface="Georgia"/>
               </a:rPr>
-              <a:t>Individual members</a:t>
+              <a:t>Индивидуальные члены</a:t>
             </a:r>
           </a:p>
         </p:txBody>
@@ -12556,7 +12556,7 @@
         </p:nvSpPr>
         <p:spPr>
           <a:xfrm>
-            <a:off x="960120" y="3566160"/>
+            <a:off x="960120" y="3520440"/>
             <a:ext cx="4846320" cy="411480"/>
           </a:xfrm>
           <a:prstGeom prst="rect">
@@ -12578,7 +12578,7 @@
                 </a:solidFill>
                 <a:latin typeface="Calibri"/>
               </a:rPr>
-              <a:t>Practitioners seeking competence, network and recognition</a:t>
+              <a:t>Практики, которым нужны компетенции, сеть и признание</a:t>
             </a:r>
           </a:p>
         </p:txBody>
@@ -12591,7 +12591,7 @@
         </p:nvSpPr>
         <p:spPr>
           <a:xfrm>
-            <a:off x="6309360" y="2926080"/>
+            <a:off x="6309360" y="2880360"/>
             <a:ext cx="5440680" cy="1234440"/>
           </a:xfrm>
           <a:prstGeom prst="roundRect">
@@ -12634,7 +12634,7 @@
         </p:nvSpPr>
         <p:spPr>
           <a:xfrm>
-            <a:off x="6629400" y="3154680"/>
+            <a:off x="6629400" y="3108960"/>
             <a:ext cx="4846320" cy="320040"/>
           </a:xfrm>
           <a:prstGeom prst="rect">
@@ -12650,13 +12650,13 @@
           <a:p>
             <a:pPr algn="l"/>
             <a:r>
-              <a:rPr sz="1600" b="1">
+              <a:rPr sz="1500" b="1">
                 <a:solidFill>
                   <a:srgbClr val="0B1F33"/>
                 </a:solidFill>
                 <a:latin typeface="Georgia"/>
               </a:rPr>
-              <a:t>Corporate members</a:t>
+              <a:t>Корпоративные члены</a:t>
             </a:r>
           </a:p>
         </p:txBody>
@@ -12669,7 +12669,7 @@
         </p:nvSpPr>
         <p:spPr>
           <a:xfrm>
-            <a:off x="6629400" y="3566160"/>
+            <a:off x="6629400" y="3520440"/>
             <a:ext cx="4846320" cy="411480"/>
           </a:xfrm>
           <a:prstGeom prst="rect">
@@ -12691,7 +12691,7 @@
                 </a:solidFill>
                 <a:latin typeface="Calibri"/>
               </a:rPr>
-              <a:t>Employers investing in project capability and standards</a:t>
+              <a:t>Работодатели, инвестирующие в стандарты и проектные способности</a:t>
             </a:r>
           </a:p>
         </p:txBody>
@@ -12704,7 +12704,7 @@
         </p:nvSpPr>
         <p:spPr>
           <a:xfrm>
-            <a:off x="640080" y="4343400"/>
+            <a:off x="640080" y="4297680"/>
             <a:ext cx="5440680" cy="1234440"/>
           </a:xfrm>
           <a:prstGeom prst="roundRect">
@@ -12747,7 +12747,7 @@
         </p:nvSpPr>
         <p:spPr>
           <a:xfrm>
-            <a:off x="960120" y="4572000"/>
+            <a:off x="960120" y="4526280"/>
             <a:ext cx="4846320" cy="320040"/>
           </a:xfrm>
           <a:prstGeom prst="rect">
@@ -12763,13 +12763,13 @@
           <a:p>
             <a:pPr algn="l"/>
             <a:r>
-              <a:rPr sz="1600" b="1">
+              <a:rPr sz="1500" b="1">
                 <a:solidFill>
                   <a:srgbClr val="0B1F33"/>
                 </a:solidFill>
                 <a:latin typeface="Georgia"/>
               </a:rPr>
-              <a:t>Education providers</a:t>
+              <a:t>Образовательные организации</a:t>
             </a:r>
           </a:p>
         </p:txBody>
@@ -12782,7 +12782,7 @@
         </p:nvSpPr>
         <p:spPr>
           <a:xfrm>
-            <a:off x="960120" y="4983480"/>
+            <a:off x="960120" y="4937760"/>
             <a:ext cx="4846320" cy="411480"/>
           </a:xfrm>
           <a:prstGeom prst="rect">
@@ -12804,7 +12804,7 @@
                 </a:solidFill>
                 <a:latin typeface="Calibri"/>
               </a:rPr>
-              <a:t>Universities embedding IPMA into programmes</a:t>
+              <a:t>Университеты, встраивающие IPMA в учебные программы</a:t>
             </a:r>
           </a:p>
         </p:txBody>
@@ -12817,7 +12817,7 @@
         </p:nvSpPr>
         <p:spPr>
           <a:xfrm>
-            <a:off x="6309360" y="4343400"/>
+            <a:off x="6309360" y="4297680"/>
             <a:ext cx="5440680" cy="1234440"/>
           </a:xfrm>
           <a:prstGeom prst="roundRect">
@@ -12860,7 +12860,7 @@
         </p:nvSpPr>
         <p:spPr>
           <a:xfrm>
-            <a:off x="6629400" y="4572000"/>
+            <a:off x="6629400" y="4526280"/>
             <a:ext cx="4846320" cy="320040"/>
           </a:xfrm>
           <a:prstGeom prst="rect">
@@ -12876,13 +12876,13 @@
           <a:p>
             <a:pPr algn="l"/>
             <a:r>
-              <a:rPr sz="1600" b="1">
+              <a:rPr sz="1500" b="1">
                 <a:solidFill>
                   <a:srgbClr val="0B1F33"/>
                 </a:solidFill>
                 <a:latin typeface="Georgia"/>
               </a:rPr>
-              <a:t>Training providers</a:t>
+              <a:t>Провайдеры обучения</a:t>
             </a:r>
           </a:p>
         </p:txBody>
@@ -12895,7 +12895,7 @@
         </p:nvSpPr>
         <p:spPr>
           <a:xfrm>
-            <a:off x="6629400" y="4983480"/>
+            <a:off x="6629400" y="4937760"/>
             <a:ext cx="4846320" cy="411480"/>
           </a:xfrm>
           <a:prstGeom prst="rect">
@@ -12917,7 +12917,7 @@
                 </a:solidFill>
                 <a:latin typeface="Calibri"/>
               </a:rPr>
-              <a:t>ATOs and partners supporting certification pathways</a:t>
+              <a:t>ATO и партнёры, поддерживающие пути сертификации</a:t>
             </a:r>
           </a:p>
         </p:txBody>
@@ -12931,7 +12931,7 @@
         <p:spPr>
           <a:xfrm>
             <a:off x="502920" y="6446520"/>
-            <a:ext cx="7315200" cy="320040"/>
+            <a:ext cx="8229600" cy="320040"/>
           </a:xfrm>
           <a:prstGeom prst="rect">
             <a:avLst/>
@@ -12952,7 +12952,7 @@
                 </a:solidFill>
                 <a:latin typeface="Calibri"/>
               </a:rPr>
-              <a:t>IPMA Kyrgyzstan  ·  Applying Member Association</a:t>
+              <a:t>IPMA Кыргызстан  ·  Ассоциация-кандидат</a:t>
             </a:r>
           </a:p>
         </p:txBody>
@@ -13126,7 +13126,7 @@
                 </a:solidFill>
                 <a:latin typeface="Calibri"/>
               </a:rPr>
-              <a:t>IPMA KYRGYZSTAN</a:t>
+              <a:t>IPMA КЫРГЫЗСТАН</a:t>
             </a:r>
           </a:p>
         </p:txBody>
@@ -13155,13 +13155,13 @@
           <a:p>
             <a:pPr algn="l"/>
             <a:r>
-              <a:rPr sz="3000" b="1">
+              <a:rPr sz="2800" b="1">
                 <a:solidFill>
                   <a:srgbClr val="0B1F33"/>
                 </a:solidFill>
                 <a:latin typeface="Georgia"/>
               </a:rPr>
-              <a:t>Co-creating our Certification Body</a:t>
+              <a:t>Совместное создание Certification Body</a:t>
             </a:r>
           </a:p>
         </p:txBody>
@@ -13196,7 +13196,7 @@
                 </a:solidFill>
                 <a:latin typeface="Calibri"/>
               </a:rPr>
-              <a:t>Quality certification rooted in collaboration with peer MAs / CBs</a:t>
+              <a:t>Качественная сертификация через сотрудничество с опытными MA / CB</a:t>
             </a:r>
           </a:p>
         </p:txBody>
@@ -13225,97 +13225,97 @@
           <a:p>
             <a:pPr>
               <a:spcAft>
-                <a:spcPts val="1400"/>
+                <a:spcPts val="1300"/>
               </a:spcAft>
             </a:pPr>
             <a:r>
-              <a:rPr sz="1600" b="0">
+              <a:rPr sz="1500" b="0">
                 <a:solidFill>
                   <a:srgbClr val="1C2834"/>
                 </a:solidFill>
                 <a:latin typeface="Calibri"/>
               </a:rPr>
-              <a:t>• Offer all 4 IPMA certification levels, with a phased start where needed</a:t>
+              <a:t>• Предложить все 4 уровня сертификации IPMA, при необходимости — поэтапный старт</a:t>
             </a:r>
           </a:p>
           <a:p>
             <a:pPr>
               <a:spcAft>
-                <a:spcPts val="1400"/>
+                <a:spcPts val="1300"/>
               </a:spcAft>
             </a:pPr>
             <a:r>
-              <a:rPr sz="1600" b="0">
+              <a:rPr sz="1500" b="0">
                 <a:solidFill>
                   <a:srgbClr val="1C2834"/>
                 </a:solidFill>
                 <a:latin typeface="Calibri"/>
               </a:rPr>
-              <a:t>• Collaborate with established MAs / CBs to harmonise process and quality</a:t>
+              <a:t>• Сотрудничать с действующими MA / CB для гармонизации процессов и качества</a:t>
             </a:r>
           </a:p>
           <a:p>
             <a:pPr>
               <a:spcAft>
-                <a:spcPts val="1400"/>
+                <a:spcPts val="1300"/>
               </a:spcAft>
             </a:pPr>
             <a:r>
-              <a:rPr sz="1600" b="0">
+              <a:rPr sz="1500" b="0">
                 <a:solidFill>
                   <a:srgbClr val="1C2834"/>
                 </a:solidFill>
                 <a:latin typeface="Calibri"/>
               </a:rPr>
-              <a:t>• Build a committed pool of assessors and share capacity regionally where appropriate</a:t>
+              <a:t>• Сформировать пул ассессоров и при необходимости делить ресурсы в регионе</a:t>
             </a:r>
           </a:p>
           <a:p>
             <a:pPr>
               <a:spcAft>
-                <a:spcPts val="1400"/>
+                <a:spcPts val="1300"/>
               </a:spcAft>
             </a:pPr>
             <a:r>
-              <a:rPr sz="1600" b="0">
+              <a:rPr sz="1500" b="0">
                 <a:solidFill>
                   <a:srgbClr val="1C2834"/>
                 </a:solidFill>
                 <a:latin typeface="Calibri"/>
               </a:rPr>
-              <a:t>• Outsource examination processing where it strengthens reliability and speed</a:t>
+              <a:t>• При необходимости аутсорсить обработку экзаменов для надёжности и скорости</a:t>
             </a:r>
           </a:p>
           <a:p>
             <a:pPr>
               <a:spcAft>
-                <a:spcPts val="1400"/>
+                <a:spcPts val="1300"/>
               </a:spcAft>
             </a:pPr>
             <a:r>
-              <a:rPr sz="1600" b="0">
+              <a:rPr sz="1500" b="0">
                 <a:solidFill>
                   <a:srgbClr val="1C2834"/>
                 </a:solidFill>
                 <a:latin typeface="Calibri"/>
               </a:rPr>
-              <a:t>• Protect candidate experience and the reputation of the IPMA brand</a:t>
+              <a:t>• Защищать опыт кандидатов и репутацию бренда IPMA</a:t>
             </a:r>
           </a:p>
           <a:p>
             <a:pPr>
               <a:spcAft>
-                <a:spcPts val="1400"/>
+                <a:spcPts val="1300"/>
               </a:spcAft>
             </a:pPr>
             <a:r>
-              <a:rPr sz="1600" b="0">
+              <a:rPr sz="1500" b="0">
                 <a:solidFill>
                   <a:srgbClr val="1C2834"/>
                 </a:solidFill>
                 <a:latin typeface="Calibri"/>
               </a:rPr>
-              <a:t>• Reinvest certification income into community development and Young Crew</a:t>
+              <a:t>• Реинвестировать доходы от сертификации в развитие сообщества и Young Crew</a:t>
             </a:r>
           </a:p>
         </p:txBody>
@@ -13329,7 +13329,7 @@
         <p:spPr>
           <a:xfrm>
             <a:off x="502920" y="6446520"/>
-            <a:ext cx="7315200" cy="320040"/>
+            <a:ext cx="8229600" cy="320040"/>
           </a:xfrm>
           <a:prstGeom prst="rect">
             <a:avLst/>
@@ -13350,7 +13350,7 @@
                 </a:solidFill>
                 <a:latin typeface="Calibri"/>
               </a:rPr>
-              <a:t>IPMA Kyrgyzstan  ·  Applying Member Association</a:t>
+              <a:t>IPMA Кыргызстан  ·  Ассоциация-кандидат</a:t>
             </a:r>
           </a:p>
         </p:txBody>

</xml_diff>

<commit_message>
Add KgPMU brand logo to CoD presentation
Include the snow leopard wordmark on title/closing slides and
the emblem mark on content slides in both HTML and PPTX.

Co-authored-by: umekishev <umekishev@users.noreply.github.com>
</commit_message>
<xml_diff>
--- a/presentations/IPMA_Kyrgyzstan_CoD_Presentation.pptx
+++ b/presentations/IPMA_Kyrgyzstan_CoD_Presentation.pptx
@@ -3185,29 +3185,53 @@
           </a:p>
         </p:txBody>
       </p:sp>
-      <p:sp>
-        <p:nvSpPr>
-          <p:cNvPr id="4" name="TextBox 3"/>
-          <p:cNvSpPr txBox="1"/>
-          <p:nvPr/>
-        </p:nvSpPr>
-        <p:spPr>
-          <a:xfrm>
-            <a:off x="731520" y="1463040"/>
-            <a:ext cx="10515600" cy="320040"/>
-          </a:xfrm>
-          <a:prstGeom prst="rect">
-            <a:avLst/>
-          </a:prstGeom>
-          <a:noFill/>
-        </p:spPr>
-        <p:txBody>
-          <a:bodyPr wrap="square">
-            <a:spAutoFit/>
-          </a:bodyPr>
-          <a:lstStyle/>
-          <a:p>
-            <a:pPr algn="l"/>
+      <p:pic>
+        <p:nvPicPr>
+          <p:cNvPr id="4" name="Picture 3" descr="kgpmu-logo-full.png"/>
+          <p:cNvPicPr>
+            <a:picLocks noChangeAspect="1"/>
+          </p:cNvPicPr>
+          <p:nvPr/>
+        </p:nvPicPr>
+        <p:blipFill>
+          <a:blip r:embed="rId2"/>
+          <a:stretch>
+            <a:fillRect/>
+          </a:stretch>
+        </p:blipFill>
+        <p:spPr>
+          <a:xfrm>
+            <a:off x="4175607" y="822960"/>
+            <a:ext cx="3840480" cy="1823761"/>
+          </a:xfrm>
+          <a:prstGeom prst="rect">
+            <a:avLst/>
+          </a:prstGeom>
+        </p:spPr>
+      </p:pic>
+      <p:sp>
+        <p:nvSpPr>
+          <p:cNvPr id="5" name="TextBox 4"/>
+          <p:cNvSpPr txBox="1"/>
+          <p:nvPr/>
+        </p:nvSpPr>
+        <p:spPr>
+          <a:xfrm>
+            <a:off x="731520" y="2606040"/>
+            <a:ext cx="10698480" cy="320040"/>
+          </a:xfrm>
+          <a:prstGeom prst="rect">
+            <a:avLst/>
+          </a:prstGeom>
+          <a:noFill/>
+        </p:spPr>
+        <p:txBody>
+          <a:bodyPr wrap="square">
+            <a:spAutoFit/>
+          </a:bodyPr>
+          <a:lstStyle/>
+          <a:p>
+            <a:pPr algn="ctr"/>
             <a:r>
               <a:rPr sz="1300" b="1">
                 <a:solidFill>
@@ -3222,29 +3246,29 @@
       </p:sp>
       <p:sp>
         <p:nvSpPr>
-          <p:cNvPr id="5" name="TextBox 4"/>
-          <p:cNvSpPr txBox="1"/>
-          <p:nvPr/>
-        </p:nvSpPr>
-        <p:spPr>
-          <a:xfrm>
-            <a:off x="731520" y="1965960"/>
-            <a:ext cx="10515600" cy="1097280"/>
-          </a:xfrm>
-          <a:prstGeom prst="rect">
-            <a:avLst/>
-          </a:prstGeom>
-          <a:noFill/>
-        </p:spPr>
-        <p:txBody>
-          <a:bodyPr wrap="square">
-            <a:spAutoFit/>
-          </a:bodyPr>
-          <a:lstStyle/>
-          <a:p>
-            <a:pPr algn="l"/>
-            <a:r>
-              <a:rPr sz="3600" b="1">
+          <p:cNvPr id="6" name="TextBox 5"/>
+          <p:cNvSpPr txBox="1"/>
+          <p:nvPr/>
+        </p:nvSpPr>
+        <p:spPr>
+          <a:xfrm>
+            <a:off x="731520" y="3017520"/>
+            <a:ext cx="10698480" cy="914400"/>
+          </a:xfrm>
+          <a:prstGeom prst="rect">
+            <a:avLst/>
+          </a:prstGeom>
+          <a:noFill/>
+        </p:spPr>
+        <p:txBody>
+          <a:bodyPr wrap="square">
+            <a:spAutoFit/>
+          </a:bodyPr>
+          <a:lstStyle/>
+          <a:p>
+            <a:pPr algn="ctr"/>
+            <a:r>
+              <a:rPr sz="3200" b="1">
                 <a:solidFill>
                   <a:srgbClr val="FFFFFF"/>
                 </a:solidFill>
@@ -3258,29 +3282,29 @@
       </p:sp>
       <p:sp>
         <p:nvSpPr>
-          <p:cNvPr id="6" name="TextBox 5"/>
-          <p:cNvSpPr txBox="1"/>
-          <p:nvPr/>
-        </p:nvSpPr>
-        <p:spPr>
-          <a:xfrm>
-            <a:off x="731520" y="3291840"/>
-            <a:ext cx="10058400" cy="457200"/>
-          </a:xfrm>
-          <a:prstGeom prst="rect">
-            <a:avLst/>
-          </a:prstGeom>
-          <a:noFill/>
-        </p:spPr>
-        <p:txBody>
-          <a:bodyPr wrap="square">
-            <a:spAutoFit/>
-          </a:bodyPr>
-          <a:lstStyle/>
-          <a:p>
-            <a:pPr algn="l"/>
-            <a:r>
-              <a:rPr sz="1600" b="0">
+          <p:cNvPr id="7" name="TextBox 6"/>
+          <p:cNvSpPr txBox="1"/>
+          <p:nvPr/>
+        </p:nvSpPr>
+        <p:spPr>
+          <a:xfrm>
+            <a:off x="731520" y="4114800"/>
+            <a:ext cx="10698480" cy="365760"/>
+          </a:xfrm>
+          <a:prstGeom prst="rect">
+            <a:avLst/>
+          </a:prstGeom>
+          <a:noFill/>
+        </p:spPr>
+        <p:txBody>
+          <a:bodyPr wrap="square">
+            <a:spAutoFit/>
+          </a:bodyPr>
+          <a:lstStyle/>
+          <a:p>
+            <a:pPr algn="ctr"/>
+            <a:r>
+              <a:rPr sz="1500" b="0">
                 <a:solidFill>
                   <a:srgbClr val="F3DCC9"/>
                 </a:solidFill>
@@ -3293,14 +3317,14 @@
       </p:sp>
       <p:sp>
         <p:nvSpPr>
-          <p:cNvPr id="7" name="Rounded Rectangle 6"/>
+          <p:cNvPr id="8" name="Rounded Rectangle 7"/>
           <p:cNvSpPr/>
           <p:nvPr/>
         </p:nvSpPr>
         <p:spPr>
           <a:xfrm>
-            <a:off x="731520" y="4023360"/>
-            <a:ext cx="9601200" cy="640080"/>
+            <a:off x="1645920" y="4709160"/>
+            <a:ext cx="8869680" cy="594360"/>
           </a:xfrm>
           <a:prstGeom prst="roundRect">
             <a:avLst/>
@@ -3336,29 +3360,29 @@
       </p:sp>
       <p:sp>
         <p:nvSpPr>
-          <p:cNvPr id="8" name="TextBox 7"/>
-          <p:cNvSpPr txBox="1"/>
-          <p:nvPr/>
-        </p:nvSpPr>
-        <p:spPr>
-          <a:xfrm>
-            <a:off x="914400" y="4160520"/>
-            <a:ext cx="9144000" cy="411480"/>
-          </a:xfrm>
-          <a:prstGeom prst="rect">
-            <a:avLst/>
-          </a:prstGeom>
-          <a:noFill/>
-        </p:spPr>
-        <p:txBody>
-          <a:bodyPr wrap="square">
-            <a:spAutoFit/>
-          </a:bodyPr>
-          <a:lstStyle/>
-          <a:p>
-            <a:pPr algn="l"/>
-            <a:r>
-              <a:rPr sz="1500" b="1">
+          <p:cNvPr id="9" name="TextBox 8"/>
+          <p:cNvSpPr txBox="1"/>
+          <p:nvPr/>
+        </p:nvSpPr>
+        <p:spPr>
+          <a:xfrm>
+            <a:off x="1828800" y="4828032"/>
+            <a:ext cx="8503920" cy="365760"/>
+          </a:xfrm>
+          <a:prstGeom prst="rect">
+            <a:avLst/>
+          </a:prstGeom>
+          <a:noFill/>
+        </p:spPr>
+        <p:txBody>
+          <a:bodyPr wrap="square">
+            <a:spAutoFit/>
+          </a:bodyPr>
+          <a:lstStyle/>
+          <a:p>
+            <a:pPr algn="ctr"/>
+            <a:r>
+              <a:rPr sz="1400" b="1">
                 <a:solidFill>
                   <a:srgbClr val="FFFFFF"/>
                 </a:solidFill>
@@ -3371,29 +3395,29 @@
       </p:sp>
       <p:sp>
         <p:nvSpPr>
-          <p:cNvPr id="9" name="TextBox 8"/>
-          <p:cNvSpPr txBox="1"/>
-          <p:nvPr/>
-        </p:nvSpPr>
-        <p:spPr>
-          <a:xfrm>
-            <a:off x="731520" y="5029200"/>
-            <a:ext cx="10058400" cy="365760"/>
-          </a:xfrm>
-          <a:prstGeom prst="rect">
-            <a:avLst/>
-          </a:prstGeom>
-          <a:noFill/>
-        </p:spPr>
-        <p:txBody>
-          <a:bodyPr wrap="square">
-            <a:spAutoFit/>
-          </a:bodyPr>
-          <a:lstStyle/>
-          <a:p>
-            <a:pPr algn="l"/>
-            <a:r>
-              <a:rPr sz="1500" b="0">
+          <p:cNvPr id="10" name="TextBox 9"/>
+          <p:cNvSpPr txBox="1"/>
+          <p:nvPr/>
+        </p:nvSpPr>
+        <p:spPr>
+          <a:xfrm>
+            <a:off x="731520" y="5532120"/>
+            <a:ext cx="10698480" cy="320040"/>
+          </a:xfrm>
+          <a:prstGeom prst="rect">
+            <a:avLst/>
+          </a:prstGeom>
+          <a:noFill/>
+        </p:spPr>
+        <p:txBody>
+          <a:bodyPr wrap="square">
+            <a:spAutoFit/>
+          </a:bodyPr>
+          <a:lstStyle/>
+          <a:p>
+            <a:pPr algn="ctr"/>
+            <a:r>
+              <a:rPr sz="1400" b="0">
                 <a:solidFill>
                   <a:srgbClr val="F3DCC9"/>
                 </a:solidFill>
@@ -3508,16 +3532,40 @@
           </a:p>
         </p:txBody>
       </p:sp>
-      <p:sp>
-        <p:nvSpPr>
-          <p:cNvPr id="4" name="TextBox 3"/>
+      <p:pic>
+        <p:nvPicPr>
+          <p:cNvPr id="4" name="Picture 3" descr="kgpmu-emblem.png"/>
+          <p:cNvPicPr>
+            <a:picLocks noChangeAspect="1"/>
+          </p:cNvPicPr>
+          <p:nvPr/>
+        </p:nvPicPr>
+        <p:blipFill>
+          <a:blip r:embed="rId2"/>
+          <a:stretch>
+            <a:fillRect/>
+          </a:stretch>
+        </p:blipFill>
+        <p:spPr>
+          <a:xfrm>
+            <a:off x="11201400" y="228600"/>
+            <a:ext cx="708894" cy="640080"/>
+          </a:xfrm>
+          <a:prstGeom prst="rect">
+            <a:avLst/>
+          </a:prstGeom>
+        </p:spPr>
+      </p:pic>
+      <p:sp>
+        <p:nvSpPr>
+          <p:cNvPr id="5" name="TextBox 4"/>
           <p:cNvSpPr txBox="1"/>
           <p:nvPr/>
         </p:nvSpPr>
         <p:spPr>
           <a:xfrm>
             <a:off x="548640" y="320040"/>
-            <a:ext cx="10972800" cy="274320"/>
+            <a:ext cx="10058400" cy="274320"/>
           </a:xfrm>
           <a:prstGeom prst="rect">
             <a:avLst/>
@@ -3545,14 +3593,14 @@
       </p:sp>
       <p:sp>
         <p:nvSpPr>
-          <p:cNvPr id="5" name="TextBox 4"/>
+          <p:cNvPr id="6" name="TextBox 5"/>
           <p:cNvSpPr txBox="1"/>
           <p:nvPr/>
         </p:nvSpPr>
         <p:spPr>
           <a:xfrm>
             <a:off x="548640" y="640080"/>
-            <a:ext cx="10972800" cy="548640"/>
+            <a:ext cx="10241280" cy="548640"/>
           </a:xfrm>
           <a:prstGeom prst="rect">
             <a:avLst/>
@@ -3580,7 +3628,7 @@
       </p:sp>
       <p:sp>
         <p:nvSpPr>
-          <p:cNvPr id="6" name="Rounded Rectangle 5"/>
+          <p:cNvPr id="7" name="Rounded Rectangle 6"/>
           <p:cNvSpPr/>
           <p:nvPr/>
         </p:nvSpPr>
@@ -3623,7 +3671,7 @@
       </p:sp>
       <p:sp>
         <p:nvSpPr>
-          <p:cNvPr id="7" name="TextBox 6"/>
+          <p:cNvPr id="8" name="TextBox 7"/>
           <p:cNvSpPr txBox="1"/>
           <p:nvPr/>
         </p:nvSpPr>
@@ -3658,7 +3706,7 @@
       </p:sp>
       <p:sp>
         <p:nvSpPr>
-          <p:cNvPr id="8" name="TextBox 7"/>
+          <p:cNvPr id="9" name="TextBox 8"/>
           <p:cNvSpPr txBox="1"/>
           <p:nvPr/>
         </p:nvSpPr>
@@ -3693,7 +3741,7 @@
       </p:sp>
       <p:sp>
         <p:nvSpPr>
-          <p:cNvPr id="9" name="Rounded Rectangle 8"/>
+          <p:cNvPr id="10" name="Rounded Rectangle 9"/>
           <p:cNvSpPr/>
           <p:nvPr/>
         </p:nvSpPr>
@@ -3736,7 +3784,7 @@
       </p:sp>
       <p:sp>
         <p:nvSpPr>
-          <p:cNvPr id="10" name="TextBox 9"/>
+          <p:cNvPr id="11" name="TextBox 10"/>
           <p:cNvSpPr txBox="1"/>
           <p:nvPr/>
         </p:nvSpPr>
@@ -3771,7 +3819,7 @@
       </p:sp>
       <p:sp>
         <p:nvSpPr>
-          <p:cNvPr id="11" name="TextBox 10"/>
+          <p:cNvPr id="12" name="TextBox 11"/>
           <p:cNvSpPr txBox="1"/>
           <p:nvPr/>
         </p:nvSpPr>
@@ -3806,7 +3854,7 @@
       </p:sp>
       <p:sp>
         <p:nvSpPr>
-          <p:cNvPr id="12" name="Rounded Rectangle 11"/>
+          <p:cNvPr id="13" name="Rounded Rectangle 12"/>
           <p:cNvSpPr/>
           <p:nvPr/>
         </p:nvSpPr>
@@ -3849,7 +3897,7 @@
       </p:sp>
       <p:sp>
         <p:nvSpPr>
-          <p:cNvPr id="13" name="TextBox 12"/>
+          <p:cNvPr id="14" name="TextBox 13"/>
           <p:cNvSpPr txBox="1"/>
           <p:nvPr/>
         </p:nvSpPr>
@@ -3884,7 +3932,7 @@
       </p:sp>
       <p:sp>
         <p:nvSpPr>
-          <p:cNvPr id="14" name="TextBox 13"/>
+          <p:cNvPr id="15" name="TextBox 14"/>
           <p:cNvSpPr txBox="1"/>
           <p:nvPr/>
         </p:nvSpPr>
@@ -3919,7 +3967,7 @@
       </p:sp>
       <p:sp>
         <p:nvSpPr>
-          <p:cNvPr id="15" name="Rounded Rectangle 14"/>
+          <p:cNvPr id="16" name="Rounded Rectangle 15"/>
           <p:cNvSpPr/>
           <p:nvPr/>
         </p:nvSpPr>
@@ -3962,7 +4010,7 @@
       </p:sp>
       <p:sp>
         <p:nvSpPr>
-          <p:cNvPr id="16" name="TextBox 15"/>
+          <p:cNvPr id="17" name="TextBox 16"/>
           <p:cNvSpPr txBox="1"/>
           <p:nvPr/>
         </p:nvSpPr>
@@ -3997,7 +4045,7 @@
       </p:sp>
       <p:sp>
         <p:nvSpPr>
-          <p:cNvPr id="17" name="TextBox 16"/>
+          <p:cNvPr id="18" name="TextBox 17"/>
           <p:cNvSpPr txBox="1"/>
           <p:nvPr/>
         </p:nvSpPr>
@@ -4032,7 +4080,7 @@
       </p:sp>
       <p:sp>
         <p:nvSpPr>
-          <p:cNvPr id="18" name="TextBox 17"/>
+          <p:cNvPr id="19" name="TextBox 18"/>
           <p:cNvSpPr txBox="1"/>
           <p:nvPr/>
         </p:nvSpPr>
@@ -4067,7 +4115,7 @@
       </p:sp>
       <p:sp>
         <p:nvSpPr>
-          <p:cNvPr id="19" name="TextBox 18"/>
+          <p:cNvPr id="20" name="TextBox 19"/>
           <p:cNvSpPr txBox="1"/>
           <p:nvPr/>
         </p:nvSpPr>
@@ -4204,16 +4252,40 @@
           </a:p>
         </p:txBody>
       </p:sp>
-      <p:sp>
-        <p:nvSpPr>
-          <p:cNvPr id="4" name="TextBox 3"/>
+      <p:pic>
+        <p:nvPicPr>
+          <p:cNvPr id="4" name="Picture 3" descr="kgpmu-emblem.png"/>
+          <p:cNvPicPr>
+            <a:picLocks noChangeAspect="1"/>
+          </p:cNvPicPr>
+          <p:nvPr/>
+        </p:nvPicPr>
+        <p:blipFill>
+          <a:blip r:embed="rId2"/>
+          <a:stretch>
+            <a:fillRect/>
+          </a:stretch>
+        </p:blipFill>
+        <p:spPr>
+          <a:xfrm>
+            <a:off x="11201400" y="228600"/>
+            <a:ext cx="708894" cy="640080"/>
+          </a:xfrm>
+          <a:prstGeom prst="rect">
+            <a:avLst/>
+          </a:prstGeom>
+        </p:spPr>
+      </p:pic>
+      <p:sp>
+        <p:nvSpPr>
+          <p:cNvPr id="5" name="TextBox 4"/>
           <p:cNvSpPr txBox="1"/>
           <p:nvPr/>
         </p:nvSpPr>
         <p:spPr>
           <a:xfrm>
             <a:off x="548640" y="320040"/>
-            <a:ext cx="10972800" cy="274320"/>
+            <a:ext cx="10058400" cy="274320"/>
           </a:xfrm>
           <a:prstGeom prst="rect">
             <a:avLst/>
@@ -4241,14 +4313,14 @@
       </p:sp>
       <p:sp>
         <p:nvSpPr>
-          <p:cNvPr id="5" name="TextBox 4"/>
+          <p:cNvPr id="6" name="TextBox 5"/>
           <p:cNvSpPr txBox="1"/>
           <p:nvPr/>
         </p:nvSpPr>
         <p:spPr>
           <a:xfrm>
             <a:off x="548640" y="640080"/>
-            <a:ext cx="10972800" cy="548640"/>
+            <a:ext cx="10241280" cy="548640"/>
           </a:xfrm>
           <a:prstGeom prst="rect">
             <a:avLst/>
@@ -4276,7 +4348,7 @@
       </p:sp>
       <p:sp>
         <p:nvSpPr>
-          <p:cNvPr id="6" name="TextBox 5"/>
+          <p:cNvPr id="7" name="TextBox 6"/>
           <p:cNvSpPr txBox="1"/>
           <p:nvPr/>
         </p:nvSpPr>
@@ -4379,7 +4451,7 @@
       </p:sp>
       <p:sp>
         <p:nvSpPr>
-          <p:cNvPr id="7" name="TextBox 6"/>
+          <p:cNvPr id="8" name="TextBox 7"/>
           <p:cNvSpPr txBox="1"/>
           <p:nvPr/>
         </p:nvSpPr>
@@ -4414,7 +4486,7 @@
       </p:sp>
       <p:sp>
         <p:nvSpPr>
-          <p:cNvPr id="8" name="TextBox 7"/>
+          <p:cNvPr id="9" name="TextBox 8"/>
           <p:cNvSpPr txBox="1"/>
           <p:nvPr/>
         </p:nvSpPr>
@@ -4551,29 +4623,53 @@
           </a:p>
         </p:txBody>
       </p:sp>
-      <p:sp>
-        <p:nvSpPr>
-          <p:cNvPr id="4" name="TextBox 3"/>
-          <p:cNvSpPr txBox="1"/>
-          <p:nvPr/>
-        </p:nvSpPr>
-        <p:spPr>
-          <a:xfrm>
-            <a:off x="731520" y="1371600"/>
-            <a:ext cx="10515600" cy="320040"/>
-          </a:xfrm>
-          <a:prstGeom prst="rect">
-            <a:avLst/>
-          </a:prstGeom>
-          <a:noFill/>
-        </p:spPr>
-        <p:txBody>
-          <a:bodyPr wrap="square">
-            <a:spAutoFit/>
-          </a:bodyPr>
-          <a:lstStyle/>
-          <a:p>
-            <a:pPr algn="l"/>
+      <p:pic>
+        <p:nvPicPr>
+          <p:cNvPr id="4" name="Picture 3" descr="kgpmu-logo-full.png"/>
+          <p:cNvPicPr>
+            <a:picLocks noChangeAspect="1"/>
+          </p:cNvPicPr>
+          <p:nvPr/>
+        </p:nvPicPr>
+        <p:blipFill>
+          <a:blip r:embed="rId2"/>
+          <a:stretch>
+            <a:fillRect/>
+          </a:stretch>
+        </p:blipFill>
+        <p:spPr>
+          <a:xfrm>
+            <a:off x="4541367" y="640080"/>
+            <a:ext cx="3108960" cy="1476378"/>
+          </a:xfrm>
+          <a:prstGeom prst="rect">
+            <a:avLst/>
+          </a:prstGeom>
+        </p:spPr>
+      </p:pic>
+      <p:sp>
+        <p:nvSpPr>
+          <p:cNvPr id="5" name="TextBox 4"/>
+          <p:cNvSpPr txBox="1"/>
+          <p:nvPr/>
+        </p:nvSpPr>
+        <p:spPr>
+          <a:xfrm>
+            <a:off x="731520" y="2286000"/>
+            <a:ext cx="10698480" cy="320040"/>
+          </a:xfrm>
+          <a:prstGeom prst="rect">
+            <a:avLst/>
+          </a:prstGeom>
+          <a:noFill/>
+        </p:spPr>
+        <p:txBody>
+          <a:bodyPr wrap="square">
+            <a:spAutoFit/>
+          </a:bodyPr>
+          <a:lstStyle/>
+          <a:p>
+            <a:pPr algn="ctr"/>
             <a:r>
               <a:rPr sz="1300" b="1">
                 <a:solidFill>
@@ -4588,29 +4684,29 @@
       </p:sp>
       <p:sp>
         <p:nvSpPr>
-          <p:cNvPr id="5" name="TextBox 4"/>
-          <p:cNvSpPr txBox="1"/>
-          <p:nvPr/>
-        </p:nvSpPr>
-        <p:spPr>
-          <a:xfrm>
-            <a:off x="731520" y="1828800"/>
-            <a:ext cx="10515600" cy="731520"/>
-          </a:xfrm>
-          <a:prstGeom prst="rect">
-            <a:avLst/>
-          </a:prstGeom>
-          <a:noFill/>
-        </p:spPr>
-        <p:txBody>
-          <a:bodyPr wrap="square">
-            <a:spAutoFit/>
-          </a:bodyPr>
-          <a:lstStyle/>
-          <a:p>
-            <a:pPr algn="l"/>
-            <a:r>
-              <a:rPr sz="3200" b="1">
+          <p:cNvPr id="6" name="TextBox 5"/>
+          <p:cNvSpPr txBox="1"/>
+          <p:nvPr/>
+        </p:nvSpPr>
+        <p:spPr>
+          <a:xfrm>
+            <a:off x="731520" y="2697480"/>
+            <a:ext cx="10698480" cy="548640"/>
+          </a:xfrm>
+          <a:prstGeom prst="rect">
+            <a:avLst/>
+          </a:prstGeom>
+          <a:noFill/>
+        </p:spPr>
+        <p:txBody>
+          <a:bodyPr wrap="square">
+            <a:spAutoFit/>
+          </a:bodyPr>
+          <a:lstStyle/>
+          <a:p>
+            <a:pPr algn="ctr"/>
+            <a:r>
+              <a:rPr sz="2800" b="1">
                 <a:solidFill>
                   <a:srgbClr val="FFFFFF"/>
                 </a:solidFill>
@@ -4623,29 +4719,29 @@
       </p:sp>
       <p:sp>
         <p:nvSpPr>
-          <p:cNvPr id="6" name="TextBox 5"/>
-          <p:cNvSpPr txBox="1"/>
-          <p:nvPr/>
-        </p:nvSpPr>
-        <p:spPr>
-          <a:xfrm>
-            <a:off x="731520" y="2651760"/>
-            <a:ext cx="10515600" cy="914400"/>
-          </a:xfrm>
-          <a:prstGeom prst="rect">
-            <a:avLst/>
-          </a:prstGeom>
-          <a:noFill/>
-        </p:spPr>
-        <p:txBody>
-          <a:bodyPr wrap="square">
-            <a:spAutoFit/>
-          </a:bodyPr>
-          <a:lstStyle/>
-          <a:p>
-            <a:pPr algn="l"/>
-            <a:r>
-              <a:rPr sz="1600" b="0">
+          <p:cNvPr id="7" name="TextBox 6"/>
+          <p:cNvSpPr txBox="1"/>
+          <p:nvPr/>
+        </p:nvSpPr>
+        <p:spPr>
+          <a:xfrm>
+            <a:off x="1371600" y="3383280"/>
+            <a:ext cx="9418320" cy="731520"/>
+          </a:xfrm>
+          <a:prstGeom prst="rect">
+            <a:avLst/>
+          </a:prstGeom>
+          <a:noFill/>
+        </p:spPr>
+        <p:txBody>
+          <a:bodyPr wrap="square">
+            <a:spAutoFit/>
+          </a:bodyPr>
+          <a:lstStyle/>
+          <a:p>
+            <a:pPr algn="ctr"/>
+            <a:r>
+              <a:rPr sz="1500" b="0">
                 <a:solidFill>
                   <a:srgbClr val="F3DCC9"/>
                 </a:solidFill>
@@ -4658,14 +4754,14 @@
       </p:sp>
       <p:sp>
         <p:nvSpPr>
-          <p:cNvPr id="7" name="Rounded Rectangle 6"/>
+          <p:cNvPr id="8" name="Rounded Rectangle 7"/>
           <p:cNvSpPr/>
           <p:nvPr/>
         </p:nvSpPr>
         <p:spPr>
           <a:xfrm>
-            <a:off x="731520" y="3840480"/>
-            <a:ext cx="10515600" cy="1828800"/>
+            <a:off x="2011680" y="4297680"/>
+            <a:ext cx="8138160" cy="1554480"/>
           </a:xfrm>
           <a:prstGeom prst="roundRect">
             <a:avLst/>
@@ -4701,29 +4797,29 @@
       </p:sp>
       <p:sp>
         <p:nvSpPr>
-          <p:cNvPr id="8" name="TextBox 7"/>
-          <p:cNvSpPr txBox="1"/>
-          <p:nvPr/>
-        </p:nvSpPr>
-        <p:spPr>
-          <a:xfrm>
-            <a:off x="1005840" y="4069080"/>
-            <a:ext cx="10058400" cy="1371600"/>
-          </a:xfrm>
-          <a:prstGeom prst="rect">
-            <a:avLst/>
-          </a:prstGeom>
-          <a:noFill/>
-        </p:spPr>
-        <p:txBody>
-          <a:bodyPr wrap="square">
-            <a:spAutoFit/>
-          </a:bodyPr>
-          <a:lstStyle/>
-          <a:p>
-            <a:pPr algn="l"/>
-            <a:r>
-              <a:rPr sz="1600" b="0">
+          <p:cNvPr id="9" name="TextBox 8"/>
+          <p:cNvSpPr txBox="1"/>
+          <p:nvPr/>
+        </p:nvSpPr>
+        <p:spPr>
+          <a:xfrm>
+            <a:off x="2286000" y="4526280"/>
+            <a:ext cx="7589520" cy="1188720"/>
+          </a:xfrm>
+          <a:prstGeom prst="rect">
+            <a:avLst/>
+          </a:prstGeom>
+          <a:noFill/>
+        </p:spPr>
+        <p:txBody>
+          <a:bodyPr wrap="square">
+            <a:spAutoFit/>
+          </a:bodyPr>
+          <a:lstStyle/>
+          <a:p>
+            <a:pPr algn="ctr"/>
+            <a:r>
+              <a:rPr sz="1500" b="0">
                 <a:solidFill>
                   <a:srgbClr val="FFFFFF"/>
                 </a:solidFill>
@@ -4738,7 +4834,7 @@
       </p:sp>
       <p:sp>
         <p:nvSpPr>
-          <p:cNvPr id="9" name="TextBox 8"/>
+          <p:cNvPr id="10" name="TextBox 9"/>
           <p:cNvSpPr txBox="1"/>
           <p:nvPr/>
         </p:nvSpPr>
@@ -4773,7 +4869,7 @@
       </p:sp>
       <p:sp>
         <p:nvSpPr>
-          <p:cNvPr id="10" name="TextBox 9"/>
+          <p:cNvPr id="11" name="TextBox 10"/>
           <p:cNvSpPr txBox="1"/>
           <p:nvPr/>
         </p:nvSpPr>
@@ -4910,16 +5006,40 @@
           </a:p>
         </p:txBody>
       </p:sp>
-      <p:sp>
-        <p:nvSpPr>
-          <p:cNvPr id="4" name="TextBox 3"/>
+      <p:pic>
+        <p:nvPicPr>
+          <p:cNvPr id="4" name="Picture 3" descr="kgpmu-emblem.png"/>
+          <p:cNvPicPr>
+            <a:picLocks noChangeAspect="1"/>
+          </p:cNvPicPr>
+          <p:nvPr/>
+        </p:nvPicPr>
+        <p:blipFill>
+          <a:blip r:embed="rId2"/>
+          <a:stretch>
+            <a:fillRect/>
+          </a:stretch>
+        </p:blipFill>
+        <p:spPr>
+          <a:xfrm>
+            <a:off x="11201400" y="228600"/>
+            <a:ext cx="708894" cy="640080"/>
+          </a:xfrm>
+          <a:prstGeom prst="rect">
+            <a:avLst/>
+          </a:prstGeom>
+        </p:spPr>
+      </p:pic>
+      <p:sp>
+        <p:nvSpPr>
+          <p:cNvPr id="5" name="TextBox 4"/>
           <p:cNvSpPr txBox="1"/>
           <p:nvPr/>
         </p:nvSpPr>
         <p:spPr>
           <a:xfrm>
             <a:off x="548640" y="320040"/>
-            <a:ext cx="10972800" cy="274320"/>
+            <a:ext cx="10058400" cy="274320"/>
           </a:xfrm>
           <a:prstGeom prst="rect">
             <a:avLst/>
@@ -4947,14 +5067,14 @@
       </p:sp>
       <p:sp>
         <p:nvSpPr>
-          <p:cNvPr id="5" name="TextBox 4"/>
+          <p:cNvPr id="6" name="TextBox 5"/>
           <p:cNvSpPr txBox="1"/>
           <p:nvPr/>
         </p:nvSpPr>
         <p:spPr>
           <a:xfrm>
             <a:off x="548640" y="640080"/>
-            <a:ext cx="10972800" cy="548640"/>
+            <a:ext cx="10241280" cy="548640"/>
           </a:xfrm>
           <a:prstGeom prst="rect">
             <a:avLst/>
@@ -4982,7 +5102,7 @@
       </p:sp>
       <p:sp>
         <p:nvSpPr>
-          <p:cNvPr id="6" name="Rounded Rectangle 5"/>
+          <p:cNvPr id="7" name="Rounded Rectangle 6"/>
           <p:cNvSpPr/>
           <p:nvPr/>
         </p:nvSpPr>
@@ -5025,7 +5145,7 @@
       </p:sp>
       <p:sp>
         <p:nvSpPr>
-          <p:cNvPr id="7" name="TextBox 6"/>
+          <p:cNvPr id="8" name="TextBox 7"/>
           <p:cNvSpPr txBox="1"/>
           <p:nvPr/>
         </p:nvSpPr>
@@ -5060,7 +5180,7 @@
       </p:sp>
       <p:sp>
         <p:nvSpPr>
-          <p:cNvPr id="8" name="TextBox 7"/>
+          <p:cNvPr id="9" name="TextBox 8"/>
           <p:cNvSpPr txBox="1"/>
           <p:nvPr/>
         </p:nvSpPr>
@@ -5131,7 +5251,7 @@
       </p:sp>
       <p:sp>
         <p:nvSpPr>
-          <p:cNvPr id="9" name="TextBox 8"/>
+          <p:cNvPr id="10" name="TextBox 9"/>
           <p:cNvSpPr txBox="1"/>
           <p:nvPr/>
         </p:nvSpPr>
@@ -5166,7 +5286,7 @@
       </p:sp>
       <p:sp>
         <p:nvSpPr>
-          <p:cNvPr id="10" name="TextBox 9"/>
+          <p:cNvPr id="11" name="TextBox 10"/>
           <p:cNvSpPr txBox="1"/>
           <p:nvPr/>
         </p:nvSpPr>
@@ -5201,7 +5321,7 @@
       </p:sp>
       <p:sp>
         <p:nvSpPr>
-          <p:cNvPr id="11" name="TextBox 10"/>
+          <p:cNvPr id="12" name="TextBox 11"/>
           <p:cNvSpPr txBox="1"/>
           <p:nvPr/>
         </p:nvSpPr>
@@ -5338,16 +5458,40 @@
           </a:p>
         </p:txBody>
       </p:sp>
-      <p:sp>
-        <p:nvSpPr>
-          <p:cNvPr id="4" name="TextBox 3"/>
+      <p:pic>
+        <p:nvPicPr>
+          <p:cNvPr id="4" name="Picture 3" descr="kgpmu-emblem.png"/>
+          <p:cNvPicPr>
+            <a:picLocks noChangeAspect="1"/>
+          </p:cNvPicPr>
+          <p:nvPr/>
+        </p:nvPicPr>
+        <p:blipFill>
+          <a:blip r:embed="rId2"/>
+          <a:stretch>
+            <a:fillRect/>
+          </a:stretch>
+        </p:blipFill>
+        <p:spPr>
+          <a:xfrm>
+            <a:off x="11201400" y="228600"/>
+            <a:ext cx="708894" cy="640080"/>
+          </a:xfrm>
+          <a:prstGeom prst="rect">
+            <a:avLst/>
+          </a:prstGeom>
+        </p:spPr>
+      </p:pic>
+      <p:sp>
+        <p:nvSpPr>
+          <p:cNvPr id="5" name="TextBox 4"/>
           <p:cNvSpPr txBox="1"/>
           <p:nvPr/>
         </p:nvSpPr>
         <p:spPr>
           <a:xfrm>
             <a:off x="548640" y="320040"/>
-            <a:ext cx="10972800" cy="274320"/>
+            <a:ext cx="10058400" cy="274320"/>
           </a:xfrm>
           <a:prstGeom prst="rect">
             <a:avLst/>
@@ -5375,14 +5519,14 @@
       </p:sp>
       <p:sp>
         <p:nvSpPr>
-          <p:cNvPr id="5" name="TextBox 4"/>
+          <p:cNvPr id="6" name="TextBox 5"/>
           <p:cNvSpPr txBox="1"/>
           <p:nvPr/>
         </p:nvSpPr>
         <p:spPr>
           <a:xfrm>
             <a:off x="548640" y="640080"/>
-            <a:ext cx="10972800" cy="548640"/>
+            <a:ext cx="10241280" cy="548640"/>
           </a:xfrm>
           <a:prstGeom prst="rect">
             <a:avLst/>
@@ -5410,7 +5554,7 @@
       </p:sp>
       <p:sp>
         <p:nvSpPr>
-          <p:cNvPr id="6" name="TextBox 5"/>
+          <p:cNvPr id="7" name="TextBox 6"/>
           <p:cNvSpPr txBox="1"/>
           <p:nvPr/>
         </p:nvSpPr>
@@ -5445,7 +5589,7 @@
       </p:sp>
       <p:sp>
         <p:nvSpPr>
-          <p:cNvPr id="7" name="Rounded Rectangle 6"/>
+          <p:cNvPr id="8" name="Rounded Rectangle 7"/>
           <p:cNvSpPr/>
           <p:nvPr/>
         </p:nvSpPr>
@@ -5488,7 +5632,7 @@
       </p:sp>
       <p:sp>
         <p:nvSpPr>
-          <p:cNvPr id="8" name="TextBox 7"/>
+          <p:cNvPr id="9" name="TextBox 8"/>
           <p:cNvSpPr txBox="1"/>
           <p:nvPr/>
         </p:nvSpPr>
@@ -5523,7 +5667,7 @@
       </p:sp>
       <p:sp>
         <p:nvSpPr>
-          <p:cNvPr id="9" name="TextBox 8"/>
+          <p:cNvPr id="10" name="TextBox 9"/>
           <p:cNvSpPr txBox="1"/>
           <p:nvPr/>
         </p:nvSpPr>
@@ -5558,7 +5702,7 @@
       </p:sp>
       <p:sp>
         <p:nvSpPr>
-          <p:cNvPr id="10" name="Rounded Rectangle 9"/>
+          <p:cNvPr id="11" name="Rounded Rectangle 10"/>
           <p:cNvSpPr/>
           <p:nvPr/>
         </p:nvSpPr>
@@ -5601,7 +5745,7 @@
       </p:sp>
       <p:sp>
         <p:nvSpPr>
-          <p:cNvPr id="11" name="TextBox 10"/>
+          <p:cNvPr id="12" name="TextBox 11"/>
           <p:cNvSpPr txBox="1"/>
           <p:nvPr/>
         </p:nvSpPr>
@@ -5636,7 +5780,7 @@
       </p:sp>
       <p:sp>
         <p:nvSpPr>
-          <p:cNvPr id="12" name="TextBox 11"/>
+          <p:cNvPr id="13" name="TextBox 12"/>
           <p:cNvSpPr txBox="1"/>
           <p:nvPr/>
         </p:nvSpPr>
@@ -5671,7 +5815,7 @@
       </p:sp>
       <p:sp>
         <p:nvSpPr>
-          <p:cNvPr id="13" name="Rounded Rectangle 12"/>
+          <p:cNvPr id="14" name="Rounded Rectangle 13"/>
           <p:cNvSpPr/>
           <p:nvPr/>
         </p:nvSpPr>
@@ -5714,7 +5858,7 @@
       </p:sp>
       <p:sp>
         <p:nvSpPr>
-          <p:cNvPr id="14" name="TextBox 13"/>
+          <p:cNvPr id="15" name="TextBox 14"/>
           <p:cNvSpPr txBox="1"/>
           <p:nvPr/>
         </p:nvSpPr>
@@ -5749,7 +5893,7 @@
       </p:sp>
       <p:sp>
         <p:nvSpPr>
-          <p:cNvPr id="15" name="TextBox 14"/>
+          <p:cNvPr id="16" name="TextBox 15"/>
           <p:cNvSpPr txBox="1"/>
           <p:nvPr/>
         </p:nvSpPr>
@@ -5784,7 +5928,7 @@
       </p:sp>
       <p:sp>
         <p:nvSpPr>
-          <p:cNvPr id="16" name="Rounded Rectangle 15"/>
+          <p:cNvPr id="17" name="Rounded Rectangle 16"/>
           <p:cNvSpPr/>
           <p:nvPr/>
         </p:nvSpPr>
@@ -5827,7 +5971,7 @@
       </p:sp>
       <p:sp>
         <p:nvSpPr>
-          <p:cNvPr id="17" name="TextBox 16"/>
+          <p:cNvPr id="18" name="TextBox 17"/>
           <p:cNvSpPr txBox="1"/>
           <p:nvPr/>
         </p:nvSpPr>
@@ -5862,7 +6006,7 @@
       </p:sp>
       <p:sp>
         <p:nvSpPr>
-          <p:cNvPr id="18" name="TextBox 17"/>
+          <p:cNvPr id="19" name="TextBox 18"/>
           <p:cNvSpPr txBox="1"/>
           <p:nvPr/>
         </p:nvSpPr>
@@ -5897,7 +6041,7 @@
       </p:sp>
       <p:sp>
         <p:nvSpPr>
-          <p:cNvPr id="19" name="TextBox 18"/>
+          <p:cNvPr id="20" name="TextBox 19"/>
           <p:cNvSpPr txBox="1"/>
           <p:nvPr/>
         </p:nvSpPr>
@@ -5932,7 +6076,7 @@
       </p:sp>
       <p:sp>
         <p:nvSpPr>
-          <p:cNvPr id="20" name="TextBox 19"/>
+          <p:cNvPr id="21" name="TextBox 20"/>
           <p:cNvSpPr txBox="1"/>
           <p:nvPr/>
         </p:nvSpPr>
@@ -6069,16 +6213,40 @@
           </a:p>
         </p:txBody>
       </p:sp>
-      <p:sp>
-        <p:nvSpPr>
-          <p:cNvPr id="4" name="TextBox 3"/>
+      <p:pic>
+        <p:nvPicPr>
+          <p:cNvPr id="4" name="Picture 3" descr="kgpmu-emblem.png"/>
+          <p:cNvPicPr>
+            <a:picLocks noChangeAspect="1"/>
+          </p:cNvPicPr>
+          <p:nvPr/>
+        </p:nvPicPr>
+        <p:blipFill>
+          <a:blip r:embed="rId2"/>
+          <a:stretch>
+            <a:fillRect/>
+          </a:stretch>
+        </p:blipFill>
+        <p:spPr>
+          <a:xfrm>
+            <a:off x="11201400" y="228600"/>
+            <a:ext cx="708894" cy="640080"/>
+          </a:xfrm>
+          <a:prstGeom prst="rect">
+            <a:avLst/>
+          </a:prstGeom>
+        </p:spPr>
+      </p:pic>
+      <p:sp>
+        <p:nvSpPr>
+          <p:cNvPr id="5" name="TextBox 4"/>
           <p:cNvSpPr txBox="1"/>
           <p:nvPr/>
         </p:nvSpPr>
         <p:spPr>
           <a:xfrm>
             <a:off x="548640" y="320040"/>
-            <a:ext cx="10972800" cy="274320"/>
+            <a:ext cx="10058400" cy="274320"/>
           </a:xfrm>
           <a:prstGeom prst="rect">
             <a:avLst/>
@@ -6106,14 +6274,14 @@
       </p:sp>
       <p:sp>
         <p:nvSpPr>
-          <p:cNvPr id="5" name="TextBox 4"/>
+          <p:cNvPr id="6" name="TextBox 5"/>
           <p:cNvSpPr txBox="1"/>
           <p:nvPr/>
         </p:nvSpPr>
         <p:spPr>
           <a:xfrm>
             <a:off x="548640" y="640080"/>
-            <a:ext cx="10972800" cy="548640"/>
+            <a:ext cx="10241280" cy="548640"/>
           </a:xfrm>
           <a:prstGeom prst="rect">
             <a:avLst/>
@@ -6141,7 +6309,7 @@
       </p:sp>
       <p:sp>
         <p:nvSpPr>
-          <p:cNvPr id="6" name="Rounded Rectangle 5"/>
+          <p:cNvPr id="7" name="Rounded Rectangle 6"/>
           <p:cNvSpPr/>
           <p:nvPr/>
         </p:nvSpPr>
@@ -6184,7 +6352,7 @@
       </p:sp>
       <p:sp>
         <p:nvSpPr>
-          <p:cNvPr id="7" name="TextBox 6"/>
+          <p:cNvPr id="8" name="TextBox 7"/>
           <p:cNvSpPr txBox="1"/>
           <p:nvPr/>
         </p:nvSpPr>
@@ -6219,7 +6387,7 @@
       </p:sp>
       <p:sp>
         <p:nvSpPr>
-          <p:cNvPr id="8" name="TextBox 7"/>
+          <p:cNvPr id="9" name="TextBox 8"/>
           <p:cNvSpPr txBox="1"/>
           <p:nvPr/>
         </p:nvSpPr>
@@ -6254,7 +6422,7 @@
       </p:sp>
       <p:sp>
         <p:nvSpPr>
-          <p:cNvPr id="9" name="Rounded Rectangle 8"/>
+          <p:cNvPr id="10" name="Rounded Rectangle 9"/>
           <p:cNvSpPr/>
           <p:nvPr/>
         </p:nvSpPr>
@@ -6297,7 +6465,7 @@
       </p:sp>
       <p:sp>
         <p:nvSpPr>
-          <p:cNvPr id="10" name="TextBox 9"/>
+          <p:cNvPr id="11" name="TextBox 10"/>
           <p:cNvSpPr txBox="1"/>
           <p:nvPr/>
         </p:nvSpPr>
@@ -6332,7 +6500,7 @@
       </p:sp>
       <p:sp>
         <p:nvSpPr>
-          <p:cNvPr id="11" name="TextBox 10"/>
+          <p:cNvPr id="12" name="TextBox 11"/>
           <p:cNvSpPr txBox="1"/>
           <p:nvPr/>
         </p:nvSpPr>
@@ -6367,7 +6535,7 @@
       </p:sp>
       <p:sp>
         <p:nvSpPr>
-          <p:cNvPr id="12" name="Rounded Rectangle 11"/>
+          <p:cNvPr id="13" name="Rounded Rectangle 12"/>
           <p:cNvSpPr/>
           <p:nvPr/>
         </p:nvSpPr>
@@ -6410,7 +6578,7 @@
       </p:sp>
       <p:sp>
         <p:nvSpPr>
-          <p:cNvPr id="13" name="TextBox 12"/>
+          <p:cNvPr id="14" name="TextBox 13"/>
           <p:cNvSpPr txBox="1"/>
           <p:nvPr/>
         </p:nvSpPr>
@@ -6445,7 +6613,7 @@
       </p:sp>
       <p:sp>
         <p:nvSpPr>
-          <p:cNvPr id="14" name="TextBox 13"/>
+          <p:cNvPr id="15" name="TextBox 14"/>
           <p:cNvSpPr txBox="1"/>
           <p:nvPr/>
         </p:nvSpPr>
@@ -6480,7 +6648,7 @@
       </p:sp>
       <p:sp>
         <p:nvSpPr>
-          <p:cNvPr id="15" name="Rounded Rectangle 14"/>
+          <p:cNvPr id="16" name="Rounded Rectangle 15"/>
           <p:cNvSpPr/>
           <p:nvPr/>
         </p:nvSpPr>
@@ -6523,7 +6691,7 @@
       </p:sp>
       <p:sp>
         <p:nvSpPr>
-          <p:cNvPr id="16" name="TextBox 15"/>
+          <p:cNvPr id="17" name="TextBox 16"/>
           <p:cNvSpPr txBox="1"/>
           <p:nvPr/>
         </p:nvSpPr>
@@ -6558,7 +6726,7 @@
       </p:sp>
       <p:sp>
         <p:nvSpPr>
-          <p:cNvPr id="17" name="TextBox 16"/>
+          <p:cNvPr id="18" name="TextBox 17"/>
           <p:cNvSpPr txBox="1"/>
           <p:nvPr/>
         </p:nvSpPr>
@@ -6593,7 +6761,7 @@
       </p:sp>
       <p:sp>
         <p:nvSpPr>
-          <p:cNvPr id="18" name="TextBox 17"/>
+          <p:cNvPr id="19" name="TextBox 18"/>
           <p:cNvSpPr txBox="1"/>
           <p:nvPr/>
         </p:nvSpPr>
@@ -6664,7 +6832,7 @@
       </p:sp>
       <p:sp>
         <p:nvSpPr>
-          <p:cNvPr id="19" name="TextBox 18"/>
+          <p:cNvPr id="20" name="TextBox 19"/>
           <p:cNvSpPr txBox="1"/>
           <p:nvPr/>
         </p:nvSpPr>
@@ -6699,7 +6867,7 @@
       </p:sp>
       <p:sp>
         <p:nvSpPr>
-          <p:cNvPr id="20" name="TextBox 19"/>
+          <p:cNvPr id="21" name="TextBox 20"/>
           <p:cNvSpPr txBox="1"/>
           <p:nvPr/>
         </p:nvSpPr>
@@ -6836,16 +7004,40 @@
           </a:p>
         </p:txBody>
       </p:sp>
-      <p:sp>
-        <p:nvSpPr>
-          <p:cNvPr id="4" name="TextBox 3"/>
+      <p:pic>
+        <p:nvPicPr>
+          <p:cNvPr id="4" name="Picture 3" descr="kgpmu-emblem.png"/>
+          <p:cNvPicPr>
+            <a:picLocks noChangeAspect="1"/>
+          </p:cNvPicPr>
+          <p:nvPr/>
+        </p:nvPicPr>
+        <p:blipFill>
+          <a:blip r:embed="rId2"/>
+          <a:stretch>
+            <a:fillRect/>
+          </a:stretch>
+        </p:blipFill>
+        <p:spPr>
+          <a:xfrm>
+            <a:off x="11201400" y="228600"/>
+            <a:ext cx="708894" cy="640080"/>
+          </a:xfrm>
+          <a:prstGeom prst="rect">
+            <a:avLst/>
+          </a:prstGeom>
+        </p:spPr>
+      </p:pic>
+      <p:sp>
+        <p:nvSpPr>
+          <p:cNvPr id="5" name="TextBox 4"/>
           <p:cNvSpPr txBox="1"/>
           <p:nvPr/>
         </p:nvSpPr>
         <p:spPr>
           <a:xfrm>
             <a:off x="548640" y="320040"/>
-            <a:ext cx="10972800" cy="274320"/>
+            <a:ext cx="10058400" cy="274320"/>
           </a:xfrm>
           <a:prstGeom prst="rect">
             <a:avLst/>
@@ -6873,14 +7065,14 @@
       </p:sp>
       <p:sp>
         <p:nvSpPr>
-          <p:cNvPr id="5" name="TextBox 4"/>
+          <p:cNvPr id="6" name="TextBox 5"/>
           <p:cNvSpPr txBox="1"/>
           <p:nvPr/>
         </p:nvSpPr>
         <p:spPr>
           <a:xfrm>
             <a:off x="548640" y="640080"/>
-            <a:ext cx="10972800" cy="548640"/>
+            <a:ext cx="10241280" cy="548640"/>
           </a:xfrm>
           <a:prstGeom prst="rect">
             <a:avLst/>
@@ -6908,7 +7100,7 @@
       </p:sp>
       <p:sp>
         <p:nvSpPr>
-          <p:cNvPr id="6" name="TextBox 5"/>
+          <p:cNvPr id="7" name="TextBox 6"/>
           <p:cNvSpPr txBox="1"/>
           <p:nvPr/>
         </p:nvSpPr>
@@ -6943,7 +7135,7 @@
       </p:sp>
       <p:sp>
         <p:nvSpPr>
-          <p:cNvPr id="7" name="Rounded Rectangle 6"/>
+          <p:cNvPr id="8" name="Rounded Rectangle 7"/>
           <p:cNvSpPr/>
           <p:nvPr/>
         </p:nvSpPr>
@@ -6986,7 +7178,7 @@
       </p:sp>
       <p:sp>
         <p:nvSpPr>
-          <p:cNvPr id="8" name="TextBox 7"/>
+          <p:cNvPr id="9" name="TextBox 8"/>
           <p:cNvSpPr txBox="1"/>
           <p:nvPr/>
         </p:nvSpPr>
@@ -7021,7 +7213,7 @@
       </p:sp>
       <p:sp>
         <p:nvSpPr>
-          <p:cNvPr id="9" name="TextBox 8"/>
+          <p:cNvPr id="10" name="TextBox 9"/>
           <p:cNvSpPr txBox="1"/>
           <p:nvPr/>
         </p:nvSpPr>
@@ -7056,7 +7248,7 @@
       </p:sp>
       <p:sp>
         <p:nvSpPr>
-          <p:cNvPr id="10" name="TextBox 9"/>
+          <p:cNvPr id="11" name="TextBox 10"/>
           <p:cNvSpPr txBox="1"/>
           <p:nvPr/>
         </p:nvSpPr>
@@ -7193,16 +7385,40 @@
           </a:p>
         </p:txBody>
       </p:sp>
-      <p:sp>
-        <p:nvSpPr>
-          <p:cNvPr id="4" name="TextBox 3"/>
+      <p:pic>
+        <p:nvPicPr>
+          <p:cNvPr id="4" name="Picture 3" descr="kgpmu-emblem.png"/>
+          <p:cNvPicPr>
+            <a:picLocks noChangeAspect="1"/>
+          </p:cNvPicPr>
+          <p:nvPr/>
+        </p:nvPicPr>
+        <p:blipFill>
+          <a:blip r:embed="rId2"/>
+          <a:stretch>
+            <a:fillRect/>
+          </a:stretch>
+        </p:blipFill>
+        <p:spPr>
+          <a:xfrm>
+            <a:off x="11201400" y="228600"/>
+            <a:ext cx="708894" cy="640080"/>
+          </a:xfrm>
+          <a:prstGeom prst="rect">
+            <a:avLst/>
+          </a:prstGeom>
+        </p:spPr>
+      </p:pic>
+      <p:sp>
+        <p:nvSpPr>
+          <p:cNvPr id="5" name="TextBox 4"/>
           <p:cNvSpPr txBox="1"/>
           <p:nvPr/>
         </p:nvSpPr>
         <p:spPr>
           <a:xfrm>
             <a:off x="548640" y="320040"/>
-            <a:ext cx="10972800" cy="274320"/>
+            <a:ext cx="10058400" cy="274320"/>
           </a:xfrm>
           <a:prstGeom prst="rect">
             <a:avLst/>
@@ -7230,14 +7446,14 @@
       </p:sp>
       <p:sp>
         <p:nvSpPr>
-          <p:cNvPr id="5" name="TextBox 4"/>
+          <p:cNvPr id="6" name="TextBox 5"/>
           <p:cNvSpPr txBox="1"/>
           <p:nvPr/>
         </p:nvSpPr>
         <p:spPr>
           <a:xfrm>
             <a:off x="548640" y="640080"/>
-            <a:ext cx="10972800" cy="548640"/>
+            <a:ext cx="10241280" cy="548640"/>
           </a:xfrm>
           <a:prstGeom prst="rect">
             <a:avLst/>
@@ -7265,7 +7481,7 @@
       </p:sp>
       <p:sp>
         <p:nvSpPr>
-          <p:cNvPr id="6" name="Rounded Rectangle 5"/>
+          <p:cNvPr id="7" name="Rounded Rectangle 6"/>
           <p:cNvSpPr/>
           <p:nvPr/>
         </p:nvSpPr>
@@ -7308,7 +7524,7 @@
       </p:sp>
       <p:sp>
         <p:nvSpPr>
-          <p:cNvPr id="7" name="TextBox 6"/>
+          <p:cNvPr id="8" name="TextBox 7"/>
           <p:cNvSpPr txBox="1"/>
           <p:nvPr/>
         </p:nvSpPr>
@@ -7343,7 +7559,7 @@
       </p:sp>
       <p:sp>
         <p:nvSpPr>
-          <p:cNvPr id="8" name="TextBox 7"/>
+          <p:cNvPr id="9" name="TextBox 8"/>
           <p:cNvSpPr txBox="1"/>
           <p:nvPr/>
         </p:nvSpPr>
@@ -7378,7 +7594,7 @@
       </p:sp>
       <p:sp>
         <p:nvSpPr>
-          <p:cNvPr id="9" name="Rounded Rectangle 8"/>
+          <p:cNvPr id="10" name="Rounded Rectangle 9"/>
           <p:cNvSpPr/>
           <p:nvPr/>
         </p:nvSpPr>
@@ -7421,7 +7637,7 @@
       </p:sp>
       <p:sp>
         <p:nvSpPr>
-          <p:cNvPr id="10" name="TextBox 9"/>
+          <p:cNvPr id="11" name="TextBox 10"/>
           <p:cNvSpPr txBox="1"/>
           <p:nvPr/>
         </p:nvSpPr>
@@ -7456,7 +7672,7 @@
       </p:sp>
       <p:sp>
         <p:nvSpPr>
-          <p:cNvPr id="11" name="TextBox 10"/>
+          <p:cNvPr id="12" name="TextBox 11"/>
           <p:cNvSpPr txBox="1"/>
           <p:nvPr/>
         </p:nvSpPr>
@@ -7491,7 +7707,7 @@
       </p:sp>
       <p:sp>
         <p:nvSpPr>
-          <p:cNvPr id="12" name="Rounded Rectangle 11"/>
+          <p:cNvPr id="13" name="Rounded Rectangle 12"/>
           <p:cNvSpPr/>
           <p:nvPr/>
         </p:nvSpPr>
@@ -7534,7 +7750,7 @@
       </p:sp>
       <p:sp>
         <p:nvSpPr>
-          <p:cNvPr id="13" name="TextBox 12"/>
+          <p:cNvPr id="14" name="TextBox 13"/>
           <p:cNvSpPr txBox="1"/>
           <p:nvPr/>
         </p:nvSpPr>
@@ -7569,7 +7785,7 @@
       </p:sp>
       <p:sp>
         <p:nvSpPr>
-          <p:cNvPr id="14" name="TextBox 13"/>
+          <p:cNvPr id="15" name="TextBox 14"/>
           <p:cNvSpPr txBox="1"/>
           <p:nvPr/>
         </p:nvSpPr>
@@ -7604,7 +7820,7 @@
       </p:sp>
       <p:sp>
         <p:nvSpPr>
-          <p:cNvPr id="15" name="Rounded Rectangle 14"/>
+          <p:cNvPr id="16" name="Rounded Rectangle 15"/>
           <p:cNvSpPr/>
           <p:nvPr/>
         </p:nvSpPr>
@@ -7647,7 +7863,7 @@
       </p:sp>
       <p:sp>
         <p:nvSpPr>
-          <p:cNvPr id="16" name="TextBox 15"/>
+          <p:cNvPr id="17" name="TextBox 16"/>
           <p:cNvSpPr txBox="1"/>
           <p:nvPr/>
         </p:nvSpPr>
@@ -7682,7 +7898,7 @@
       </p:sp>
       <p:sp>
         <p:nvSpPr>
-          <p:cNvPr id="17" name="TextBox 16"/>
+          <p:cNvPr id="18" name="TextBox 17"/>
           <p:cNvSpPr txBox="1"/>
           <p:nvPr/>
         </p:nvSpPr>
@@ -7717,7 +7933,7 @@
       </p:sp>
       <p:sp>
         <p:nvSpPr>
-          <p:cNvPr id="18" name="TextBox 17"/>
+          <p:cNvPr id="19" name="TextBox 18"/>
           <p:cNvSpPr txBox="1"/>
           <p:nvPr/>
         </p:nvSpPr>
@@ -7752,7 +7968,7 @@
       </p:sp>
       <p:sp>
         <p:nvSpPr>
-          <p:cNvPr id="19" name="TextBox 18"/>
+          <p:cNvPr id="20" name="TextBox 19"/>
           <p:cNvSpPr txBox="1"/>
           <p:nvPr/>
         </p:nvSpPr>
@@ -7889,16 +8105,40 @@
           </a:p>
         </p:txBody>
       </p:sp>
-      <p:sp>
-        <p:nvSpPr>
-          <p:cNvPr id="4" name="TextBox 3"/>
+      <p:pic>
+        <p:nvPicPr>
+          <p:cNvPr id="4" name="Picture 3" descr="kgpmu-emblem.png"/>
+          <p:cNvPicPr>
+            <a:picLocks noChangeAspect="1"/>
+          </p:cNvPicPr>
+          <p:nvPr/>
+        </p:nvPicPr>
+        <p:blipFill>
+          <a:blip r:embed="rId2"/>
+          <a:stretch>
+            <a:fillRect/>
+          </a:stretch>
+        </p:blipFill>
+        <p:spPr>
+          <a:xfrm>
+            <a:off x="11201400" y="228600"/>
+            <a:ext cx="708894" cy="640080"/>
+          </a:xfrm>
+          <a:prstGeom prst="rect">
+            <a:avLst/>
+          </a:prstGeom>
+        </p:spPr>
+      </p:pic>
+      <p:sp>
+        <p:nvSpPr>
+          <p:cNvPr id="5" name="TextBox 4"/>
           <p:cNvSpPr txBox="1"/>
           <p:nvPr/>
         </p:nvSpPr>
         <p:spPr>
           <a:xfrm>
             <a:off x="548640" y="320040"/>
-            <a:ext cx="10972800" cy="274320"/>
+            <a:ext cx="10058400" cy="274320"/>
           </a:xfrm>
           <a:prstGeom prst="rect">
             <a:avLst/>
@@ -7926,14 +8166,14 @@
       </p:sp>
       <p:sp>
         <p:nvSpPr>
-          <p:cNvPr id="5" name="TextBox 4"/>
+          <p:cNvPr id="6" name="TextBox 5"/>
           <p:cNvSpPr txBox="1"/>
           <p:nvPr/>
         </p:nvSpPr>
         <p:spPr>
           <a:xfrm>
             <a:off x="548640" y="640080"/>
-            <a:ext cx="10972800" cy="548640"/>
+            <a:ext cx="10241280" cy="548640"/>
           </a:xfrm>
           <a:prstGeom prst="rect">
             <a:avLst/>
@@ -7961,7 +8201,7 @@
       </p:sp>
       <p:sp>
         <p:nvSpPr>
-          <p:cNvPr id="6" name="TextBox 5"/>
+          <p:cNvPr id="7" name="TextBox 6"/>
           <p:cNvSpPr txBox="1"/>
           <p:nvPr/>
         </p:nvSpPr>
@@ -8096,7 +8336,7 @@
       </p:sp>
       <p:sp>
         <p:nvSpPr>
-          <p:cNvPr id="7" name="TextBox 6"/>
+          <p:cNvPr id="8" name="TextBox 7"/>
           <p:cNvSpPr txBox="1"/>
           <p:nvPr/>
         </p:nvSpPr>
@@ -8131,7 +8371,7 @@
       </p:sp>
       <p:sp>
         <p:nvSpPr>
-          <p:cNvPr id="8" name="TextBox 7"/>
+          <p:cNvPr id="9" name="TextBox 8"/>
           <p:cNvSpPr txBox="1"/>
           <p:nvPr/>
         </p:nvSpPr>
@@ -8268,16 +8508,40 @@
           </a:p>
         </p:txBody>
       </p:sp>
-      <p:sp>
-        <p:nvSpPr>
-          <p:cNvPr id="4" name="TextBox 3"/>
+      <p:pic>
+        <p:nvPicPr>
+          <p:cNvPr id="4" name="Picture 3" descr="kgpmu-emblem.png"/>
+          <p:cNvPicPr>
+            <a:picLocks noChangeAspect="1"/>
+          </p:cNvPicPr>
+          <p:nvPr/>
+        </p:nvPicPr>
+        <p:blipFill>
+          <a:blip r:embed="rId2"/>
+          <a:stretch>
+            <a:fillRect/>
+          </a:stretch>
+        </p:blipFill>
+        <p:spPr>
+          <a:xfrm>
+            <a:off x="11201400" y="228600"/>
+            <a:ext cx="708894" cy="640080"/>
+          </a:xfrm>
+          <a:prstGeom prst="rect">
+            <a:avLst/>
+          </a:prstGeom>
+        </p:spPr>
+      </p:pic>
+      <p:sp>
+        <p:nvSpPr>
+          <p:cNvPr id="5" name="TextBox 4"/>
           <p:cNvSpPr txBox="1"/>
           <p:nvPr/>
         </p:nvSpPr>
         <p:spPr>
           <a:xfrm>
             <a:off x="548640" y="320040"/>
-            <a:ext cx="10972800" cy="274320"/>
+            <a:ext cx="10058400" cy="274320"/>
           </a:xfrm>
           <a:prstGeom prst="rect">
             <a:avLst/>
@@ -8305,14 +8569,14 @@
       </p:sp>
       <p:sp>
         <p:nvSpPr>
-          <p:cNvPr id="5" name="TextBox 4"/>
+          <p:cNvPr id="6" name="TextBox 5"/>
           <p:cNvSpPr txBox="1"/>
           <p:nvPr/>
         </p:nvSpPr>
         <p:spPr>
           <a:xfrm>
             <a:off x="548640" y="640080"/>
-            <a:ext cx="10972800" cy="548640"/>
+            <a:ext cx="10241280" cy="548640"/>
           </a:xfrm>
           <a:prstGeom prst="rect">
             <a:avLst/>
@@ -8340,7 +8604,7 @@
       </p:sp>
       <p:sp>
         <p:nvSpPr>
-          <p:cNvPr id="6" name="TextBox 5"/>
+          <p:cNvPr id="7" name="TextBox 6"/>
           <p:cNvSpPr txBox="1"/>
           <p:nvPr/>
         </p:nvSpPr>
@@ -8375,7 +8639,7 @@
       </p:sp>
       <p:sp>
         <p:nvSpPr>
-          <p:cNvPr id="7" name="Rounded Rectangle 6"/>
+          <p:cNvPr id="8" name="Rounded Rectangle 7"/>
           <p:cNvSpPr/>
           <p:nvPr/>
         </p:nvSpPr>
@@ -8418,7 +8682,7 @@
       </p:sp>
       <p:sp>
         <p:nvSpPr>
-          <p:cNvPr id="8" name="TextBox 7"/>
+          <p:cNvPr id="9" name="TextBox 8"/>
           <p:cNvSpPr txBox="1"/>
           <p:nvPr/>
         </p:nvSpPr>
@@ -8453,7 +8717,7 @@
       </p:sp>
       <p:sp>
         <p:nvSpPr>
-          <p:cNvPr id="9" name="TextBox 8"/>
+          <p:cNvPr id="10" name="TextBox 9"/>
           <p:cNvSpPr txBox="1"/>
           <p:nvPr/>
         </p:nvSpPr>
@@ -8488,7 +8752,7 @@
       </p:sp>
       <p:sp>
         <p:nvSpPr>
-          <p:cNvPr id="10" name="Rounded Rectangle 9"/>
+          <p:cNvPr id="11" name="Rounded Rectangle 10"/>
           <p:cNvSpPr/>
           <p:nvPr/>
         </p:nvSpPr>
@@ -8531,7 +8795,7 @@
       </p:sp>
       <p:sp>
         <p:nvSpPr>
-          <p:cNvPr id="11" name="TextBox 10"/>
+          <p:cNvPr id="12" name="TextBox 11"/>
           <p:cNvSpPr txBox="1"/>
           <p:nvPr/>
         </p:nvSpPr>
@@ -8566,7 +8830,7 @@
       </p:sp>
       <p:sp>
         <p:nvSpPr>
-          <p:cNvPr id="12" name="TextBox 11"/>
+          <p:cNvPr id="13" name="TextBox 12"/>
           <p:cNvSpPr txBox="1"/>
           <p:nvPr/>
         </p:nvSpPr>
@@ -8601,7 +8865,7 @@
       </p:sp>
       <p:sp>
         <p:nvSpPr>
-          <p:cNvPr id="13" name="Rounded Rectangle 12"/>
+          <p:cNvPr id="14" name="Rounded Rectangle 13"/>
           <p:cNvSpPr/>
           <p:nvPr/>
         </p:nvSpPr>
@@ -8644,7 +8908,7 @@
       </p:sp>
       <p:sp>
         <p:nvSpPr>
-          <p:cNvPr id="14" name="TextBox 13"/>
+          <p:cNvPr id="15" name="TextBox 14"/>
           <p:cNvSpPr txBox="1"/>
           <p:nvPr/>
         </p:nvSpPr>
@@ -8679,7 +8943,7 @@
       </p:sp>
       <p:sp>
         <p:nvSpPr>
-          <p:cNvPr id="15" name="TextBox 14"/>
+          <p:cNvPr id="16" name="TextBox 15"/>
           <p:cNvSpPr txBox="1"/>
           <p:nvPr/>
         </p:nvSpPr>
@@ -8714,7 +8978,7 @@
       </p:sp>
       <p:sp>
         <p:nvSpPr>
-          <p:cNvPr id="16" name="Rounded Rectangle 15"/>
+          <p:cNvPr id="17" name="Rounded Rectangle 16"/>
           <p:cNvSpPr/>
           <p:nvPr/>
         </p:nvSpPr>
@@ -8757,7 +9021,7 @@
       </p:sp>
       <p:sp>
         <p:nvSpPr>
-          <p:cNvPr id="17" name="TextBox 16"/>
+          <p:cNvPr id="18" name="TextBox 17"/>
           <p:cNvSpPr txBox="1"/>
           <p:nvPr/>
         </p:nvSpPr>
@@ -8792,7 +9056,7 @@
       </p:sp>
       <p:sp>
         <p:nvSpPr>
-          <p:cNvPr id="18" name="TextBox 17"/>
+          <p:cNvPr id="19" name="TextBox 18"/>
           <p:cNvSpPr txBox="1"/>
           <p:nvPr/>
         </p:nvSpPr>
@@ -8827,7 +9091,7 @@
       </p:sp>
       <p:sp>
         <p:nvSpPr>
-          <p:cNvPr id="19" name="TextBox 18"/>
+          <p:cNvPr id="20" name="TextBox 19"/>
           <p:cNvSpPr txBox="1"/>
           <p:nvPr/>
         </p:nvSpPr>
@@ -8862,7 +9126,7 @@
       </p:sp>
       <p:sp>
         <p:nvSpPr>
-          <p:cNvPr id="20" name="TextBox 19"/>
+          <p:cNvPr id="21" name="TextBox 20"/>
           <p:cNvSpPr txBox="1"/>
           <p:nvPr/>
         </p:nvSpPr>
@@ -8999,16 +9263,40 @@
           </a:p>
         </p:txBody>
       </p:sp>
-      <p:sp>
-        <p:nvSpPr>
-          <p:cNvPr id="4" name="TextBox 3"/>
+      <p:pic>
+        <p:nvPicPr>
+          <p:cNvPr id="4" name="Picture 3" descr="kgpmu-emblem.png"/>
+          <p:cNvPicPr>
+            <a:picLocks noChangeAspect="1"/>
+          </p:cNvPicPr>
+          <p:nvPr/>
+        </p:nvPicPr>
+        <p:blipFill>
+          <a:blip r:embed="rId2"/>
+          <a:stretch>
+            <a:fillRect/>
+          </a:stretch>
+        </p:blipFill>
+        <p:spPr>
+          <a:xfrm>
+            <a:off x="11201400" y="228600"/>
+            <a:ext cx="708894" cy="640080"/>
+          </a:xfrm>
+          <a:prstGeom prst="rect">
+            <a:avLst/>
+          </a:prstGeom>
+        </p:spPr>
+      </p:pic>
+      <p:sp>
+        <p:nvSpPr>
+          <p:cNvPr id="5" name="TextBox 4"/>
           <p:cNvSpPr txBox="1"/>
           <p:nvPr/>
         </p:nvSpPr>
         <p:spPr>
           <a:xfrm>
             <a:off x="548640" y="320040"/>
-            <a:ext cx="10972800" cy="274320"/>
+            <a:ext cx="10058400" cy="274320"/>
           </a:xfrm>
           <a:prstGeom prst="rect">
             <a:avLst/>
@@ -9036,14 +9324,14 @@
       </p:sp>
       <p:sp>
         <p:nvSpPr>
-          <p:cNvPr id="5" name="TextBox 4"/>
+          <p:cNvPr id="6" name="TextBox 5"/>
           <p:cNvSpPr txBox="1"/>
           <p:nvPr/>
         </p:nvSpPr>
         <p:spPr>
           <a:xfrm>
             <a:off x="548640" y="640080"/>
-            <a:ext cx="10972800" cy="548640"/>
+            <a:ext cx="10241280" cy="548640"/>
           </a:xfrm>
           <a:prstGeom prst="rect">
             <a:avLst/>
@@ -9071,7 +9359,7 @@
       </p:sp>
       <p:sp>
         <p:nvSpPr>
-          <p:cNvPr id="6" name="Rounded Rectangle 5"/>
+          <p:cNvPr id="7" name="Rounded Rectangle 6"/>
           <p:cNvSpPr/>
           <p:nvPr/>
         </p:nvSpPr>
@@ -9114,7 +9402,7 @@
       </p:sp>
       <p:sp>
         <p:nvSpPr>
-          <p:cNvPr id="7" name="TextBox 6"/>
+          <p:cNvPr id="8" name="TextBox 7"/>
           <p:cNvSpPr txBox="1"/>
           <p:nvPr/>
         </p:nvSpPr>
@@ -9149,7 +9437,7 @@
       </p:sp>
       <p:sp>
         <p:nvSpPr>
-          <p:cNvPr id="8" name="TextBox 7"/>
+          <p:cNvPr id="9" name="TextBox 8"/>
           <p:cNvSpPr txBox="1"/>
           <p:nvPr/>
         </p:nvSpPr>
@@ -9184,7 +9472,7 @@
       </p:sp>
       <p:sp>
         <p:nvSpPr>
-          <p:cNvPr id="9" name="Rounded Rectangle 8"/>
+          <p:cNvPr id="10" name="Rounded Rectangle 9"/>
           <p:cNvSpPr/>
           <p:nvPr/>
         </p:nvSpPr>
@@ -9227,7 +9515,7 @@
       </p:sp>
       <p:sp>
         <p:nvSpPr>
-          <p:cNvPr id="10" name="TextBox 9"/>
+          <p:cNvPr id="11" name="TextBox 10"/>
           <p:cNvSpPr txBox="1"/>
           <p:nvPr/>
         </p:nvSpPr>
@@ -9262,7 +9550,7 @@
       </p:sp>
       <p:sp>
         <p:nvSpPr>
-          <p:cNvPr id="11" name="TextBox 10"/>
+          <p:cNvPr id="12" name="TextBox 11"/>
           <p:cNvSpPr txBox="1"/>
           <p:nvPr/>
         </p:nvSpPr>
@@ -9297,7 +9585,7 @@
       </p:sp>
       <p:sp>
         <p:nvSpPr>
-          <p:cNvPr id="12" name="Rounded Rectangle 11"/>
+          <p:cNvPr id="13" name="Rounded Rectangle 12"/>
           <p:cNvSpPr/>
           <p:nvPr/>
         </p:nvSpPr>
@@ -9340,7 +9628,7 @@
       </p:sp>
       <p:sp>
         <p:nvSpPr>
-          <p:cNvPr id="13" name="TextBox 12"/>
+          <p:cNvPr id="14" name="TextBox 13"/>
           <p:cNvSpPr txBox="1"/>
           <p:nvPr/>
         </p:nvSpPr>
@@ -9375,7 +9663,7 @@
       </p:sp>
       <p:sp>
         <p:nvSpPr>
-          <p:cNvPr id="14" name="TextBox 13"/>
+          <p:cNvPr id="15" name="TextBox 14"/>
           <p:cNvSpPr txBox="1"/>
           <p:nvPr/>
         </p:nvSpPr>
@@ -9410,7 +9698,7 @@
       </p:sp>
       <p:sp>
         <p:nvSpPr>
-          <p:cNvPr id="15" name="TextBox 14"/>
+          <p:cNvPr id="16" name="TextBox 15"/>
           <p:cNvSpPr txBox="1"/>
           <p:nvPr/>
         </p:nvSpPr>
@@ -9445,7 +9733,7 @@
       </p:sp>
       <p:sp>
         <p:nvSpPr>
-          <p:cNvPr id="16" name="TextBox 15"/>
+          <p:cNvPr id="17" name="TextBox 16"/>
           <p:cNvSpPr txBox="1"/>
           <p:nvPr/>
         </p:nvSpPr>
@@ -9480,7 +9768,7 @@
       </p:sp>
       <p:sp>
         <p:nvSpPr>
-          <p:cNvPr id="17" name="TextBox 16"/>
+          <p:cNvPr id="18" name="TextBox 17"/>
           <p:cNvSpPr txBox="1"/>
           <p:nvPr/>
         </p:nvSpPr>
@@ -9515,7 +9803,7 @@
       </p:sp>
       <p:sp>
         <p:nvSpPr>
-          <p:cNvPr id="18" name="TextBox 17"/>
+          <p:cNvPr id="19" name="TextBox 18"/>
           <p:cNvSpPr txBox="1"/>
           <p:nvPr/>
         </p:nvSpPr>

</xml_diff>

<commit_message>
Use IPMA Kyrgyz Republic brand logos in presentation
Add white wordmark and snow-leopard emblem variants from the
new IPMA KR identity assets across HTML and PPTX decks.

Co-authored-by: umekishev <umekishev@users.noreply.github.com>
</commit_message>
<xml_diff>
--- a/presentations/IPMA_Kyrgyzstan_CoD_Presentation.pptx
+++ b/presentations/IPMA_Kyrgyzstan_CoD_Presentation.pptx
@@ -3187,7 +3187,7 @@
       </p:sp>
       <p:pic>
         <p:nvPicPr>
-          <p:cNvPr id="4" name="Picture 3" descr="kgpmu-logo-full.png"/>
+          <p:cNvPr id="4" name="Picture 3" descr="ipma-kr-logo-white.png"/>
           <p:cNvPicPr>
             <a:picLocks noChangeAspect="1"/>
           </p:cNvPicPr>
@@ -3201,8 +3201,8 @@
         </p:blipFill>
         <p:spPr>
           <a:xfrm>
-            <a:off x="4175607" y="822960"/>
-            <a:ext cx="3840480" cy="1823761"/>
+            <a:off x="3535527" y="914400"/>
+            <a:ext cx="5120640" cy="1496630"/>
           </a:xfrm>
           <a:prstGeom prst="rect">
             <a:avLst/>
@@ -3217,7 +3217,7 @@
         </p:nvSpPr>
         <p:spPr>
           <a:xfrm>
-            <a:off x="731520" y="2606040"/>
+            <a:off x="731520" y="2788920"/>
             <a:ext cx="10698480" cy="320040"/>
           </a:xfrm>
           <a:prstGeom prst="rect">
@@ -3252,7 +3252,7 @@
         </p:nvSpPr>
         <p:spPr>
           <a:xfrm>
-            <a:off x="731520" y="3017520"/>
+            <a:off x="731520" y="3200400"/>
             <a:ext cx="10698480" cy="914400"/>
           </a:xfrm>
           <a:prstGeom prst="rect">
@@ -3268,7 +3268,7 @@
           <a:p>
             <a:pPr algn="ctr"/>
             <a:r>
-              <a:rPr sz="3200" b="1">
+              <a:rPr sz="3000" b="1">
                 <a:solidFill>
                   <a:srgbClr val="FFFFFF"/>
                 </a:solidFill>
@@ -3288,7 +3288,7 @@
         </p:nvSpPr>
         <p:spPr>
           <a:xfrm>
-            <a:off x="731520" y="4114800"/>
+            <a:off x="731520" y="4251960"/>
             <a:ext cx="10698480" cy="365760"/>
           </a:xfrm>
           <a:prstGeom prst="rect">
@@ -3310,7 +3310,7 @@
                 </a:solidFill>
                 <a:latin typeface="Calibri"/>
               </a:rPr>
-              <a:t>ОО «KgPMU» · Kyrgyz Project Management Union · ipma.kg</a:t>
+              <a:t>ОО «KgPMU» · IPMA Kyrgyz Republic · ipma.kg</a:t>
             </a:r>
           </a:p>
         </p:txBody>
@@ -3323,7 +3323,7 @@
         </p:nvSpPr>
         <p:spPr>
           <a:xfrm>
-            <a:off x="1645920" y="4709160"/>
+            <a:off x="1645920" y="4800600"/>
             <a:ext cx="8869680" cy="594360"/>
           </a:xfrm>
           <a:prstGeom prst="roundRect">
@@ -3366,7 +3366,7 @@
         </p:nvSpPr>
         <p:spPr>
           <a:xfrm>
-            <a:off x="1828800" y="4828032"/>
+            <a:off x="1828800" y="4919472"/>
             <a:ext cx="8503920" cy="365760"/>
           </a:xfrm>
           <a:prstGeom prst="rect">
@@ -3401,7 +3401,7 @@
         </p:nvSpPr>
         <p:spPr>
           <a:xfrm>
-            <a:off x="731520" y="5532120"/>
+            <a:off x="731520" y="5623560"/>
             <a:ext cx="10698480" cy="320040"/>
           </a:xfrm>
           <a:prstGeom prst="rect">
@@ -3534,7 +3534,7 @@
       </p:sp>
       <p:pic>
         <p:nvPicPr>
-          <p:cNvPr id="4" name="Picture 3" descr="kgpmu-emblem.png"/>
+          <p:cNvPr id="4" name="Picture 3" descr="ipma-kr-emblem.png"/>
           <p:cNvPicPr>
             <a:picLocks noChangeAspect="1"/>
           </p:cNvPicPr>
@@ -3548,8 +3548,8 @@
         </p:blipFill>
         <p:spPr>
           <a:xfrm>
-            <a:off x="11201400" y="228600"/>
-            <a:ext cx="708894" cy="640080"/>
+            <a:off x="11292840" y="201168"/>
+            <a:ext cx="661788" cy="658368"/>
           </a:xfrm>
           <a:prstGeom prst="rect">
             <a:avLst/>
@@ -4108,7 +4108,7 @@
                 </a:solidFill>
                 <a:latin typeface="Calibri"/>
               </a:rPr>
-              <a:t>KgPMU · ipma.kg · Ассоциация-заявитель IPMA</a:t>
+              <a:t>IPMA Kyrgyz Republic · ipma.kg · Ассоциация-заявитель</a:t>
             </a:r>
           </a:p>
         </p:txBody>
@@ -4254,7 +4254,7 @@
       </p:sp>
       <p:pic>
         <p:nvPicPr>
-          <p:cNvPr id="4" name="Picture 3" descr="kgpmu-emblem.png"/>
+          <p:cNvPr id="4" name="Picture 3" descr="ipma-kr-emblem.png"/>
           <p:cNvPicPr>
             <a:picLocks noChangeAspect="1"/>
           </p:cNvPicPr>
@@ -4268,8 +4268,8 @@
         </p:blipFill>
         <p:spPr>
           <a:xfrm>
-            <a:off x="11201400" y="228600"/>
-            <a:ext cx="708894" cy="640080"/>
+            <a:off x="11292840" y="201168"/>
+            <a:ext cx="661788" cy="658368"/>
           </a:xfrm>
           <a:prstGeom prst="rect">
             <a:avLst/>
@@ -4479,7 +4479,7 @@
                 </a:solidFill>
                 <a:latin typeface="Calibri"/>
               </a:rPr>
-              <a:t>KgPMU · ipma.kg · Ассоциация-заявитель IPMA</a:t>
+              <a:t>IPMA Kyrgyz Republic · ipma.kg · Ассоциация-заявитель</a:t>
             </a:r>
           </a:p>
         </p:txBody>
@@ -4625,7 +4625,7 @@
       </p:sp>
       <p:pic>
         <p:nvPicPr>
-          <p:cNvPr id="4" name="Picture 3" descr="kgpmu-logo-full.png"/>
+          <p:cNvPr id="4" name="Picture 3" descr="ipma-kr-logo-white.png"/>
           <p:cNvPicPr>
             <a:picLocks noChangeAspect="1"/>
           </p:cNvPicPr>
@@ -4639,8 +4639,8 @@
         </p:blipFill>
         <p:spPr>
           <a:xfrm>
-            <a:off x="4541367" y="640080"/>
-            <a:ext cx="3108960" cy="1476378"/>
+            <a:off x="3992727" y="685800"/>
+            <a:ext cx="4206240" cy="1229375"/>
           </a:xfrm>
           <a:prstGeom prst="rect">
             <a:avLst/>
@@ -4655,7 +4655,7 @@
         </p:nvSpPr>
         <p:spPr>
           <a:xfrm>
-            <a:off x="731520" y="2286000"/>
+            <a:off x="731520" y="2331720"/>
             <a:ext cx="10698480" cy="320040"/>
           </a:xfrm>
           <a:prstGeom prst="rect">
@@ -4690,8 +4690,8 @@
         </p:nvSpPr>
         <p:spPr>
           <a:xfrm>
-            <a:off x="731520" y="2697480"/>
-            <a:ext cx="10698480" cy="548640"/>
+            <a:off x="731520" y="2743200"/>
+            <a:ext cx="10698480" cy="502920"/>
           </a:xfrm>
           <a:prstGeom prst="rect">
             <a:avLst/>
@@ -4747,7 +4747,7 @@
                 </a:solidFill>
                 <a:latin typeface="Calibri"/>
               </a:rPr>
-              <a:t>KgPMU уже является Ассоциацией-заявителем IPMA и готова двигаться к полноправному членству и сертификации в Центральной Азии.</a:t>
+              <a:t>KgPMU / IPMA Kyrgyz Republic уже является Ассоциацией-заявителем IPMA и готова двигаться к полноправному членству и сертификации в Центральной Азии.</a:t>
             </a:r>
           </a:p>
         </p:txBody>
@@ -4862,7 +4862,7 @@
                 </a:solidFill>
                 <a:latin typeface="Calibri"/>
               </a:rPr>
-              <a:t>KgPMU · ipma.kg · Ассоциация-заявитель IPMA</a:t>
+              <a:t>IPMA Kyrgyz Republic · ipma.kg · Ассоциация-заявитель</a:t>
             </a:r>
           </a:p>
         </p:txBody>
@@ -5008,7 +5008,7 @@
       </p:sp>
       <p:pic>
         <p:nvPicPr>
-          <p:cNvPr id="4" name="Picture 3" descr="kgpmu-emblem.png"/>
+          <p:cNvPr id="4" name="Picture 3" descr="ipma-kr-emblem.png"/>
           <p:cNvPicPr>
             <a:picLocks noChangeAspect="1"/>
           </p:cNvPicPr>
@@ -5022,8 +5022,8 @@
         </p:blipFill>
         <p:spPr>
           <a:xfrm>
-            <a:off x="11201400" y="228600"/>
-            <a:ext cx="708894" cy="640080"/>
+            <a:off x="11292840" y="201168"/>
+            <a:ext cx="661788" cy="658368"/>
           </a:xfrm>
           <a:prstGeom prst="rect">
             <a:avLst/>
@@ -5314,7 +5314,7 @@
                 </a:solidFill>
                 <a:latin typeface="Calibri"/>
               </a:rPr>
-              <a:t>KgPMU · ipma.kg · Ассоциация-заявитель IPMA</a:t>
+              <a:t>IPMA Kyrgyz Republic · ipma.kg · Ассоциация-заявитель</a:t>
             </a:r>
           </a:p>
         </p:txBody>
@@ -5460,7 +5460,7 @@
       </p:sp>
       <p:pic>
         <p:nvPicPr>
-          <p:cNvPr id="4" name="Picture 3" descr="kgpmu-emblem.png"/>
+          <p:cNvPr id="4" name="Picture 3" descr="ipma-kr-emblem.png"/>
           <p:cNvPicPr>
             <a:picLocks noChangeAspect="1"/>
           </p:cNvPicPr>
@@ -5474,8 +5474,8 @@
         </p:blipFill>
         <p:spPr>
           <a:xfrm>
-            <a:off x="11201400" y="228600"/>
-            <a:ext cx="708894" cy="640080"/>
+            <a:off x="11292840" y="201168"/>
+            <a:ext cx="661788" cy="658368"/>
           </a:xfrm>
           <a:prstGeom prst="rect">
             <a:avLst/>
@@ -6069,7 +6069,7 @@
                 </a:solidFill>
                 <a:latin typeface="Calibri"/>
               </a:rPr>
-              <a:t>KgPMU · ipma.kg · Ассоциация-заявитель IPMA</a:t>
+              <a:t>IPMA Kyrgyz Republic · ipma.kg · Ассоциация-заявитель</a:t>
             </a:r>
           </a:p>
         </p:txBody>
@@ -6215,7 +6215,7 @@
       </p:sp>
       <p:pic>
         <p:nvPicPr>
-          <p:cNvPr id="4" name="Picture 3" descr="kgpmu-emblem.png"/>
+          <p:cNvPr id="4" name="Picture 3" descr="ipma-kr-emblem.png"/>
           <p:cNvPicPr>
             <a:picLocks noChangeAspect="1"/>
           </p:cNvPicPr>
@@ -6229,8 +6229,8 @@
         </p:blipFill>
         <p:spPr>
           <a:xfrm>
-            <a:off x="11201400" y="228600"/>
-            <a:ext cx="708894" cy="640080"/>
+            <a:off x="11292840" y="201168"/>
+            <a:ext cx="661788" cy="658368"/>
           </a:xfrm>
           <a:prstGeom prst="rect">
             <a:avLst/>
@@ -6860,7 +6860,7 @@
                 </a:solidFill>
                 <a:latin typeface="Calibri"/>
               </a:rPr>
-              <a:t>KgPMU · ipma.kg · Ассоциация-заявитель IPMA</a:t>
+              <a:t>IPMA Kyrgyz Republic · ipma.kg · Ассоциация-заявитель</a:t>
             </a:r>
           </a:p>
         </p:txBody>
@@ -7006,7 +7006,7 @@
       </p:sp>
       <p:pic>
         <p:nvPicPr>
-          <p:cNvPr id="4" name="Picture 3" descr="kgpmu-emblem.png"/>
+          <p:cNvPr id="4" name="Picture 3" descr="ipma-kr-emblem.png"/>
           <p:cNvPicPr>
             <a:picLocks noChangeAspect="1"/>
           </p:cNvPicPr>
@@ -7020,8 +7020,8 @@
         </p:blipFill>
         <p:spPr>
           <a:xfrm>
-            <a:off x="11201400" y="228600"/>
-            <a:ext cx="708894" cy="640080"/>
+            <a:off x="11292840" y="201168"/>
+            <a:ext cx="661788" cy="658368"/>
           </a:xfrm>
           <a:prstGeom prst="rect">
             <a:avLst/>
@@ -7241,7 +7241,7 @@
                 </a:solidFill>
                 <a:latin typeface="Calibri"/>
               </a:rPr>
-              <a:t>KgPMU · ipma.kg · Ассоциация-заявитель IPMA</a:t>
+              <a:t>IPMA Kyrgyz Republic · ipma.kg · Ассоциация-заявитель</a:t>
             </a:r>
           </a:p>
         </p:txBody>
@@ -7387,7 +7387,7 @@
       </p:sp>
       <p:pic>
         <p:nvPicPr>
-          <p:cNvPr id="4" name="Picture 3" descr="kgpmu-emblem.png"/>
+          <p:cNvPr id="4" name="Picture 3" descr="ipma-kr-emblem.png"/>
           <p:cNvPicPr>
             <a:picLocks noChangeAspect="1"/>
           </p:cNvPicPr>
@@ -7401,8 +7401,8 @@
         </p:blipFill>
         <p:spPr>
           <a:xfrm>
-            <a:off x="11201400" y="228600"/>
-            <a:ext cx="708894" cy="640080"/>
+            <a:off x="11292840" y="201168"/>
+            <a:ext cx="661788" cy="658368"/>
           </a:xfrm>
           <a:prstGeom prst="rect">
             <a:avLst/>
@@ -7961,7 +7961,7 @@
                 </a:solidFill>
                 <a:latin typeface="Calibri"/>
               </a:rPr>
-              <a:t>KgPMU · ipma.kg · Ассоциация-заявитель IPMA</a:t>
+              <a:t>IPMA Kyrgyz Republic · ipma.kg · Ассоциация-заявитель</a:t>
             </a:r>
           </a:p>
         </p:txBody>
@@ -8107,7 +8107,7 @@
       </p:sp>
       <p:pic>
         <p:nvPicPr>
-          <p:cNvPr id="4" name="Picture 3" descr="kgpmu-emblem.png"/>
+          <p:cNvPr id="4" name="Picture 3" descr="ipma-kr-emblem.png"/>
           <p:cNvPicPr>
             <a:picLocks noChangeAspect="1"/>
           </p:cNvPicPr>
@@ -8121,8 +8121,8 @@
         </p:blipFill>
         <p:spPr>
           <a:xfrm>
-            <a:off x="11201400" y="228600"/>
-            <a:ext cx="708894" cy="640080"/>
+            <a:off x="11292840" y="201168"/>
+            <a:ext cx="661788" cy="658368"/>
           </a:xfrm>
           <a:prstGeom prst="rect">
             <a:avLst/>
@@ -8364,7 +8364,7 @@
                 </a:solidFill>
                 <a:latin typeface="Calibri"/>
               </a:rPr>
-              <a:t>KgPMU · ipma.kg · Ассоциация-заявитель IPMA</a:t>
+              <a:t>IPMA Kyrgyz Republic · ipma.kg · Ассоциация-заявитель</a:t>
             </a:r>
           </a:p>
         </p:txBody>
@@ -8510,7 +8510,7 @@
       </p:sp>
       <p:pic>
         <p:nvPicPr>
-          <p:cNvPr id="4" name="Picture 3" descr="kgpmu-emblem.png"/>
+          <p:cNvPr id="4" name="Picture 3" descr="ipma-kr-emblem.png"/>
           <p:cNvPicPr>
             <a:picLocks noChangeAspect="1"/>
           </p:cNvPicPr>
@@ -8524,8 +8524,8 @@
         </p:blipFill>
         <p:spPr>
           <a:xfrm>
-            <a:off x="11201400" y="228600"/>
-            <a:ext cx="708894" cy="640080"/>
+            <a:off x="11292840" y="201168"/>
+            <a:ext cx="661788" cy="658368"/>
           </a:xfrm>
           <a:prstGeom prst="rect">
             <a:avLst/>
@@ -9119,7 +9119,7 @@
                 </a:solidFill>
                 <a:latin typeface="Calibri"/>
               </a:rPr>
-              <a:t>KgPMU · ipma.kg · Ассоциация-заявитель IPMA</a:t>
+              <a:t>IPMA Kyrgyz Republic · ipma.kg · Ассоциация-заявитель</a:t>
             </a:r>
           </a:p>
         </p:txBody>
@@ -9265,7 +9265,7 @@
       </p:sp>
       <p:pic>
         <p:nvPicPr>
-          <p:cNvPr id="4" name="Picture 3" descr="kgpmu-emblem.png"/>
+          <p:cNvPr id="4" name="Picture 3" descr="ipma-kr-emblem.png"/>
           <p:cNvPicPr>
             <a:picLocks noChangeAspect="1"/>
           </p:cNvPicPr>
@@ -9279,8 +9279,8 @@
         </p:blipFill>
         <p:spPr>
           <a:xfrm>
-            <a:off x="11201400" y="228600"/>
-            <a:ext cx="708894" cy="640080"/>
+            <a:off x="11292840" y="201168"/>
+            <a:ext cx="661788" cy="658368"/>
           </a:xfrm>
           <a:prstGeom prst="rect">
             <a:avLst/>
@@ -9796,7 +9796,7 @@
                 </a:solidFill>
                 <a:latin typeface="Calibri"/>
               </a:rPr>
-              <a:t>KgPMU · ipma.kg · Ассоциация-заявитель IPMA</a:t>
+              <a:t>IPMA Kyrgyz Republic · ipma.kg · Ассоциация-заявитель</a:t>
             </a:r>
           </a:p>
         </p:txBody>

</xml_diff>